<commit_message>
Workshop deck: less on each slide, bigger type
Every card is cut to one idea, the subtitles to one line, and the body
type goes up two points. What came off the slides is in the speaker
notes, where it belongs in a room with laptops open.

Small-caps labels now use a text-weight violet rather than the brand
fill violet, which washes out on a projector at that size.

Co-Authored-By: Claude Opus 5 <noreply@anthropic.com>
Claude-Session: https://claude.ai/code/session_01GU6RhWctnBpcS6dNZ87S1b
</commit_message>
<xml_diff>
--- a/docs/Personal AI Assistant — Installation.pptx
+++ b/docs/Personal AI Assistant — Installation.pptx
@@ -2546,7 +2546,7 @@
                 <a:ea typeface="Public Sans" pitchFamily="34" charset="-122"/>
                 <a:cs typeface="Public Sans" pitchFamily="34" charset="-120"/>
               </a:rPr>
-              <a:t>A hands-on hour. Open your laptop: you are building your own AI Second Brain with me, not watching me build one.</a:t>
+              <a:t>A hands-on hour. Laptops open — you are building this with me, not watching.</a:t>
             </a:r>
             <a:endParaRPr lang="en-US" sz="1700" dirty="0"/>
           </a:p>
@@ -2579,7 +2579,7 @@
             <a:r>
               <a:rPr lang="en-US" sz="950" spc="100" kern="0" dirty="0">
                 <a:solidFill>
-                  <a:srgbClr val="7E8492"/>
+                  <a:srgbClr val="8A90A0"/>
                 </a:solidFill>
                 <a:latin typeface="Courier New" pitchFamily="34" charset="0"/>
                 <a:ea typeface="Courier New" pitchFamily="34" charset="-122"/>
@@ -2650,7 +2650,7 @@
             <a:r>
               <a:rPr lang="en-US" sz="1100" spc="200" kern="0" dirty="0">
                 <a:solidFill>
-                  <a:srgbClr val="7367F0"/>
+                  <a:srgbClr val="6055D8"/>
                 </a:solidFill>
                 <a:latin typeface="Courier New" pitchFamily="34" charset="0"/>
                 <a:ea typeface="Courier New" pitchFamily="34" charset="-122"/>
@@ -2760,12 +2760,12 @@
         </p:nvSpPr>
         <p:spPr>
           <a:xfrm>
-            <a:off x="9262872" y="1719072"/>
-            <a:ext cx="2258568" cy="1599819"/>
+            <a:off x="9262872" y="3540252"/>
+            <a:ext cx="2258568" cy="2156460"/>
           </a:xfrm>
           <a:prstGeom prst="roundRect">
             <a:avLst>
-              <a:gd name="adj" fmla="val 3429"/>
+              <a:gd name="adj" fmla="val 2544"/>
             </a:avLst>
           </a:prstGeom>
           <a:solidFill>
@@ -2787,8 +2787,8 @@
         </p:nvSpPr>
         <p:spPr>
           <a:xfrm>
-            <a:off x="9537192" y="1993392"/>
-            <a:ext cx="1709928" cy="228600"/>
+            <a:off x="9537192" y="3814572"/>
+            <a:ext cx="1709928" cy="487680"/>
           </a:xfrm>
           <a:prstGeom prst="rect">
             <a:avLst/>
@@ -2802,12 +2802,12 @@
           <a:p>
             <a:pPr indent="0" marL="0">
               <a:lnSpc>
-                <a:spcPts val="1800"/>
+                <a:spcPts val="1920"/>
               </a:lnSpc>
               <a:buNone/>
             </a:pPr>
             <a:r>
-              <a:rPr lang="en-US" sz="1500" b="1" dirty="0">
+              <a:rPr lang="en-US" sz="1600" b="1" dirty="0">
                 <a:solidFill>
                   <a:srgbClr val="15171F"/>
                 </a:solidFill>
@@ -2815,9 +2815,9 @@
                 <a:ea typeface="Public Sans" pitchFamily="34" charset="-122"/>
                 <a:cs typeface="Public Sans" pitchFamily="34" charset="-120"/>
               </a:rPr>
-              <a:t>Four tabs</a:t>
-            </a:r>
-            <a:endParaRPr lang="en-US" sz="1500" dirty="0"/>
+              <a:t>Honest on day one</a:t>
+            </a:r>
+            <a:endParaRPr lang="en-US" sz="1600" dirty="0"/>
           </a:p>
         </p:txBody>
       </p:sp>
@@ -2829,8 +2829,8 @@
         </p:nvSpPr>
         <p:spPr>
           <a:xfrm>
-            <a:off x="9537192" y="2350008"/>
-            <a:ext cx="1709928" cy="712851"/>
+            <a:off x="9537192" y="4430268"/>
+            <a:ext cx="1709928" cy="1010412"/>
           </a:xfrm>
           <a:prstGeom prst="rect">
             <a:avLst/>
@@ -2844,12 +2844,12 @@
           <a:p>
             <a:pPr indent="0" marL="0">
               <a:lnSpc>
-                <a:spcPts val="1775"/>
+                <a:spcPts val="1917"/>
               </a:lnSpc>
               <a:buNone/>
             </a:pPr>
             <a:r>
-              <a:rPr lang="en-US" sz="1250" dirty="0">
+              <a:rPr lang="en-US" sz="1350" dirty="0">
                 <a:solidFill>
                   <a:srgbClr val="5B6270"/>
                 </a:solidFill>
@@ -2857,9 +2857,9 @@
                 <a:ea typeface="Public Sans" pitchFamily="34" charset="-122"/>
                 <a:cs typeface="Public Sans" pitchFamily="34" charset="-120"/>
               </a:rPr>
-              <a:t>Dashboard, agent organization, workflows, projects.</a:t>
-            </a:r>
-            <a:endParaRPr lang="en-US" sz="1250" dirty="0"/>
+              <a:t>Two departments, three executives — and it says so. Your job is next.</a:t>
+            </a:r>
+            <a:endParaRPr lang="en-US" sz="1350" dirty="0"/>
           </a:p>
         </p:txBody>
       </p:sp>
@@ -2871,12 +2871,12 @@
         </p:nvSpPr>
         <p:spPr>
           <a:xfrm>
-            <a:off x="9262872" y="3871468"/>
-            <a:ext cx="2258568" cy="1825244"/>
+            <a:off x="9262872" y="1719072"/>
+            <a:ext cx="2258568" cy="1669161"/>
           </a:xfrm>
           <a:prstGeom prst="roundRect">
             <a:avLst>
-              <a:gd name="adj" fmla="val 3006"/>
+              <a:gd name="adj" fmla="val 3287"/>
             </a:avLst>
           </a:prstGeom>
           <a:solidFill>
@@ -2898,8 +2898,8 @@
         </p:nvSpPr>
         <p:spPr>
           <a:xfrm>
-            <a:off x="9537192" y="4145788"/>
-            <a:ext cx="1709928" cy="228600"/>
+            <a:off x="9537192" y="1993392"/>
+            <a:ext cx="1709928" cy="243840"/>
           </a:xfrm>
           <a:prstGeom prst="rect">
             <a:avLst/>
@@ -2913,12 +2913,12 @@
           <a:p>
             <a:pPr indent="0" marL="0">
               <a:lnSpc>
-                <a:spcPts val="1800"/>
+                <a:spcPts val="1920"/>
               </a:lnSpc>
               <a:buNone/>
             </a:pPr>
             <a:r>
-              <a:rPr lang="en-US" sz="1500" b="1" dirty="0">
+              <a:rPr lang="en-US" sz="1600" b="1" dirty="0">
                 <a:solidFill>
                   <a:srgbClr val="15171F"/>
                 </a:solidFill>
@@ -2926,9 +2926,9 @@
                 <a:ea typeface="Public Sans" pitchFamily="34" charset="-122"/>
                 <a:cs typeface="Public Sans" pitchFamily="34" charset="-120"/>
               </a:rPr>
-              <a:t>Honest on day one</a:t>
-            </a:r>
-            <a:endParaRPr lang="en-US" sz="1500" dirty="0"/>
+              <a:t>Four tabs</a:t>
+            </a:r>
+            <a:endParaRPr lang="en-US" sz="1600" dirty="0"/>
           </a:p>
         </p:txBody>
       </p:sp>
@@ -2940,8 +2940,8 @@
         </p:nvSpPr>
         <p:spPr>
           <a:xfrm>
-            <a:off x="9537192" y="4502404"/>
-            <a:ext cx="1709928" cy="938276"/>
+            <a:off x="9537192" y="2365248"/>
+            <a:ext cx="1709928" cy="766953"/>
           </a:xfrm>
           <a:prstGeom prst="rect">
             <a:avLst/>
@@ -2955,12 +2955,12 @@
           <a:p>
             <a:pPr indent="0" marL="0">
               <a:lnSpc>
-                <a:spcPts val="1775"/>
+                <a:spcPts val="1917"/>
               </a:lnSpc>
               <a:buNone/>
             </a:pPr>
             <a:r>
-              <a:rPr lang="en-US" sz="1250" dirty="0">
+              <a:rPr lang="en-US" sz="1350" dirty="0">
                 <a:solidFill>
                   <a:srgbClr val="5B6270"/>
                 </a:solidFill>
@@ -2968,9 +2968,9 @@
                 <a:ea typeface="Public Sans" pitchFamily="34" charset="-122"/>
                 <a:cs typeface="Public Sans" pitchFamily="34" charset="-120"/>
               </a:rPr>
-              <a:t>Two departments, three executives, and it says so. Not your job yet — that is next.</a:t>
-            </a:r>
-            <a:endParaRPr lang="en-US" sz="1250" dirty="0"/>
+              <a:t>Dashboard, agent organization, workflows, projects.</a:t>
+            </a:r>
+            <a:endParaRPr lang="en-US" sz="1350" dirty="0"/>
           </a:p>
         </p:txBody>
       </p:sp>
@@ -3001,7 +3001,7 @@
             <a:r>
               <a:rPr lang="en-US" sz="950" spc="100" kern="0" dirty="0">
                 <a:solidFill>
-                  <a:srgbClr val="9198A6"/>
+                  <a:srgbClr val="6B6D72"/>
                 </a:solidFill>
                 <a:latin typeface="Courier New" pitchFamily="34" charset="0"/>
                 <a:ea typeface="Courier New" pitchFamily="34" charset="-122"/>
@@ -3072,7 +3072,7 @@
             <a:r>
               <a:rPr lang="en-US" sz="1100" spc="200" kern="0" dirty="0">
                 <a:solidFill>
-                  <a:srgbClr val="7367F0"/>
+                  <a:srgbClr val="6055D8"/>
                 </a:solidFill>
                 <a:latin typeface="Courier New" pitchFamily="34" charset="0"/>
                 <a:ea typeface="Courier New" pitchFamily="34" charset="-122"/>
@@ -3266,7 +3266,7 @@
             <a:r>
               <a:rPr lang="en-US" sz="1050" spc="160" kern="0" dirty="0">
                 <a:solidFill>
-                  <a:srgbClr val="7367F0"/>
+                  <a:srgbClr val="6055D8"/>
                 </a:solidFill>
                 <a:latin typeface="Courier New" pitchFamily="34" charset="0"/>
                 <a:ea typeface="Courier New" pitchFamily="34" charset="-122"/>
@@ -3372,11 +3372,11 @@
         <p:spPr>
           <a:xfrm>
             <a:off x="777240" y="3917188"/>
-            <a:ext cx="5029200" cy="1718310"/>
+            <a:ext cx="5029200" cy="1769618"/>
           </a:xfrm>
           <a:prstGeom prst="roundRect">
             <a:avLst>
-              <a:gd name="adj" fmla="val 3193"/>
+              <a:gd name="adj" fmla="val 3100"/>
             </a:avLst>
           </a:prstGeom>
           <a:solidFill>
@@ -3417,7 +3417,7 @@
             <a:r>
               <a:rPr lang="en-US" sz="950" spc="140" kern="0" dirty="0">
                 <a:solidFill>
-                  <a:srgbClr val="7367F0"/>
+                  <a:srgbClr val="6055D8"/>
                 </a:solidFill>
                 <a:latin typeface="Courier New" pitchFamily="34" charset="0"/>
                 <a:ea typeface="Courier New" pitchFamily="34" charset="-122"/>
@@ -3438,7 +3438,7 @@
         <p:spPr>
           <a:xfrm>
             <a:off x="1051560" y="4484116"/>
-            <a:ext cx="4480560" cy="243840"/>
+            <a:ext cx="4480560" cy="259080"/>
           </a:xfrm>
           <a:prstGeom prst="rect">
             <a:avLst/>
@@ -3452,12 +3452,12 @@
           <a:p>
             <a:pPr indent="0" marL="0">
               <a:lnSpc>
-                <a:spcPts val="1920"/>
+                <a:spcPts val="2040"/>
               </a:lnSpc>
               <a:buNone/>
             </a:pPr>
             <a:r>
-              <a:rPr lang="en-US" sz="1600" b="1" dirty="0">
+              <a:rPr lang="en-US" sz="1700" b="1" dirty="0">
                 <a:solidFill>
                   <a:srgbClr val="15171F"/>
                 </a:solidFill>
@@ -3467,7 +3467,7 @@
               </a:rPr>
               <a:t>A part of your job you answer for</a:t>
             </a:r>
-            <a:endParaRPr lang="en-US" sz="1600" dirty="0"/>
+            <a:endParaRPr lang="en-US" sz="1700" dirty="0"/>
           </a:p>
         </p:txBody>
       </p:sp>
@@ -3479,8 +3479,8 @@
         </p:nvSpPr>
         <p:spPr>
           <a:xfrm>
-            <a:off x="1051560" y="4855972"/>
-            <a:ext cx="4480560" cy="523494"/>
+            <a:off x="1051560" y="4871212"/>
+            <a:ext cx="4480560" cy="559562"/>
           </a:xfrm>
           <a:prstGeom prst="rect">
             <a:avLst/>
@@ -3494,12 +3494,12 @@
           <a:p>
             <a:pPr indent="0" marL="0">
               <a:lnSpc>
-                <a:spcPts val="1917"/>
+                <a:spcPts val="2059"/>
               </a:lnSpc>
               <a:buNone/>
             </a:pPr>
             <a:r>
-              <a:rPr lang="en-US" sz="1350" dirty="0">
+              <a:rPr lang="en-US" sz="1450" dirty="0">
                 <a:solidFill>
                   <a:srgbClr val="5B6270"/>
                 </a:solidFill>
@@ -3507,9 +3507,9 @@
                 <a:ea typeface="Public Sans" pitchFamily="34" charset="-122"/>
                 <a:cs typeface="Public Sans" pitchFamily="34" charset="-120"/>
               </a:rPr>
-              <a:t>The accounts. The reporting. The posting. The thing you inherited that nobody else touches.</a:t>
-            </a:r>
-            <a:endParaRPr lang="en-US" sz="1350" dirty="0"/>
+              <a:t>The accounts. The reporting. The posting. The thing you inherited.</a:t>
+            </a:r>
+            <a:endParaRPr lang="en-US" sz="1450" dirty="0"/>
           </a:p>
         </p:txBody>
       </p:sp>
@@ -3522,11 +3522,11 @@
         <p:spPr>
           <a:xfrm>
             <a:off x="6172200" y="3917188"/>
-            <a:ext cx="5029200" cy="1718310"/>
+            <a:ext cx="5029200" cy="1769618"/>
           </a:xfrm>
           <a:prstGeom prst="roundRect">
             <a:avLst>
-              <a:gd name="adj" fmla="val 3193"/>
+              <a:gd name="adj" fmla="val 3100"/>
             </a:avLst>
           </a:prstGeom>
           <a:solidFill>
@@ -3567,7 +3567,7 @@
             <a:r>
               <a:rPr lang="en-US" sz="950" spc="140" kern="0" dirty="0">
                 <a:solidFill>
-                  <a:srgbClr val="7367F0"/>
+                  <a:srgbClr val="6055D8"/>
                 </a:solidFill>
                 <a:latin typeface="Courier New" pitchFamily="34" charset="0"/>
                 <a:ea typeface="Courier New" pitchFamily="34" charset="-122"/>
@@ -3588,7 +3588,7 @@
         <p:spPr>
           <a:xfrm>
             <a:off x="6446520" y="4484116"/>
-            <a:ext cx="4480560" cy="243840"/>
+            <a:ext cx="4480560" cy="259080"/>
           </a:xfrm>
           <a:prstGeom prst="rect">
             <a:avLst/>
@@ -3602,12 +3602,12 @@
           <a:p>
             <a:pPr indent="0" marL="0">
               <a:lnSpc>
-                <a:spcPts val="1920"/>
+                <a:spcPts val="2040"/>
               </a:lnSpc>
               <a:buNone/>
             </a:pPr>
             <a:r>
-              <a:rPr lang="en-US" sz="1600" b="1" dirty="0">
+              <a:rPr lang="en-US" sz="1700" b="1" dirty="0">
                 <a:solidFill>
                   <a:srgbClr val="15171F"/>
                 </a:solidFill>
@@ -3617,7 +3617,7 @@
               </a:rPr>
               <a:t>Not twelve</a:t>
             </a:r>
-            <a:endParaRPr lang="en-US" sz="1600" dirty="0"/>
+            <a:endParaRPr lang="en-US" sz="1700" dirty="0"/>
           </a:p>
         </p:txBody>
       </p:sp>
@@ -3629,8 +3629,8 @@
         </p:nvSpPr>
         <p:spPr>
           <a:xfrm>
-            <a:off x="6446520" y="4855972"/>
-            <a:ext cx="4480560" cy="523494"/>
+            <a:off x="6446520" y="4871212"/>
+            <a:ext cx="4480560" cy="559562"/>
           </a:xfrm>
           <a:prstGeom prst="rect">
             <a:avLst/>
@@ -3644,12 +3644,12 @@
           <a:p>
             <a:pPr indent="0" marL="0">
               <a:lnSpc>
-                <a:spcPts val="1917"/>
+                <a:spcPts val="2059"/>
               </a:lnSpc>
               <a:buNone/>
             </a:pPr>
             <a:r>
-              <a:rPr lang="en-US" sz="1350" dirty="0">
+              <a:rPr lang="en-US" sz="1450" dirty="0">
                 <a:solidFill>
                   <a:srgbClr val="5B6270"/>
                 </a:solidFill>
@@ -3657,9 +3657,9 @@
                 <a:ea typeface="Public Sans" pitchFamily="34" charset="-122"/>
                 <a:cs typeface="Public Sans" pitchFamily="34" charset="-120"/>
               </a:rPr>
-              <a:t>If two would never disagree about anything, they are one. You can add another next week in a sentence.</a:t>
-            </a:r>
-            <a:endParaRPr lang="en-US" sz="1350" dirty="0"/>
+              <a:t>If two would never disagree, they are one. Add another next week in a sentence.</a:t>
+            </a:r>
+            <a:endParaRPr lang="en-US" sz="1450" dirty="0"/>
           </a:p>
         </p:txBody>
       </p:sp>
@@ -3690,7 +3690,7 @@
             <a:r>
               <a:rPr lang="en-US" sz="950" spc="100" kern="0" dirty="0">
                 <a:solidFill>
-                  <a:srgbClr val="9198A6"/>
+                  <a:srgbClr val="6B6D72"/>
                 </a:solidFill>
                 <a:latin typeface="Courier New" pitchFamily="34" charset="0"/>
                 <a:ea typeface="Courier New" pitchFamily="34" charset="-122"/>
@@ -3761,7 +3761,7 @@
             <a:r>
               <a:rPr lang="en-US" sz="1100" spc="200" kern="0" dirty="0">
                 <a:solidFill>
-                  <a:srgbClr val="7367F0"/>
+                  <a:srgbClr val="6055D8"/>
                 </a:solidFill>
                 <a:latin typeface="Courier New" pitchFamily="34" charset="0"/>
                 <a:ea typeface="Courier New" pitchFamily="34" charset="-122"/>
@@ -3862,12 +3862,12 @@
           <a:p>
             <a:pPr indent="0" marL="0">
               <a:lnSpc>
-                <a:spcPts val="2100"/>
+                <a:spcPts val="2300"/>
               </a:lnSpc>
               <a:buNone/>
             </a:pPr>
             <a:r>
-              <a:rPr lang="en-US" sz="1500" dirty="0">
+              <a:rPr lang="en-US" sz="1600" dirty="0">
                 <a:solidFill>
                   <a:srgbClr val="5B6270"/>
                 </a:solidFill>
@@ -3875,9 +3875,9 @@
                 <a:ea typeface="Public Sans" pitchFamily="34" charset="-122"/>
                 <a:cs typeface="Public Sans" pitchFamily="34" charset="-120"/>
               </a:rPr>
-              <a:t>Each department note compiles into an agent that answers for that department and nothing else. That is the unit everything else hangs off.</a:t>
-            </a:r>
-            <a:endParaRPr lang="en-US" sz="1500" dirty="0"/>
+              <a:t>Each department note compiles into an agent that answers for that department and nothing else.</a:t>
+            </a:r>
+            <a:endParaRPr lang="en-US" sz="1600" dirty="0"/>
           </a:p>
         </p:txBody>
       </p:sp>
@@ -3889,12 +3889,12 @@
         </p:nvSpPr>
         <p:spPr>
           <a:xfrm>
-            <a:off x="777240" y="2651760"/>
-            <a:ext cx="3291840" cy="2373757"/>
+            <a:off x="777240" y="2788920"/>
+            <a:ext cx="3291840" cy="1977009"/>
           </a:xfrm>
           <a:prstGeom prst="roundRect">
             <a:avLst>
-              <a:gd name="adj" fmla="val 2311"/>
+              <a:gd name="adj" fmla="val 2775"/>
             </a:avLst>
           </a:prstGeom>
           <a:solidFill>
@@ -3916,7 +3916,7 @@
         </p:nvSpPr>
         <p:spPr>
           <a:xfrm>
-            <a:off x="1051560" y="2926080"/>
+            <a:off x="1051560" y="3063240"/>
             <a:ext cx="2743200" cy="219456"/>
           </a:xfrm>
           <a:prstGeom prst="rect">
@@ -3935,7 +3935,7 @@
             <a:r>
               <a:rPr lang="en-US" sz="950" spc="140" kern="0" dirty="0">
                 <a:solidFill>
-                  <a:srgbClr val="7367F0"/>
+                  <a:srgbClr val="6055D8"/>
                 </a:solidFill>
                 <a:latin typeface="Courier New" pitchFamily="34" charset="0"/>
                 <a:ea typeface="Courier New" pitchFamily="34" charset="-122"/>
@@ -3955,7 +3955,7 @@
         </p:nvSpPr>
         <p:spPr>
           <a:xfrm>
-            <a:off x="1051560" y="3218688"/>
+            <a:off x="1051560" y="3355848"/>
             <a:ext cx="2743200" cy="259080"/>
           </a:xfrm>
           <a:prstGeom prst="rect">
@@ -3997,8 +3997,8 @@
         </p:nvSpPr>
         <p:spPr>
           <a:xfrm>
-            <a:off x="1051560" y="3605784"/>
-            <a:ext cx="2743200" cy="1163701"/>
+            <a:off x="1051560" y="3742944"/>
+            <a:ext cx="2743200" cy="766953"/>
           </a:xfrm>
           <a:prstGeom prst="rect">
             <a:avLst/>
@@ -4012,12 +4012,12 @@
           <a:p>
             <a:pPr indent="0" marL="0">
               <a:lnSpc>
-                <a:spcPts val="1775"/>
+                <a:spcPts val="1917"/>
               </a:lnSpc>
               <a:buNone/>
             </a:pPr>
             <a:r>
-              <a:rPr lang="en-US" sz="1250" dirty="0">
+              <a:rPr lang="en-US" sz="1350" dirty="0">
                 <a:solidFill>
                   <a:srgbClr val="5B6270"/>
                 </a:solidFill>
@@ -4025,9 +4025,9 @@
                 <a:ea typeface="Public Sans" pitchFamily="34" charset="-122"/>
                 <a:cs typeface="Public Sans" pitchFamily="34" charset="-120"/>
               </a:rPr>
-              <a:t>Ask it about its own ground and it knows the notes, the workflows and what is outstanding. Ask it about somebody else's and it hands the question back.</a:t>
-            </a:r>
-            <a:endParaRPr lang="en-US" sz="1250" dirty="0"/>
+              <a:t>It knows its own notes, workflows and what is outstanding. Anything else, it hands back.</a:t>
+            </a:r>
+            <a:endParaRPr lang="en-US" sz="1350" dirty="0"/>
           </a:p>
         </p:txBody>
       </p:sp>
@@ -4039,12 +4039,12 @@
         </p:nvSpPr>
         <p:spPr>
           <a:xfrm>
-            <a:off x="4434840" y="2651760"/>
-            <a:ext cx="3291840" cy="2373757"/>
+            <a:off x="4434840" y="2788920"/>
+            <a:ext cx="3291840" cy="1977009"/>
           </a:xfrm>
           <a:prstGeom prst="roundRect">
             <a:avLst>
-              <a:gd name="adj" fmla="val 2311"/>
+              <a:gd name="adj" fmla="val 2775"/>
             </a:avLst>
           </a:prstGeom>
           <a:solidFill>
@@ -4066,7 +4066,7 @@
         </p:nvSpPr>
         <p:spPr>
           <a:xfrm>
-            <a:off x="4709160" y="2926080"/>
+            <a:off x="4709160" y="3063240"/>
             <a:ext cx="2743200" cy="219456"/>
           </a:xfrm>
           <a:prstGeom prst="rect">
@@ -4085,7 +4085,7 @@
             <a:r>
               <a:rPr lang="en-US" sz="950" spc="140" kern="0" dirty="0">
                 <a:solidFill>
-                  <a:srgbClr val="7367F0"/>
+                  <a:srgbClr val="6055D8"/>
                 </a:solidFill>
                 <a:latin typeface="Courier New" pitchFamily="34" charset="0"/>
                 <a:ea typeface="Courier New" pitchFamily="34" charset="-122"/>
@@ -4105,7 +4105,7 @@
         </p:nvSpPr>
         <p:spPr>
           <a:xfrm>
-            <a:off x="4709160" y="3218688"/>
+            <a:off x="4709160" y="3355848"/>
             <a:ext cx="2743200" cy="259080"/>
           </a:xfrm>
           <a:prstGeom prst="rect">
@@ -4147,8 +4147,8 @@
         </p:nvSpPr>
         <p:spPr>
           <a:xfrm>
-            <a:off x="4709160" y="3605784"/>
-            <a:ext cx="2743200" cy="1163701"/>
+            <a:off x="4709160" y="3742944"/>
+            <a:ext cx="2743200" cy="766953"/>
           </a:xfrm>
           <a:prstGeom prst="rect">
             <a:avLst/>
@@ -4162,12 +4162,12 @@
           <a:p>
             <a:pPr indent="0" marL="0">
               <a:lnSpc>
-                <a:spcPts val="1775"/>
+                <a:spcPts val="1917"/>
               </a:lnSpc>
               <a:buNone/>
             </a:pPr>
             <a:r>
-              <a:rPr lang="en-US" sz="1250" dirty="0">
+              <a:rPr lang="en-US" sz="1350" dirty="0">
                 <a:solidFill>
                   <a:srgbClr val="5B6270"/>
                 </a:solidFill>
@@ -4175,9 +4175,9 @@
                 <a:ea typeface="Public Sans" pitchFamily="34" charset="-122"/>
                 <a:cs typeface="Public Sans" pitchFamily="34" charset="-120"/>
               </a:rPr>
-              <a:t>Drafts, assessments, the next version of a note. Publishing, sending, spending and deleting stay yours — that never changes.</a:t>
-            </a:r>
-            <a:endParaRPr lang="en-US" sz="1250" dirty="0"/>
+              <a:t>Drafts and assessments. Publishing, sending and spending stay yours.</a:t>
+            </a:r>
+            <a:endParaRPr lang="en-US" sz="1350" dirty="0"/>
           </a:p>
         </p:txBody>
       </p:sp>
@@ -4189,12 +4189,12 @@
         </p:nvSpPr>
         <p:spPr>
           <a:xfrm>
-            <a:off x="8092440" y="2651760"/>
-            <a:ext cx="3291840" cy="2373757"/>
+            <a:off x="8092440" y="2788920"/>
+            <a:ext cx="3291840" cy="1977009"/>
           </a:xfrm>
           <a:prstGeom prst="roundRect">
             <a:avLst>
-              <a:gd name="adj" fmla="val 2311"/>
+              <a:gd name="adj" fmla="val 2775"/>
             </a:avLst>
           </a:prstGeom>
           <a:solidFill>
@@ -4216,7 +4216,7 @@
         </p:nvSpPr>
         <p:spPr>
           <a:xfrm>
-            <a:off x="8366760" y="2926080"/>
+            <a:off x="8366760" y="3063240"/>
             <a:ext cx="2743200" cy="219456"/>
           </a:xfrm>
           <a:prstGeom prst="rect">
@@ -4235,7 +4235,7 @@
             <a:r>
               <a:rPr lang="en-US" sz="950" spc="140" kern="0" dirty="0">
                 <a:solidFill>
-                  <a:srgbClr val="7367F0"/>
+                  <a:srgbClr val="6055D8"/>
                 </a:solidFill>
                 <a:latin typeface="Courier New" pitchFamily="34" charset="0"/>
                 <a:ea typeface="Courier New" pitchFamily="34" charset="-122"/>
@@ -4255,7 +4255,7 @@
         </p:nvSpPr>
         <p:spPr>
           <a:xfrm>
-            <a:off x="8366760" y="3218688"/>
+            <a:off x="8366760" y="3355848"/>
             <a:ext cx="2743200" cy="259080"/>
           </a:xfrm>
           <a:prstGeom prst="rect">
@@ -4297,8 +4297,8 @@
         </p:nvSpPr>
         <p:spPr>
           <a:xfrm>
-            <a:off x="8366760" y="3605784"/>
-            <a:ext cx="2743200" cy="1163701"/>
+            <a:off x="8366760" y="3742944"/>
+            <a:ext cx="2743200" cy="766953"/>
           </a:xfrm>
           <a:prstGeom prst="rect">
             <a:avLst/>
@@ -4312,12 +4312,12 @@
           <a:p>
             <a:pPr indent="0" marL="0">
               <a:lnSpc>
-                <a:spcPts val="1775"/>
+                <a:spcPts val="1917"/>
               </a:lnSpc>
               <a:buNone/>
             </a:pPr>
             <a:r>
-              <a:rPr lang="en-US" sz="1250" dirty="0">
+              <a:rPr lang="en-US" sz="1350" dirty="0">
                 <a:solidFill>
                   <a:srgbClr val="5B6270"/>
                 </a:solidFill>
@@ -4325,9 +4325,9 @@
                 <a:ea typeface="Public Sans" pitchFamily="34" charset="-122"/>
                 <a:cs typeface="Public Sans" pitchFamily="34" charset="-120"/>
               </a:rPr>
-              <a:t>Every executive writes down what it does not own. An agent always answers; the stop line is what makes the answers you do get worth having.</a:t>
-            </a:r>
-            <a:endParaRPr lang="en-US" sz="1250" dirty="0"/>
+              <a:t>Every executive writes down what it does not own. That is what makes its answers worth having.</a:t>
+            </a:r>
+            <a:endParaRPr lang="en-US" sz="1350" dirty="0"/>
           </a:p>
         </p:txBody>
       </p:sp>
@@ -4339,7 +4339,7 @@
         </p:nvSpPr>
         <p:spPr>
           <a:xfrm>
-            <a:off x="777240" y="5669280"/>
+            <a:off x="777240" y="5223129"/>
             <a:ext cx="10607040" cy="365760"/>
           </a:xfrm>
           <a:prstGeom prst="rect">
@@ -4397,7 +4397,7 @@
             <a:r>
               <a:rPr lang="en-US" sz="950" spc="100" kern="0" dirty="0">
                 <a:solidFill>
-                  <a:srgbClr val="9198A6"/>
+                  <a:srgbClr val="6B6D72"/>
                 </a:solidFill>
                 <a:latin typeface="Courier New" pitchFamily="34" charset="0"/>
                 <a:ea typeface="Courier New" pitchFamily="34" charset="-122"/>
@@ -4468,7 +4468,7 @@
             <a:r>
               <a:rPr lang="en-US" sz="1100" spc="200" kern="0" dirty="0">
                 <a:solidFill>
-                  <a:srgbClr val="7367F0"/>
+                  <a:srgbClr val="6055D8"/>
                 </a:solidFill>
                 <a:latin typeface="Courier New" pitchFamily="34" charset="0"/>
                 <a:ea typeface="Courier New" pitchFamily="34" charset="-122"/>
@@ -4569,12 +4569,12 @@
           <a:p>
             <a:pPr indent="0" marL="0">
               <a:lnSpc>
-                <a:spcPts val="2100"/>
+                <a:spcPts val="2300"/>
               </a:lnSpc>
               <a:buNone/>
             </a:pPr>
             <a:r>
-              <a:rPr lang="en-US" sz="1500" dirty="0">
+              <a:rPr lang="en-US" sz="1600" dirty="0">
                 <a:solidFill>
                   <a:srgbClr val="5B6270"/>
                 </a:solidFill>
@@ -4582,9 +4582,9 @@
                 <a:ea typeface="Public Sans" pitchFamily="34" charset="-122"/>
                 <a:cs typeface="Public Sans" pitchFamily="34" charset="-120"/>
               </a:rPr>
-              <a:t>Nobody drew this. It is read off each role note — who it reports to, which department it answers for — and redrawn every time the site is built.</a:t>
-            </a:r>
-            <a:endParaRPr lang="en-US" sz="1500" dirty="0"/>
+              <a:t>Nobody drew this. It is read off the role notes and redrawn every time the site is built.</a:t>
+            </a:r>
+            <a:endParaRPr lang="en-US" sz="1600" dirty="0"/>
           </a:p>
         </p:txBody>
       </p:sp>
@@ -4639,7 +4639,7 @@
             <a:r>
               <a:rPr lang="en-US" sz="950" spc="100" kern="0" dirty="0">
                 <a:solidFill>
-                  <a:srgbClr val="9198A6"/>
+                  <a:srgbClr val="6B6D72"/>
                 </a:solidFill>
                 <a:latin typeface="Courier New" pitchFamily="34" charset="0"/>
                 <a:ea typeface="Courier New" pitchFamily="34" charset="-122"/>
@@ -4710,7 +4710,7 @@
             <a:r>
               <a:rPr lang="en-US" sz="1100" spc="200" kern="0" dirty="0">
                 <a:solidFill>
-                  <a:srgbClr val="7367F0"/>
+                  <a:srgbClr val="6055D8"/>
                 </a:solidFill>
                 <a:latin typeface="Courier New" pitchFamily="34" charset="0"/>
                 <a:ea typeface="Courier New" pitchFamily="34" charset="-122"/>
@@ -4856,11 +4856,11 @@
         <p:spPr>
           <a:xfrm>
             <a:off x="777240" y="1938528"/>
-            <a:ext cx="10637215" cy="1566672"/>
+            <a:ext cx="10637215" cy="1236472"/>
           </a:xfrm>
           <a:prstGeom prst="roundRect">
             <a:avLst>
-              <a:gd name="adj" fmla="val 3502"/>
+              <a:gd name="adj" fmla="val 4437"/>
             </a:avLst>
           </a:prstGeom>
           <a:solidFill>
@@ -4883,7 +4883,7 @@
         <p:spPr>
           <a:xfrm>
             <a:off x="1143000" y="1938528"/>
-            <a:ext cx="9905695" cy="1566672"/>
+            <a:ext cx="9905695" cy="1236472"/>
           </a:xfrm>
           <a:prstGeom prst="rect">
             <a:avLst/>
@@ -4904,7 +4904,7 @@
             <a:r>
               <a:rPr lang="en-US" sz="1050" spc="160" kern="0" dirty="0">
                 <a:solidFill>
-                  <a:srgbClr val="7367F0"/>
+                  <a:srgbClr val="6055D8"/>
                 </a:solidFill>
                 <a:latin typeface="Courier New" pitchFamily="34" charset="0"/>
                 <a:ea typeface="Courier New" pitchFamily="34" charset="-122"/>
@@ -4936,7 +4936,7 @@
                 <a:ea typeface="Public Sans" pitchFamily="34" charset="-122"/>
                 <a:cs typeface="Public Sans" pitchFamily="34" charset="-120"/>
               </a:rPr>
-              <a:t>Pick something you explain the same way every time. Say: teach [executive] a skill for this, and then describe how you do it.</a:t>
+              <a:t>Say: teach [executive] a skill for this. Then describe how you do it.</a:t>
             </a:r>
             <a:endParaRPr lang="en-US" sz="1050" dirty="0"/>
           </a:p>
@@ -4950,7 +4950,7 @@
         </p:nvSpPr>
         <p:spPr>
           <a:xfrm>
-            <a:off x="777240" y="3669792"/>
+            <a:off x="777240" y="3339592"/>
             <a:ext cx="10637215" cy="321564"/>
           </a:xfrm>
           <a:prstGeom prst="rect">
@@ -4995,7 +4995,7 @@
                 <a:ea typeface="Public Sans" pitchFamily="34" charset="-122"/>
                 <a:cs typeface="Public Sans" pitchFamily="34" charset="-120"/>
               </a:rPr>
-              <a:t>a skill appears in your vault, and the executive knows to reach for it by name.</a:t>
+              <a:t>a skill appears in your vault and the executive reaches for it by name.</a:t>
             </a:r>
             <a:endParaRPr lang="en-US" sz="1450" dirty="0"/>
           </a:p>
@@ -5009,12 +5009,12 @@
         </p:nvSpPr>
         <p:spPr>
           <a:xfrm>
-            <a:off x="777240" y="4247388"/>
-            <a:ext cx="5029200" cy="1700276"/>
+            <a:off x="777240" y="3917188"/>
+            <a:ext cx="5029200" cy="1751584"/>
           </a:xfrm>
           <a:prstGeom prst="roundRect">
             <a:avLst>
-              <a:gd name="adj" fmla="val 3227"/>
+              <a:gd name="adj" fmla="val 3132"/>
             </a:avLst>
           </a:prstGeom>
           <a:solidFill>
@@ -5036,7 +5036,7 @@
         </p:nvSpPr>
         <p:spPr>
           <a:xfrm>
-            <a:off x="1051560" y="4521708"/>
+            <a:off x="1051560" y="4191508"/>
             <a:ext cx="4480560" cy="219456"/>
           </a:xfrm>
           <a:prstGeom prst="rect">
@@ -5055,7 +5055,7 @@
             <a:r>
               <a:rPr lang="en-US" sz="950" spc="140" kern="0" dirty="0">
                 <a:solidFill>
-                  <a:srgbClr val="7367F0"/>
+                  <a:srgbClr val="6055D8"/>
                 </a:solidFill>
                 <a:latin typeface="Courier New" pitchFamily="34" charset="0"/>
                 <a:ea typeface="Courier New" pitchFamily="34" charset="-122"/>
@@ -5075,8 +5075,8 @@
         </p:nvSpPr>
         <p:spPr>
           <a:xfrm>
-            <a:off x="1051560" y="4814316"/>
-            <a:ext cx="4480560" cy="243840"/>
+            <a:off x="1051560" y="4484116"/>
+            <a:ext cx="4480560" cy="259080"/>
           </a:xfrm>
           <a:prstGeom prst="rect">
             <a:avLst/>
@@ -5090,12 +5090,12 @@
           <a:p>
             <a:pPr indent="0" marL="0">
               <a:lnSpc>
-                <a:spcPts val="1920"/>
+                <a:spcPts val="2040"/>
               </a:lnSpc>
               <a:buNone/>
             </a:pPr>
             <a:r>
-              <a:rPr lang="en-US" sz="1600" b="1" dirty="0">
+              <a:rPr lang="en-US" sz="1700" b="1" dirty="0">
                 <a:solidFill>
                   <a:srgbClr val="15171F"/>
                 </a:solidFill>
@@ -5105,7 +5105,7 @@
               </a:rPr>
               <a:t>Your method, written once</a:t>
             </a:r>
-            <a:endParaRPr lang="en-US" sz="1600" dirty="0"/>
+            <a:endParaRPr lang="en-US" sz="1700" dirty="0"/>
           </a:p>
         </p:txBody>
       </p:sp>
@@ -5117,8 +5117,8 @@
         </p:nvSpPr>
         <p:spPr>
           <a:xfrm>
-            <a:off x="1051560" y="5186172"/>
-            <a:ext cx="4480560" cy="505460"/>
+            <a:off x="1051560" y="4871212"/>
+            <a:ext cx="4480560" cy="541528"/>
           </a:xfrm>
           <a:prstGeom prst="rect">
             <a:avLst/>
@@ -5132,12 +5132,12 @@
           <a:p>
             <a:pPr indent="0" marL="0">
               <a:lnSpc>
-                <a:spcPts val="1846"/>
+                <a:spcPts val="1988"/>
               </a:lnSpc>
               <a:buNone/>
             </a:pPr>
             <a:r>
-              <a:rPr lang="en-US" sz="1300" dirty="0">
+              <a:rPr lang="en-US" sz="1400" dirty="0">
                 <a:solidFill>
                   <a:srgbClr val="5B6270"/>
                 </a:solidFill>
@@ -5145,9 +5145,9 @@
                 <a:ea typeface="Public Sans" pitchFamily="34" charset="-122"/>
                 <a:cs typeface="Public Sans" pitchFamily="34" charset="-120"/>
               </a:rPr>
-              <a:t>When to use it, the steps, where it stops. It is why the agent works your way instead of improvising.</a:t>
-            </a:r>
-            <a:endParaRPr lang="en-US" sz="1300" dirty="0"/>
+              <a:t>When to use it, the steps, where it stops. So it works your way, not its own.</a:t>
+            </a:r>
+            <a:endParaRPr lang="en-US" sz="1400" dirty="0"/>
           </a:p>
         </p:txBody>
       </p:sp>
@@ -5159,12 +5159,12 @@
         </p:nvSpPr>
         <p:spPr>
           <a:xfrm>
-            <a:off x="6172200" y="4247388"/>
-            <a:ext cx="5029200" cy="1700276"/>
+            <a:off x="6172200" y="3917188"/>
+            <a:ext cx="5029200" cy="1751584"/>
           </a:xfrm>
           <a:prstGeom prst="roundRect">
             <a:avLst>
-              <a:gd name="adj" fmla="val 3227"/>
+              <a:gd name="adj" fmla="val 3132"/>
             </a:avLst>
           </a:prstGeom>
           <a:solidFill>
@@ -5186,7 +5186,7 @@
         </p:nvSpPr>
         <p:spPr>
           <a:xfrm>
-            <a:off x="6446520" y="4521708"/>
+            <a:off x="6446520" y="4191508"/>
             <a:ext cx="4480560" cy="219456"/>
           </a:xfrm>
           <a:prstGeom prst="rect">
@@ -5205,7 +5205,7 @@
             <a:r>
               <a:rPr lang="en-US" sz="950" spc="140" kern="0" dirty="0">
                 <a:solidFill>
-                  <a:srgbClr val="7367F0"/>
+                  <a:srgbClr val="6055D8"/>
                 </a:solidFill>
                 <a:latin typeface="Courier New" pitchFamily="34" charset="0"/>
                 <a:ea typeface="Courier New" pitchFamily="34" charset="-122"/>
@@ -5225,8 +5225,8 @@
         </p:nvSpPr>
         <p:spPr>
           <a:xfrm>
-            <a:off x="6446520" y="4814316"/>
-            <a:ext cx="4480560" cy="243840"/>
+            <a:off x="6446520" y="4484116"/>
+            <a:ext cx="4480560" cy="259080"/>
           </a:xfrm>
           <a:prstGeom prst="rect">
             <a:avLst/>
@@ -5240,12 +5240,12 @@
           <a:p>
             <a:pPr indent="0" marL="0">
               <a:lnSpc>
-                <a:spcPts val="1920"/>
+                <a:spcPts val="2040"/>
               </a:lnSpc>
               <a:buNone/>
             </a:pPr>
             <a:r>
-              <a:rPr lang="en-US" sz="1600" b="1" dirty="0">
+              <a:rPr lang="en-US" sz="1700" b="1" dirty="0">
                 <a:solidFill>
                   <a:srgbClr val="15171F"/>
                 </a:solidFill>
@@ -5255,7 +5255,7 @@
               </a:rPr>
               <a:t>You explained it twice</a:t>
             </a:r>
-            <a:endParaRPr lang="en-US" sz="1600" dirty="0"/>
+            <a:endParaRPr lang="en-US" sz="1700" dirty="0"/>
           </a:p>
         </p:txBody>
       </p:sp>
@@ -5267,8 +5267,8 @@
         </p:nvSpPr>
         <p:spPr>
           <a:xfrm>
-            <a:off x="6446520" y="5186172"/>
-            <a:ext cx="4480560" cy="505460"/>
+            <a:off x="6446520" y="4871212"/>
+            <a:ext cx="4480560" cy="541528"/>
           </a:xfrm>
           <a:prstGeom prst="rect">
             <a:avLst/>
@@ -5282,12 +5282,12 @@
           <a:p>
             <a:pPr indent="0" marL="0">
               <a:lnSpc>
-                <a:spcPts val="1846"/>
+                <a:spcPts val="1988"/>
               </a:lnSpc>
               <a:buNone/>
             </a:pPr>
             <a:r>
-              <a:rPr lang="en-US" sz="1300" dirty="0">
+              <a:rPr lang="en-US" sz="1400" dirty="0">
                 <a:solidFill>
                   <a:srgbClr val="5B6270"/>
                 </a:solidFill>
@@ -5297,7 +5297,7 @@
               </a:rPr>
               <a:t>The second time you type the same guidance, it should have been a skill the first time.</a:t>
             </a:r>
-            <a:endParaRPr lang="en-US" sz="1300" dirty="0"/>
+            <a:endParaRPr lang="en-US" sz="1400" dirty="0"/>
           </a:p>
         </p:txBody>
       </p:sp>
@@ -5328,7 +5328,7 @@
             <a:r>
               <a:rPr lang="en-US" sz="950" spc="100" kern="0" dirty="0">
                 <a:solidFill>
-                  <a:srgbClr val="9198A6"/>
+                  <a:srgbClr val="6B6D72"/>
                 </a:solidFill>
                 <a:latin typeface="Courier New" pitchFamily="34" charset="0"/>
                 <a:ea typeface="Courier New" pitchFamily="34" charset="-122"/>
@@ -5399,7 +5399,7 @@
             <a:r>
               <a:rPr lang="en-US" sz="1100" spc="200" kern="0" dirty="0">
                 <a:solidFill>
-                  <a:srgbClr val="7367F0"/>
+                  <a:srgbClr val="6055D8"/>
                 </a:solidFill>
                 <a:latin typeface="Courier New" pitchFamily="34" charset="0"/>
                 <a:ea typeface="Courier New" pitchFamily="34" charset="-122"/>
@@ -5545,11 +5545,11 @@
         <p:spPr>
           <a:xfrm>
             <a:off x="777240" y="1938528"/>
-            <a:ext cx="10637215" cy="1566672"/>
+            <a:ext cx="10637215" cy="1236472"/>
           </a:xfrm>
           <a:prstGeom prst="roundRect">
             <a:avLst>
-              <a:gd name="adj" fmla="val 3502"/>
+              <a:gd name="adj" fmla="val 4437"/>
             </a:avLst>
           </a:prstGeom>
           <a:solidFill>
@@ -5572,7 +5572,7 @@
         <p:spPr>
           <a:xfrm>
             <a:off x="1143000" y="1938528"/>
-            <a:ext cx="9905695" cy="1566672"/>
+            <a:ext cx="9905695" cy="1236472"/>
           </a:xfrm>
           <a:prstGeom prst="rect">
             <a:avLst/>
@@ -5593,7 +5593,7 @@
             <a:r>
               <a:rPr lang="en-US" sz="1050" spc="160" kern="0" dirty="0">
                 <a:solidFill>
-                  <a:srgbClr val="7367F0"/>
+                  <a:srgbClr val="6055D8"/>
                 </a:solidFill>
                 <a:latin typeface="Courier New" pitchFamily="34" charset="0"/>
                 <a:ea typeface="Courier New" pitchFamily="34" charset="-122"/>
@@ -5625,7 +5625,7 @@
                 <a:ea typeface="Public Sans" pitchFamily="34" charset="-122"/>
                 <a:cs typeface="Public Sans" pitchFamily="34" charset="-120"/>
               </a:rPr>
-              <a:t>Say: add a specialist under [executive] that does [one narrow job]. Then rebuild and look at the chart.</a:t>
+              <a:t>Say: add a specialist under [executive] that does [one narrow job].</a:t>
             </a:r>
             <a:endParaRPr lang="en-US" sz="1050" dirty="0"/>
           </a:p>
@@ -5639,7 +5639,7 @@
         </p:nvSpPr>
         <p:spPr>
           <a:xfrm>
-            <a:off x="777240" y="3669792"/>
+            <a:off x="777240" y="3339592"/>
             <a:ext cx="10637215" cy="321564"/>
           </a:xfrm>
           <a:prstGeom prst="rect">
@@ -5698,12 +5698,12 @@
         </p:nvSpPr>
         <p:spPr>
           <a:xfrm>
-            <a:off x="777240" y="4247388"/>
-            <a:ext cx="5029200" cy="1700276"/>
+            <a:off x="777240" y="3917188"/>
+            <a:ext cx="5029200" cy="1751584"/>
           </a:xfrm>
           <a:prstGeom prst="roundRect">
             <a:avLst>
-              <a:gd name="adj" fmla="val 3227"/>
+              <a:gd name="adj" fmla="val 3132"/>
             </a:avLst>
           </a:prstGeom>
           <a:solidFill>
@@ -5725,7 +5725,7 @@
         </p:nvSpPr>
         <p:spPr>
           <a:xfrm>
-            <a:off x="1051560" y="4521708"/>
+            <a:off x="1051560" y="4191508"/>
             <a:ext cx="4480560" cy="219456"/>
           </a:xfrm>
           <a:prstGeom prst="rect">
@@ -5744,7 +5744,7 @@
             <a:r>
               <a:rPr lang="en-US" sz="950" spc="140" kern="0" dirty="0">
                 <a:solidFill>
-                  <a:srgbClr val="7367F0"/>
+                  <a:srgbClr val="6055D8"/>
                 </a:solidFill>
                 <a:latin typeface="Courier New" pitchFamily="34" charset="0"/>
                 <a:ea typeface="Courier New" pitchFamily="34" charset="-122"/>
@@ -5764,8 +5764,8 @@
         </p:nvSpPr>
         <p:spPr>
           <a:xfrm>
-            <a:off x="1051560" y="4814316"/>
-            <a:ext cx="4480560" cy="243840"/>
+            <a:off x="1051560" y="4484116"/>
+            <a:ext cx="4480560" cy="259080"/>
           </a:xfrm>
           <a:prstGeom prst="rect">
             <a:avLst/>
@@ -5779,12 +5779,12 @@
           <a:p>
             <a:pPr indent="0" marL="0">
               <a:lnSpc>
-                <a:spcPts val="1920"/>
+                <a:spcPts val="2040"/>
               </a:lnSpc>
               <a:buNone/>
             </a:pPr>
             <a:r>
-              <a:rPr lang="en-US" sz="1600" b="1" dirty="0">
+              <a:rPr lang="en-US" sz="1700" b="1" dirty="0">
                 <a:solidFill>
                   <a:srgbClr val="15171F"/>
                 </a:solidFill>
@@ -5794,7 +5794,7 @@
               </a:rPr>
               <a:t>One job, done properly</a:t>
             </a:r>
-            <a:endParaRPr lang="en-US" sz="1600" dirty="0"/>
+            <a:endParaRPr lang="en-US" sz="1700" dirty="0"/>
           </a:p>
         </p:txBody>
       </p:sp>
@@ -5806,8 +5806,8 @@
         </p:nvSpPr>
         <p:spPr>
           <a:xfrm>
-            <a:off x="1051560" y="5186172"/>
-            <a:ext cx="4480560" cy="505460"/>
+            <a:off x="1051560" y="4871212"/>
+            <a:ext cx="4480560" cy="541528"/>
           </a:xfrm>
           <a:prstGeom prst="rect">
             <a:avLst/>
@@ -5821,12 +5821,12 @@
           <a:p>
             <a:pPr indent="0" marL="0">
               <a:lnSpc>
-                <a:spcPts val="1846"/>
+                <a:spcPts val="1988"/>
               </a:lnSpc>
               <a:buNone/>
             </a:pPr>
             <a:r>
-              <a:rPr lang="en-US" sz="1300" dirty="0">
+              <a:rPr lang="en-US" sz="1400" dirty="0">
                 <a:solidFill>
                   <a:srgbClr val="5B6270"/>
                 </a:solidFill>
@@ -5836,7 +5836,7 @@
               </a:rPr>
               <a:t>Spots quiet accounts. Drafts the post. Writes the first pass. Anything else, it hands straight back.</a:t>
             </a:r>
-            <a:endParaRPr lang="en-US" sz="1300" dirty="0"/>
+            <a:endParaRPr lang="en-US" sz="1400" dirty="0"/>
           </a:p>
         </p:txBody>
       </p:sp>
@@ -5848,12 +5848,12 @@
         </p:nvSpPr>
         <p:spPr>
           <a:xfrm>
-            <a:off x="6172200" y="4247388"/>
-            <a:ext cx="5029200" cy="1700276"/>
+            <a:off x="6172200" y="3917188"/>
+            <a:ext cx="5029200" cy="1751584"/>
           </a:xfrm>
           <a:prstGeom prst="roundRect">
             <a:avLst>
-              <a:gd name="adj" fmla="val 3227"/>
+              <a:gd name="adj" fmla="val 3132"/>
             </a:avLst>
           </a:prstGeom>
           <a:solidFill>
@@ -5875,7 +5875,7 @@
         </p:nvSpPr>
         <p:spPr>
           <a:xfrm>
-            <a:off x="6446520" y="4521708"/>
+            <a:off x="6446520" y="4191508"/>
             <a:ext cx="4480560" cy="219456"/>
           </a:xfrm>
           <a:prstGeom prst="rect">
@@ -5894,7 +5894,7 @@
             <a:r>
               <a:rPr lang="en-US" sz="950" spc="140" kern="0" dirty="0">
                 <a:solidFill>
-                  <a:srgbClr val="7367F0"/>
+                  <a:srgbClr val="6055D8"/>
                 </a:solidFill>
                 <a:latin typeface="Courier New" pitchFamily="34" charset="0"/>
                 <a:ea typeface="Courier New" pitchFamily="34" charset="-122"/>
@@ -5914,8 +5914,8 @@
         </p:nvSpPr>
         <p:spPr>
           <a:xfrm>
-            <a:off x="6446520" y="4814316"/>
-            <a:ext cx="4480560" cy="243840"/>
+            <a:off x="6446520" y="4484116"/>
+            <a:ext cx="4480560" cy="259080"/>
           </a:xfrm>
           <a:prstGeom prst="rect">
             <a:avLst/>
@@ -5929,12 +5929,12 @@
           <a:p>
             <a:pPr indent="0" marL="0">
               <a:lnSpc>
-                <a:spcPts val="1920"/>
+                <a:spcPts val="2040"/>
               </a:lnSpc>
               <a:buNone/>
             </a:pPr>
             <a:r>
-              <a:rPr lang="en-US" sz="1600" b="1" dirty="0">
+              <a:rPr lang="en-US" sz="1700" b="1" dirty="0">
                 <a:solidFill>
                   <a:srgbClr val="15171F"/>
                 </a:solidFill>
@@ -5944,7 +5944,7 @@
               </a:rPr>
               <a:t>A task, not an area</a:t>
             </a:r>
-            <a:endParaRPr lang="en-US" sz="1600" dirty="0"/>
+            <a:endParaRPr lang="en-US" sz="1700" dirty="0"/>
           </a:p>
         </p:txBody>
       </p:sp>
@@ -5956,8 +5956,8 @@
         </p:nvSpPr>
         <p:spPr>
           <a:xfrm>
-            <a:off x="6446520" y="5186172"/>
-            <a:ext cx="4480560" cy="505460"/>
+            <a:off x="6446520" y="4871212"/>
+            <a:ext cx="4480560" cy="541528"/>
           </a:xfrm>
           <a:prstGeom prst="rect">
             <a:avLst/>
@@ -5971,12 +5971,12 @@
           <a:p>
             <a:pPr indent="0" marL="0">
               <a:lnSpc>
-                <a:spcPts val="1846"/>
+                <a:spcPts val="1988"/>
               </a:lnSpc>
               <a:buNone/>
             </a:pPr>
             <a:r>
-              <a:rPr lang="en-US" sz="1300" dirty="0">
+              <a:rPr lang="en-US" sz="1400" dirty="0">
                 <a:solidFill>
                   <a:srgbClr val="5B6270"/>
                 </a:solidFill>
@@ -5986,7 +5986,7 @@
               </a:rPr>
               <a:t>Several kinds of work? That is a department. One fiddly thing that keeps going wrong? That is this.</a:t>
             </a:r>
-            <a:endParaRPr lang="en-US" sz="1300" dirty="0"/>
+            <a:endParaRPr lang="en-US" sz="1400" dirty="0"/>
           </a:p>
         </p:txBody>
       </p:sp>
@@ -6017,7 +6017,7 @@
             <a:r>
               <a:rPr lang="en-US" sz="950" spc="100" kern="0" dirty="0">
                 <a:solidFill>
-                  <a:srgbClr val="9198A6"/>
+                  <a:srgbClr val="6B6D72"/>
                 </a:solidFill>
                 <a:latin typeface="Courier New" pitchFamily="34" charset="0"/>
                 <a:ea typeface="Courier New" pitchFamily="34" charset="-122"/>
@@ -6088,7 +6088,7 @@
             <a:r>
               <a:rPr lang="en-US" sz="1100" spc="200" kern="0" dirty="0">
                 <a:solidFill>
-                  <a:srgbClr val="7367F0"/>
+                  <a:srgbClr val="6055D8"/>
                 </a:solidFill>
                 <a:latin typeface="Courier New" pitchFamily="34" charset="0"/>
                 <a:ea typeface="Courier New" pitchFamily="34" charset="-122"/>
@@ -6189,12 +6189,12 @@
           <a:p>
             <a:pPr indent="0" marL="0">
               <a:lnSpc>
-                <a:spcPts val="2100"/>
+                <a:spcPts val="2300"/>
               </a:lnSpc>
               <a:buNone/>
             </a:pPr>
             <a:r>
-              <a:rPr lang="en-US" sz="1500" dirty="0">
+              <a:rPr lang="en-US" sz="1600" dirty="0">
                 <a:solidFill>
                   <a:srgbClr val="5B6270"/>
                 </a:solidFill>
@@ -6202,9 +6202,9 @@
                 <a:ea typeface="Public Sans" pitchFamily="34" charset="-122"/>
                 <a:cs typeface="Public Sans" pitchFamily="34" charset="-120"/>
               </a:rPr>
-              <a:t>A workflow is how a piece of work happens. A project is a piece of work with an end. Both belong to a department, so neither drifts into a pile nobody owns.</a:t>
-            </a:r>
-            <a:endParaRPr lang="en-US" sz="1500" dirty="0"/>
+              <a:t>A workflow is how work happens. A project is work with an end. Both belong to a department.</a:t>
+            </a:r>
+            <a:endParaRPr lang="en-US" sz="1600" dirty="0"/>
           </a:p>
         </p:txBody>
       </p:sp>
@@ -6241,11 +6241,11 @@
         <p:spPr>
           <a:xfrm>
             <a:off x="777240" y="4315968"/>
-            <a:ext cx="5029200" cy="1700276"/>
+            <a:ext cx="5029200" cy="1751584"/>
           </a:xfrm>
           <a:prstGeom prst="roundRect">
             <a:avLst>
-              <a:gd name="adj" fmla="val 3227"/>
+              <a:gd name="adj" fmla="val 3132"/>
             </a:avLst>
           </a:prstGeom>
           <a:solidFill>
@@ -6286,7 +6286,7 @@
             <a:r>
               <a:rPr lang="en-US" sz="950" spc="140" kern="0" dirty="0">
                 <a:solidFill>
-                  <a:srgbClr val="7367F0"/>
+                  <a:srgbClr val="6055D8"/>
                 </a:solidFill>
                 <a:latin typeface="Courier New" pitchFamily="34" charset="0"/>
                 <a:ea typeface="Courier New" pitchFamily="34" charset="-122"/>
@@ -6307,7 +6307,7 @@
         <p:spPr>
           <a:xfrm>
             <a:off x="1051560" y="4882896"/>
-            <a:ext cx="4480560" cy="243840"/>
+            <a:ext cx="4480560" cy="259080"/>
           </a:xfrm>
           <a:prstGeom prst="rect">
             <a:avLst/>
@@ -6321,12 +6321,12 @@
           <a:p>
             <a:pPr indent="0" marL="0">
               <a:lnSpc>
-                <a:spcPts val="1920"/>
+                <a:spcPts val="2040"/>
               </a:lnSpc>
               <a:buNone/>
             </a:pPr>
             <a:r>
-              <a:rPr lang="en-US" sz="1600" b="1" dirty="0">
+              <a:rPr lang="en-US" sz="1700" b="1" dirty="0">
                 <a:solidFill>
                   <a:srgbClr val="15171F"/>
                 </a:solidFill>
@@ -6336,7 +6336,7 @@
               </a:rPr>
               <a:t>Written down is not working</a:t>
             </a:r>
-            <a:endParaRPr lang="en-US" sz="1600" dirty="0"/>
+            <a:endParaRPr lang="en-US" sz="1700" dirty="0"/>
           </a:p>
         </p:txBody>
       </p:sp>
@@ -6348,8 +6348,8 @@
         </p:nvSpPr>
         <p:spPr>
           <a:xfrm>
-            <a:off x="1051560" y="5254752"/>
-            <a:ext cx="4480560" cy="505460"/>
+            <a:off x="1051560" y="5269992"/>
+            <a:ext cx="4480560" cy="541528"/>
           </a:xfrm>
           <a:prstGeom prst="rect">
             <a:avLst/>
@@ -6363,12 +6363,12 @@
           <a:p>
             <a:pPr indent="0" marL="0">
               <a:lnSpc>
-                <a:spcPts val="1846"/>
+                <a:spcPts val="1988"/>
               </a:lnSpc>
               <a:buNone/>
             </a:pPr>
             <a:r>
-              <a:rPr lang="en-US" sz="1300" dirty="0">
+              <a:rPr lang="en-US" sz="1400" dirty="0">
                 <a:solidFill>
                   <a:srgbClr val="5B6270"/>
                 </a:solidFill>
@@ -6378,7 +6378,7 @@
               </a:rPr>
               <a:t>Is the note true? Only after one real case. Does it run end to end? Different question.</a:t>
             </a:r>
-            <a:endParaRPr lang="en-US" sz="1300" dirty="0"/>
+            <a:endParaRPr lang="en-US" sz="1400" dirty="0"/>
           </a:p>
         </p:txBody>
       </p:sp>
@@ -6391,11 +6391,11 @@
         <p:spPr>
           <a:xfrm>
             <a:off x="6172200" y="4315968"/>
-            <a:ext cx="5029200" cy="1700276"/>
+            <a:ext cx="5029200" cy="1751584"/>
           </a:xfrm>
           <a:prstGeom prst="roundRect">
             <a:avLst>
-              <a:gd name="adj" fmla="val 3227"/>
+              <a:gd name="adj" fmla="val 3132"/>
             </a:avLst>
           </a:prstGeom>
           <a:solidFill>
@@ -6436,7 +6436,7 @@
             <a:r>
               <a:rPr lang="en-US" sz="950" spc="140" kern="0" dirty="0">
                 <a:solidFill>
-                  <a:srgbClr val="7367F0"/>
+                  <a:srgbClr val="6055D8"/>
                 </a:solidFill>
                 <a:latin typeface="Courier New" pitchFamily="34" charset="0"/>
                 <a:ea typeface="Courier New" pitchFamily="34" charset="-122"/>
@@ -6457,7 +6457,7 @@
         <p:spPr>
           <a:xfrm>
             <a:off x="6446520" y="4882896"/>
-            <a:ext cx="4480560" cy="243840"/>
+            <a:ext cx="4480560" cy="259080"/>
           </a:xfrm>
           <a:prstGeom prst="rect">
             <a:avLst/>
@@ -6471,12 +6471,12 @@
           <a:p>
             <a:pPr indent="0" marL="0">
               <a:lnSpc>
-                <a:spcPts val="1920"/>
+                <a:spcPts val="2040"/>
               </a:lnSpc>
               <a:buNone/>
             </a:pPr>
             <a:r>
-              <a:rPr lang="en-US" sz="1600" b="1" dirty="0">
+              <a:rPr lang="en-US" sz="1700" b="1" dirty="0">
                 <a:solidFill>
                   <a:srgbClr val="15171F"/>
                 </a:solidFill>
@@ -6486,7 +6486,7 @@
               </a:rPr>
               <a:t>One workflow, none running</a:t>
             </a:r>
-            <a:endParaRPr lang="en-US" sz="1600" dirty="0"/>
+            <a:endParaRPr lang="en-US" sz="1700" dirty="0"/>
           </a:p>
         </p:txBody>
       </p:sp>
@@ -6498,8 +6498,8 @@
         </p:nvSpPr>
         <p:spPr>
           <a:xfrm>
-            <a:off x="6446520" y="5254752"/>
-            <a:ext cx="4480560" cy="505460"/>
+            <a:off x="6446520" y="5269992"/>
+            <a:ext cx="4480560" cy="541528"/>
           </a:xfrm>
           <a:prstGeom prst="rect">
             <a:avLst/>
@@ -6513,12 +6513,12 @@
           <a:p>
             <a:pPr indent="0" marL="0">
               <a:lnSpc>
-                <a:spcPts val="1846"/>
+                <a:spcPts val="1988"/>
               </a:lnSpc>
               <a:buNone/>
             </a:pPr>
             <a:r>
-              <a:rPr lang="en-US" sz="1300" dirty="0">
+              <a:rPr lang="en-US" sz="1400" dirty="0">
                 <a:solidFill>
                   <a:srgbClr val="5B6270"/>
                 </a:solidFill>
@@ -6526,9 +6526,9 @@
                 <a:ea typeface="Public Sans" pitchFamily="34" charset="-122"/>
                 <a:cs typeface="Public Sans" pitchFamily="34" charset="-120"/>
               </a:rPr>
-              <a:t>Uncomfortable, true, and you did not have to admit it. It was counted.</a:t>
-            </a:r>
-            <a:endParaRPr lang="en-US" sz="1300" dirty="0"/>
+              <a:t>Uncomfortable, true, and nobody had to admit it. It was counted.</a:t>
+            </a:r>
+            <a:endParaRPr lang="en-US" sz="1400" dirty="0"/>
           </a:p>
         </p:txBody>
       </p:sp>
@@ -6559,7 +6559,7 @@
             <a:r>
               <a:rPr lang="en-US" sz="950" spc="100" kern="0" dirty="0">
                 <a:solidFill>
-                  <a:srgbClr val="9198A6"/>
+                  <a:srgbClr val="6B6D72"/>
                 </a:solidFill>
                 <a:latin typeface="Courier New" pitchFamily="34" charset="0"/>
                 <a:ea typeface="Courier New" pitchFamily="34" charset="-122"/>
@@ -7371,7 +7371,7 @@
                 <a:ea typeface="Public Sans" pitchFamily="34" charset="-122"/>
                 <a:cs typeface="Public Sans" pitchFamily="34" charset="-120"/>
               </a:rPr>
-              <a:t>None of it needs us. None of it phones home. It all still opens if you never speak to an AI again.</a:t>
+              <a:t>None of it phones home. It all still opens if you never speak to an AI again.</a:t>
             </a:r>
             <a:endParaRPr lang="en-US" sz="1500" dirty="0"/>
           </a:p>
@@ -7404,7 +7404,7 @@
             <a:r>
               <a:rPr lang="en-US" sz="950" spc="100" kern="0" dirty="0">
                 <a:solidFill>
-                  <a:srgbClr val="7E8492"/>
+                  <a:srgbClr val="8A90A0"/>
                 </a:solidFill>
                 <a:latin typeface="Courier New" pitchFamily="34" charset="0"/>
                 <a:ea typeface="Courier New" pitchFamily="34" charset="-122"/>
@@ -7552,6 +7552,126 @@
           <a:p>
             <a:pPr indent="0" marL="0">
               <a:lnSpc>
+                <a:spcPts val="2300"/>
+              </a:lnSpc>
+              <a:buNone/>
+            </a:pPr>
+            <a:r>
+              <a:rPr lang="en-US" sz="1600" dirty="0">
+                <a:solidFill>
+                  <a:srgbClr val="A8ADBA"/>
+                </a:solidFill>
+                <a:latin typeface="Public Sans" pitchFamily="34" charset="0"/>
+                <a:ea typeface="Public Sans" pitchFamily="34" charset="-122"/>
+                <a:cs typeface="Public Sans" pitchFamily="34" charset="-120"/>
+              </a:rPr>
+              <a:t>You have made one of everything. Nothing after today is a new kind of thing.</a:t>
+            </a:r>
+            <a:endParaRPr lang="en-US" sz="1600" dirty="0"/>
+          </a:p>
+        </p:txBody>
+      </p:sp>
+      <p:sp>
+        <p:nvSpPr>
+          <p:cNvPr id="5" name="Text 3"/>
+          <p:cNvSpPr txBox="1"/>
+          <p:nvPr/>
+        </p:nvSpPr>
+        <p:spPr>
+          <a:xfrm>
+            <a:off x="777240" y="2496312"/>
+            <a:ext cx="365760" cy="594360"/>
+          </a:xfrm>
+          <a:prstGeom prst="rect">
+            <a:avLst/>
+          </a:prstGeom>
+          <a:noFill/>
+          <a:ln/>
+        </p:spPr>
+        <p:txBody>
+          <a:bodyPr wrap="square" lIns="0" tIns="0" rIns="0" bIns="0" rtlCol="0" anchor="ctr"/>
+          <a:lstStyle/>
+          <a:p>
+            <a:pPr indent="0" marL="0">
+              <a:buNone/>
+            </a:pPr>
+            <a:r>
+              <a:rPr lang="en-US" sz="1600" b="1" dirty="0">
+                <a:solidFill>
+                  <a:srgbClr val="A59CFF"/>
+                </a:solidFill>
+                <a:latin typeface="Public Sans" pitchFamily="34" charset="0"/>
+                <a:ea typeface="Public Sans" pitchFamily="34" charset="-122"/>
+                <a:cs typeface="Public Sans" pitchFamily="34" charset="-120"/>
+              </a:rPr>
+              <a:t>—</a:t>
+            </a:r>
+            <a:endParaRPr lang="en-US" sz="1600" dirty="0"/>
+          </a:p>
+        </p:txBody>
+      </p:sp>
+      <p:sp>
+        <p:nvSpPr>
+          <p:cNvPr id="6" name="Text 4"/>
+          <p:cNvSpPr txBox="1"/>
+          <p:nvPr/>
+        </p:nvSpPr>
+        <p:spPr>
+          <a:xfrm>
+            <a:off x="1234440" y="2496312"/>
+            <a:ext cx="4206240" cy="594360"/>
+          </a:xfrm>
+          <a:prstGeom prst="rect">
+            <a:avLst/>
+          </a:prstGeom>
+          <a:noFill/>
+          <a:ln/>
+        </p:spPr>
+        <p:txBody>
+          <a:bodyPr wrap="square" lIns="0" tIns="0" rIns="0" bIns="0" rtlCol="0" anchor="ctr"/>
+          <a:lstStyle/>
+          <a:p>
+            <a:pPr indent="0" marL="0">
+              <a:buNone/>
+            </a:pPr>
+            <a:r>
+              <a:rPr lang="en-US" sz="1600" b="1" dirty="0">
+                <a:solidFill>
+                  <a:srgbClr val="FFFFFF"/>
+                </a:solidFill>
+                <a:latin typeface="Public Sans" pitchFamily="34" charset="0"/>
+                <a:ea typeface="Public Sans" pitchFamily="34" charset="-122"/>
+                <a:cs typeface="Public Sans" pitchFamily="34" charset="-120"/>
+              </a:rPr>
+              <a:t>Another department</a:t>
+            </a:r>
+            <a:endParaRPr lang="en-US" sz="1600" dirty="0"/>
+          </a:p>
+        </p:txBody>
+      </p:sp>
+      <p:sp>
+        <p:nvSpPr>
+          <p:cNvPr id="7" name="Text 5"/>
+          <p:cNvSpPr txBox="1"/>
+          <p:nvPr/>
+        </p:nvSpPr>
+        <p:spPr>
+          <a:xfrm>
+            <a:off x="5623560" y="2496312"/>
+            <a:ext cx="5760720" cy="594360"/>
+          </a:xfrm>
+          <a:prstGeom prst="rect">
+            <a:avLst/>
+          </a:prstGeom>
+          <a:noFill/>
+          <a:ln/>
+        </p:spPr>
+        <p:txBody>
+          <a:bodyPr wrap="square" lIns="0" tIns="0" rIns="0" bIns="0" rtlCol="0" anchor="ctr"/>
+          <a:lstStyle/>
+          <a:p>
+            <a:pPr indent="0" marL="0">
+              <a:lnSpc>
                 <a:spcPts val="2100"/>
               </a:lnSpc>
               <a:buNone/>
@@ -7565,129 +7685,9 @@
                 <a:ea typeface="Public Sans" pitchFamily="34" charset="-122"/>
                 <a:cs typeface="Public Sans" pitchFamily="34" charset="-120"/>
               </a:rPr>
-              <a:t>You have now made one of everything. Nothing you add after today is a new kind of thing to learn.</a:t>
+              <a:t>The moment you notice a part of your job nobody answers for.</a:t>
             </a:r>
             <a:endParaRPr lang="en-US" sz="1500" dirty="0"/>
-          </a:p>
-        </p:txBody>
-      </p:sp>
-      <p:sp>
-        <p:nvSpPr>
-          <p:cNvPr id="5" name="Text 3"/>
-          <p:cNvSpPr txBox="1"/>
-          <p:nvPr/>
-        </p:nvSpPr>
-        <p:spPr>
-          <a:xfrm>
-            <a:off x="777240" y="2496312"/>
-            <a:ext cx="365760" cy="594360"/>
-          </a:xfrm>
-          <a:prstGeom prst="rect">
-            <a:avLst/>
-          </a:prstGeom>
-          <a:noFill/>
-          <a:ln/>
-        </p:spPr>
-        <p:txBody>
-          <a:bodyPr wrap="square" lIns="0" tIns="0" rIns="0" bIns="0" rtlCol="0" anchor="ctr"/>
-          <a:lstStyle/>
-          <a:p>
-            <a:pPr indent="0" marL="0">
-              <a:buNone/>
-            </a:pPr>
-            <a:r>
-              <a:rPr lang="en-US" sz="1600" b="1" dirty="0">
-                <a:solidFill>
-                  <a:srgbClr val="7367F0"/>
-                </a:solidFill>
-                <a:latin typeface="Public Sans" pitchFamily="34" charset="0"/>
-                <a:ea typeface="Public Sans" pitchFamily="34" charset="-122"/>
-                <a:cs typeface="Public Sans" pitchFamily="34" charset="-120"/>
-              </a:rPr>
-              <a:t>—</a:t>
-            </a:r>
-            <a:endParaRPr lang="en-US" sz="1600" dirty="0"/>
-          </a:p>
-        </p:txBody>
-      </p:sp>
-      <p:sp>
-        <p:nvSpPr>
-          <p:cNvPr id="6" name="Text 4"/>
-          <p:cNvSpPr txBox="1"/>
-          <p:nvPr/>
-        </p:nvSpPr>
-        <p:spPr>
-          <a:xfrm>
-            <a:off x="1234440" y="2496312"/>
-            <a:ext cx="4206240" cy="594360"/>
-          </a:xfrm>
-          <a:prstGeom prst="rect">
-            <a:avLst/>
-          </a:prstGeom>
-          <a:noFill/>
-          <a:ln/>
-        </p:spPr>
-        <p:txBody>
-          <a:bodyPr wrap="square" lIns="0" tIns="0" rIns="0" bIns="0" rtlCol="0" anchor="ctr"/>
-          <a:lstStyle/>
-          <a:p>
-            <a:pPr indent="0" marL="0">
-              <a:buNone/>
-            </a:pPr>
-            <a:r>
-              <a:rPr lang="en-US" sz="1600" b="1" dirty="0">
-                <a:solidFill>
-                  <a:srgbClr val="FFFFFF"/>
-                </a:solidFill>
-                <a:latin typeface="Public Sans" pitchFamily="34" charset="0"/>
-                <a:ea typeface="Public Sans" pitchFamily="34" charset="-122"/>
-                <a:cs typeface="Public Sans" pitchFamily="34" charset="-120"/>
-              </a:rPr>
-              <a:t>Another department</a:t>
-            </a:r>
-            <a:endParaRPr lang="en-US" sz="1600" dirty="0"/>
-          </a:p>
-        </p:txBody>
-      </p:sp>
-      <p:sp>
-        <p:nvSpPr>
-          <p:cNvPr id="7" name="Text 5"/>
-          <p:cNvSpPr txBox="1"/>
-          <p:nvPr/>
-        </p:nvSpPr>
-        <p:spPr>
-          <a:xfrm>
-            <a:off x="5623560" y="2496312"/>
-            <a:ext cx="5760720" cy="594360"/>
-          </a:xfrm>
-          <a:prstGeom prst="rect">
-            <a:avLst/>
-          </a:prstGeom>
-          <a:noFill/>
-          <a:ln/>
-        </p:spPr>
-        <p:txBody>
-          <a:bodyPr wrap="square" lIns="0" tIns="0" rIns="0" bIns="0" rtlCol="0" anchor="ctr"/>
-          <a:lstStyle/>
-          <a:p>
-            <a:pPr indent="0" marL="0">
-              <a:lnSpc>
-                <a:spcPts val="1900"/>
-              </a:lnSpc>
-              <a:buNone/>
-            </a:pPr>
-            <a:r>
-              <a:rPr lang="en-US" sz="1350" dirty="0">
-                <a:solidFill>
-                  <a:srgbClr val="A8ADBA"/>
-                </a:solidFill>
-                <a:latin typeface="Public Sans" pitchFamily="34" charset="0"/>
-                <a:ea typeface="Public Sans" pitchFamily="34" charset="-122"/>
-                <a:cs typeface="Public Sans" pitchFamily="34" charset="-120"/>
-              </a:rPr>
-              <a:t>The moment you notice a part of your job nobody answers for.</a:t>
-            </a:r>
-            <a:endParaRPr lang="en-US" sz="1350" dirty="0"/>
           </a:p>
         </p:txBody>
       </p:sp>
@@ -7718,7 +7718,7 @@
             <a:r>
               <a:rPr lang="en-US" sz="1600" b="1" dirty="0">
                 <a:solidFill>
-                  <a:srgbClr val="7367F0"/>
+                  <a:srgbClr val="A59CFF"/>
                 </a:solidFill>
                 <a:latin typeface="Public Sans" pitchFamily="34" charset="0"/>
                 <a:ea typeface="Public Sans" pitchFamily="34" charset="-122"/>
@@ -7792,12 +7792,12 @@
           <a:p>
             <a:pPr indent="0" marL="0">
               <a:lnSpc>
-                <a:spcPts val="1900"/>
+                <a:spcPts val="2100"/>
               </a:lnSpc>
               <a:buNone/>
             </a:pPr>
             <a:r>
-              <a:rPr lang="en-US" sz="1350" dirty="0">
+              <a:rPr lang="en-US" sz="1500" dirty="0">
                 <a:solidFill>
                   <a:srgbClr val="A8ADBA"/>
                 </a:solidFill>
@@ -7807,7 +7807,7 @@
               </a:rPr>
               <a:t>The second time one job goes wrong the same way.</a:t>
             </a:r>
-            <a:endParaRPr lang="en-US" sz="1350" dirty="0"/>
+            <a:endParaRPr lang="en-US" sz="1500" dirty="0"/>
           </a:p>
         </p:txBody>
       </p:sp>
@@ -7838,7 +7838,7 @@
             <a:r>
               <a:rPr lang="en-US" sz="1600" b="1" dirty="0">
                 <a:solidFill>
-                  <a:srgbClr val="7367F0"/>
+                  <a:srgbClr val="A59CFF"/>
                 </a:solidFill>
                 <a:latin typeface="Public Sans" pitchFamily="34" charset="0"/>
                 <a:ea typeface="Public Sans" pitchFamily="34" charset="-122"/>
@@ -7912,12 +7912,12 @@
           <a:p>
             <a:pPr indent="0" marL="0">
               <a:lnSpc>
-                <a:spcPts val="1900"/>
+                <a:spcPts val="2100"/>
               </a:lnSpc>
               <a:buNone/>
             </a:pPr>
             <a:r>
-              <a:rPr lang="en-US" sz="1350" dirty="0">
+              <a:rPr lang="en-US" sz="1500" dirty="0">
                 <a:solidFill>
                   <a:srgbClr val="A8ADBA"/>
                 </a:solidFill>
@@ -7927,7 +7927,7 @@
               </a:rPr>
               <a:t>The second time you explain the same thing.</a:t>
             </a:r>
-            <a:endParaRPr lang="en-US" sz="1350" dirty="0"/>
+            <a:endParaRPr lang="en-US" sz="1500" dirty="0"/>
           </a:p>
         </p:txBody>
       </p:sp>
@@ -7958,7 +7958,7 @@
             <a:r>
               <a:rPr lang="en-US" sz="1600" b="1" dirty="0">
                 <a:solidFill>
-                  <a:srgbClr val="7367F0"/>
+                  <a:srgbClr val="A59CFF"/>
                 </a:solidFill>
                 <a:latin typeface="Public Sans" pitchFamily="34" charset="0"/>
                 <a:ea typeface="Public Sans" pitchFamily="34" charset="-122"/>
@@ -8032,12 +8032,12 @@
           <a:p>
             <a:pPr indent="0" marL="0">
               <a:lnSpc>
-                <a:spcPts val="1900"/>
+                <a:spcPts val="2100"/>
               </a:lnSpc>
               <a:buNone/>
             </a:pPr>
             <a:r>
-              <a:rPr lang="en-US" sz="1350" dirty="0">
+              <a:rPr lang="en-US" sz="1500" dirty="0">
                 <a:solidFill>
                   <a:srgbClr val="A8ADBA"/>
                 </a:solidFill>
@@ -8047,7 +8047,7 @@
               </a:rPr>
               <a:t>When you want the week closed on Friday without being asked.</a:t>
             </a:r>
-            <a:endParaRPr lang="en-US" sz="1350" dirty="0"/>
+            <a:endParaRPr lang="en-US" sz="1500" dirty="0"/>
           </a:p>
         </p:txBody>
       </p:sp>
@@ -8315,6 +8315,126 @@
           <a:p>
             <a:pPr indent="0" marL="0">
               <a:lnSpc>
+                <a:spcPts val="2300"/>
+              </a:lnSpc>
+              <a:buNone/>
+            </a:pPr>
+            <a:r>
+              <a:rPr lang="en-US" sz="1600" dirty="0">
+                <a:solidFill>
+                  <a:srgbClr val="A8ADBA"/>
+                </a:solidFill>
+                <a:latin typeface="Public Sans" pitchFamily="34" charset="0"/>
+                <a:ea typeface="Public Sans" pitchFamily="34" charset="-122"/>
+                <a:cs typeface="Public Sans" pitchFamily="34" charset="-120"/>
+              </a:rPr>
+              <a:t>Four things. Three of them you already have.</a:t>
+            </a:r>
+            <a:endParaRPr lang="en-US" sz="1600" dirty="0"/>
+          </a:p>
+        </p:txBody>
+      </p:sp>
+      <p:sp>
+        <p:nvSpPr>
+          <p:cNvPr id="6" name="Text 3"/>
+          <p:cNvSpPr txBox="1"/>
+          <p:nvPr/>
+        </p:nvSpPr>
+        <p:spPr>
+          <a:xfrm>
+            <a:off x="777240" y="2423160"/>
+            <a:ext cx="365760" cy="640080"/>
+          </a:xfrm>
+          <a:prstGeom prst="rect">
+            <a:avLst/>
+          </a:prstGeom>
+          <a:noFill/>
+          <a:ln/>
+        </p:spPr>
+        <p:txBody>
+          <a:bodyPr wrap="square" lIns="0" tIns="0" rIns="0" bIns="0" rtlCol="0" anchor="ctr"/>
+          <a:lstStyle/>
+          <a:p>
+            <a:pPr indent="0" marL="0">
+              <a:buNone/>
+            </a:pPr>
+            <a:r>
+              <a:rPr lang="en-US" sz="1600" b="1" dirty="0">
+                <a:solidFill>
+                  <a:srgbClr val="A59CFF"/>
+                </a:solidFill>
+                <a:latin typeface="Public Sans" pitchFamily="34" charset="0"/>
+                <a:ea typeface="Public Sans" pitchFamily="34" charset="-122"/>
+                <a:cs typeface="Public Sans" pitchFamily="34" charset="-120"/>
+              </a:rPr>
+              <a:t>—</a:t>
+            </a:r>
+            <a:endParaRPr lang="en-US" sz="1600" dirty="0"/>
+          </a:p>
+        </p:txBody>
+      </p:sp>
+      <p:sp>
+        <p:nvSpPr>
+          <p:cNvPr id="7" name="Text 4"/>
+          <p:cNvSpPr txBox="1"/>
+          <p:nvPr/>
+        </p:nvSpPr>
+        <p:spPr>
+          <a:xfrm>
+            <a:off x="1234440" y="2423160"/>
+            <a:ext cx="4023360" cy="640080"/>
+          </a:xfrm>
+          <a:prstGeom prst="rect">
+            <a:avLst/>
+          </a:prstGeom>
+          <a:noFill/>
+          <a:ln/>
+        </p:spPr>
+        <p:txBody>
+          <a:bodyPr wrap="square" lIns="0" tIns="0" rIns="0" bIns="0" rtlCol="0" anchor="ctr"/>
+          <a:lstStyle/>
+          <a:p>
+            <a:pPr indent="0" marL="0">
+              <a:buNone/>
+            </a:pPr>
+            <a:r>
+              <a:rPr lang="en-US" sz="1700" b="1" dirty="0">
+                <a:solidFill>
+                  <a:srgbClr val="FFFFFF"/>
+                </a:solidFill>
+                <a:latin typeface="Public Sans" pitchFamily="34" charset="0"/>
+                <a:ea typeface="Public Sans" pitchFamily="34" charset="-122"/>
+                <a:cs typeface="Public Sans" pitchFamily="34" charset="-120"/>
+              </a:rPr>
+              <a:t>Claude, on your laptop</a:t>
+            </a:r>
+            <a:endParaRPr lang="en-US" sz="1700" dirty="0"/>
+          </a:p>
+        </p:txBody>
+      </p:sp>
+      <p:sp>
+        <p:nvSpPr>
+          <p:cNvPr id="8" name="Text 5"/>
+          <p:cNvSpPr txBox="1"/>
+          <p:nvPr/>
+        </p:nvSpPr>
+        <p:spPr>
+          <a:xfrm>
+            <a:off x="5440680" y="2423160"/>
+            <a:ext cx="5943600" cy="640080"/>
+          </a:xfrm>
+          <a:prstGeom prst="rect">
+            <a:avLst/>
+          </a:prstGeom>
+          <a:noFill/>
+          <a:ln/>
+        </p:spPr>
+        <p:txBody>
+          <a:bodyPr wrap="square" lIns="0" tIns="0" rIns="0" bIns="0" rtlCol="0" anchor="ctr"/>
+          <a:lstStyle/>
+          <a:p>
+            <a:pPr indent="0" marL="0">
+              <a:lnSpc>
                 <a:spcPts val="2100"/>
               </a:lnSpc>
               <a:buNone/>
@@ -8328,129 +8448,9 @@
                 <a:ea typeface="Public Sans" pitchFamily="34" charset="-122"/>
                 <a:cs typeface="Public Sans" pitchFamily="34" charset="-120"/>
               </a:rPr>
-              <a:t>Four things. Three of them you already have.</a:t>
+              <a:t>The desktop app, signed in.</a:t>
             </a:r>
             <a:endParaRPr lang="en-US" sz="1500" dirty="0"/>
-          </a:p>
-        </p:txBody>
-      </p:sp>
-      <p:sp>
-        <p:nvSpPr>
-          <p:cNvPr id="6" name="Text 3"/>
-          <p:cNvSpPr txBox="1"/>
-          <p:nvPr/>
-        </p:nvSpPr>
-        <p:spPr>
-          <a:xfrm>
-            <a:off x="777240" y="2423160"/>
-            <a:ext cx="365760" cy="640080"/>
-          </a:xfrm>
-          <a:prstGeom prst="rect">
-            <a:avLst/>
-          </a:prstGeom>
-          <a:noFill/>
-          <a:ln/>
-        </p:spPr>
-        <p:txBody>
-          <a:bodyPr wrap="square" lIns="0" tIns="0" rIns="0" bIns="0" rtlCol="0" anchor="ctr"/>
-          <a:lstStyle/>
-          <a:p>
-            <a:pPr indent="0" marL="0">
-              <a:buNone/>
-            </a:pPr>
-            <a:r>
-              <a:rPr lang="en-US" sz="1600" b="1" dirty="0">
-                <a:solidFill>
-                  <a:srgbClr val="7367F0"/>
-                </a:solidFill>
-                <a:latin typeface="Public Sans" pitchFamily="34" charset="0"/>
-                <a:ea typeface="Public Sans" pitchFamily="34" charset="-122"/>
-                <a:cs typeface="Public Sans" pitchFamily="34" charset="-120"/>
-              </a:rPr>
-              <a:t>—</a:t>
-            </a:r>
-            <a:endParaRPr lang="en-US" sz="1600" dirty="0"/>
-          </a:p>
-        </p:txBody>
-      </p:sp>
-      <p:sp>
-        <p:nvSpPr>
-          <p:cNvPr id="7" name="Text 4"/>
-          <p:cNvSpPr txBox="1"/>
-          <p:nvPr/>
-        </p:nvSpPr>
-        <p:spPr>
-          <a:xfrm>
-            <a:off x="1234440" y="2423160"/>
-            <a:ext cx="4023360" cy="640080"/>
-          </a:xfrm>
-          <a:prstGeom prst="rect">
-            <a:avLst/>
-          </a:prstGeom>
-          <a:noFill/>
-          <a:ln/>
-        </p:spPr>
-        <p:txBody>
-          <a:bodyPr wrap="square" lIns="0" tIns="0" rIns="0" bIns="0" rtlCol="0" anchor="ctr"/>
-          <a:lstStyle/>
-          <a:p>
-            <a:pPr indent="0" marL="0">
-              <a:buNone/>
-            </a:pPr>
-            <a:r>
-              <a:rPr lang="en-US" sz="1700" b="1" dirty="0">
-                <a:solidFill>
-                  <a:srgbClr val="FFFFFF"/>
-                </a:solidFill>
-                <a:latin typeface="Public Sans" pitchFamily="34" charset="0"/>
-                <a:ea typeface="Public Sans" pitchFamily="34" charset="-122"/>
-                <a:cs typeface="Public Sans" pitchFamily="34" charset="-120"/>
-              </a:rPr>
-              <a:t>Claude, on your laptop</a:t>
-            </a:r>
-            <a:endParaRPr lang="en-US" sz="1700" dirty="0"/>
-          </a:p>
-        </p:txBody>
-      </p:sp>
-      <p:sp>
-        <p:nvSpPr>
-          <p:cNvPr id="8" name="Text 5"/>
-          <p:cNvSpPr txBox="1"/>
-          <p:nvPr/>
-        </p:nvSpPr>
-        <p:spPr>
-          <a:xfrm>
-            <a:off x="5440680" y="2423160"/>
-            <a:ext cx="5943600" cy="640080"/>
-          </a:xfrm>
-          <a:prstGeom prst="rect">
-            <a:avLst/>
-          </a:prstGeom>
-          <a:noFill/>
-          <a:ln/>
-        </p:spPr>
-        <p:txBody>
-          <a:bodyPr wrap="square" lIns="0" tIns="0" rIns="0" bIns="0" rtlCol="0" anchor="ctr"/>
-          <a:lstStyle/>
-          <a:p>
-            <a:pPr indent="0" marL="0">
-              <a:lnSpc>
-                <a:spcPts val="1900"/>
-              </a:lnSpc>
-              <a:buNone/>
-            </a:pPr>
-            <a:r>
-              <a:rPr lang="en-US" sz="1350" dirty="0">
-                <a:solidFill>
-                  <a:srgbClr val="A8ADBA"/>
-                </a:solidFill>
-                <a:latin typeface="Public Sans" pitchFamily="34" charset="0"/>
-                <a:ea typeface="Public Sans" pitchFamily="34" charset="-122"/>
-                <a:cs typeface="Public Sans" pitchFamily="34" charset="-120"/>
-              </a:rPr>
-              <a:t>The desktop app, signed in. This is where every step happens.</a:t>
-            </a:r>
-            <a:endParaRPr lang="en-US" sz="1350" dirty="0"/>
           </a:p>
         </p:txBody>
       </p:sp>
@@ -8481,7 +8481,7 @@
             <a:r>
               <a:rPr lang="en-US" sz="1600" b="1" dirty="0">
                 <a:solidFill>
-                  <a:srgbClr val="7367F0"/>
+                  <a:srgbClr val="A59CFF"/>
                 </a:solidFill>
                 <a:latin typeface="Public Sans" pitchFamily="34" charset="0"/>
                 <a:ea typeface="Public Sans" pitchFamily="34" charset="-122"/>
@@ -8555,12 +8555,12 @@
           <a:p>
             <a:pPr indent="0" marL="0">
               <a:lnSpc>
-                <a:spcPts val="1900"/>
+                <a:spcPts val="2100"/>
               </a:lnSpc>
               <a:buNone/>
             </a:pPr>
             <a:r>
-              <a:rPr lang="en-US" sz="1350" dirty="0">
+              <a:rPr lang="en-US" sz="1500" dirty="0">
                 <a:solidFill>
                   <a:srgbClr val="A8ADBA"/>
                 </a:solidFill>
@@ -8568,9 +8568,9 @@
                 <a:ea typeface="Public Sans" pitchFamily="34" charset="-122"/>
                 <a:cs typeface="Public Sans" pitchFamily="34" charset="-120"/>
               </a:rPr>
-              <a:t>Free, five minutes to install. It is how you read and edit your vault — and creating the vault makes the folder for you.</a:t>
-            </a:r>
-            <a:endParaRPr lang="en-US" sz="1350" dirty="0"/>
+              <a:t>Free, five minutes. It reads your vault — and creates the folder for you.</a:t>
+            </a:r>
+            <a:endParaRPr lang="en-US" sz="1500" dirty="0"/>
           </a:p>
         </p:txBody>
       </p:sp>
@@ -8601,7 +8601,7 @@
             <a:r>
               <a:rPr lang="en-US" sz="1600" b="1" dirty="0">
                 <a:solidFill>
-                  <a:srgbClr val="7367F0"/>
+                  <a:srgbClr val="A59CFF"/>
                 </a:solidFill>
                 <a:latin typeface="Public Sans" pitchFamily="34" charset="0"/>
                 <a:ea typeface="Public Sans" pitchFamily="34" charset="-122"/>
@@ -8675,12 +8675,12 @@
           <a:p>
             <a:pPr indent="0" marL="0">
               <a:lnSpc>
-                <a:spcPts val="1900"/>
+                <a:spcPts val="2100"/>
               </a:lnSpc>
               <a:buNone/>
             </a:pPr>
             <a:r>
-              <a:rPr lang="en-US" sz="1350" dirty="0">
+              <a:rPr lang="en-US" sz="1500" dirty="0">
                 <a:solidFill>
                   <a:srgbClr val="A8ADBA"/>
                 </a:solidFill>
@@ -8688,9 +8688,9 @@
                 <a:ea typeface="Public Sans" pitchFamily="34" charset="-122"/>
                 <a:cs typeface="Public Sans" pitchFamily="34" charset="-120"/>
               </a:rPr>
-              <a:t>C:\AI is a good home. Nothing to create yet; step one does it.</a:t>
-            </a:r>
-            <a:endParaRPr lang="en-US" sz="1350" dirty="0"/>
+              <a:t>C:\AI is a good home. Nothing to create yet.</a:t>
+            </a:r>
+            <a:endParaRPr lang="en-US" sz="1500" dirty="0"/>
           </a:p>
         </p:txBody>
       </p:sp>
@@ -8721,7 +8721,7 @@
             <a:r>
               <a:rPr lang="en-US" sz="1600" b="1" dirty="0">
                 <a:solidFill>
-                  <a:srgbClr val="7367F0"/>
+                  <a:srgbClr val="A59CFF"/>
                 </a:solidFill>
                 <a:latin typeface="Public Sans" pitchFamily="34" charset="0"/>
                 <a:ea typeface="Public Sans" pitchFamily="34" charset="-122"/>
@@ -8795,12 +8795,12 @@
           <a:p>
             <a:pPr indent="0" marL="0">
               <a:lnSpc>
-                <a:spcPts val="1900"/>
+                <a:spcPts val="2100"/>
               </a:lnSpc>
               <a:buNone/>
             </a:pPr>
             <a:r>
-              <a:rPr lang="en-US" sz="1350" dirty="0">
+              <a:rPr lang="en-US" sz="1500" dirty="0">
                 <a:solidFill>
                   <a:srgbClr val="A8ADBA"/>
                 </a:solidFill>
@@ -8808,9 +8808,9 @@
                 <a:ea typeface="Public Sans" pitchFamily="34" charset="-122"/>
                 <a:cs typeface="Public Sans" pitchFamily="34" charset="-120"/>
               </a:rPr>
-              <a:t>No Python, no terminal, no account to create, no plugin to buy.</a:t>
-            </a:r>
-            <a:endParaRPr lang="en-US" sz="1350" dirty="0"/>
+              <a:t>No Python, no terminal, no account, no plugin.</a:t>
+            </a:r>
+            <a:endParaRPr lang="en-US" sz="1500" dirty="0"/>
           </a:p>
         </p:txBody>
       </p:sp>
@@ -8841,7 +8841,7 @@
             <a:r>
               <a:rPr lang="en-US" sz="950" spc="100" kern="0" dirty="0">
                 <a:solidFill>
-                  <a:srgbClr val="7E8492"/>
+                  <a:srgbClr val="8A90A0"/>
                 </a:solidFill>
                 <a:latin typeface="Courier New" pitchFamily="34" charset="0"/>
                 <a:ea typeface="Courier New" pitchFamily="34" charset="-122"/>
@@ -8912,7 +8912,7 @@
             <a:r>
               <a:rPr lang="en-US" sz="1100" spc="200" kern="0" dirty="0">
                 <a:solidFill>
-                  <a:srgbClr val="7367F0"/>
+                  <a:srgbClr val="6055D8"/>
                 </a:solidFill>
                 <a:latin typeface="Courier New" pitchFamily="34" charset="0"/>
                 <a:ea typeface="Courier New" pitchFamily="34" charset="-122"/>
@@ -9013,12 +9013,12 @@
           <a:p>
             <a:pPr indent="0" marL="0">
               <a:lnSpc>
-                <a:spcPts val="2100"/>
+                <a:spcPts val="2300"/>
               </a:lnSpc>
               <a:buNone/>
             </a:pPr>
             <a:r>
-              <a:rPr lang="en-US" sz="1500" dirty="0">
+              <a:rPr lang="en-US" sz="1600" dirty="0">
                 <a:solidFill>
                   <a:srgbClr val="5B6270"/>
                 </a:solidFill>
@@ -9026,9 +9026,9 @@
                 <a:ea typeface="Public Sans" pitchFamily="34" charset="-122"/>
                 <a:cs typeface="Public Sans" pitchFamily="34" charset="-120"/>
               </a:rPr>
-              <a:t>Not a demo you watched — an architecture on your own laptop, and enough of a grip on it to keep building after today.</a:t>
-            </a:r>
-            <a:endParaRPr lang="en-US" sz="1500" dirty="0"/>
+              <a:t>Not a demo you watched. An architecture on your own laptop — and the grip to keep building on it.</a:t>
+            </a:r>
+            <a:endParaRPr lang="en-US" sz="1600" dirty="0"/>
           </a:p>
         </p:txBody>
       </p:sp>
@@ -9040,12 +9040,12 @@
         </p:nvSpPr>
         <p:spPr>
           <a:xfrm>
-            <a:off x="777240" y="2651760"/>
-            <a:ext cx="3291840" cy="2114804"/>
+            <a:off x="777240" y="2880360"/>
+            <a:ext cx="3291840" cy="1943481"/>
           </a:xfrm>
           <a:prstGeom prst="roundRect">
             <a:avLst>
-              <a:gd name="adj" fmla="val 2594"/>
+              <a:gd name="adj" fmla="val 2823"/>
             </a:avLst>
           </a:prstGeom>
           <a:solidFill>
@@ -9067,7 +9067,7 @@
         </p:nvSpPr>
         <p:spPr>
           <a:xfrm>
-            <a:off x="1051560" y="2926080"/>
+            <a:off x="1051560" y="3154680"/>
             <a:ext cx="2743200" cy="518160"/>
           </a:xfrm>
           <a:prstGeom prst="rect">
@@ -9109,8 +9109,8 @@
         </p:nvSpPr>
         <p:spPr>
           <a:xfrm>
-            <a:off x="1051560" y="3572256"/>
-            <a:ext cx="2743200" cy="938276"/>
+            <a:off x="1051560" y="3800856"/>
+            <a:ext cx="2743200" cy="766953"/>
           </a:xfrm>
           <a:prstGeom prst="rect">
             <a:avLst/>
@@ -9124,12 +9124,12 @@
           <a:p>
             <a:pPr indent="0" marL="0">
               <a:lnSpc>
-                <a:spcPts val="1775"/>
+                <a:spcPts val="1917"/>
               </a:lnSpc>
               <a:buNone/>
             </a:pPr>
             <a:r>
-              <a:rPr lang="en-US" sz="1250" dirty="0">
+              <a:rPr lang="en-US" sz="1350" dirty="0">
                 <a:solidFill>
                   <a:srgbClr val="5B6270"/>
                 </a:solidFill>
@@ -9137,9 +9137,9 @@
                 <a:ea typeface="Public Sans" pitchFamily="34" charset="-122"/>
                 <a:cs typeface="Public Sans" pitchFamily="34" charset="-120"/>
               </a:rPr>
-              <a:t>Accounts, promises, half-finished drafts — written once, in plain text you own, instead of re-typed into a chat window every morning.</a:t>
-            </a:r>
-            <a:endParaRPr lang="en-US" sz="1250" dirty="0"/>
+              <a:t>Written once, in plain text you own. Not re-typed into a chat window every morning.</a:t>
+            </a:r>
+            <a:endParaRPr lang="en-US" sz="1350" dirty="0"/>
           </a:p>
         </p:txBody>
       </p:sp>
@@ -9151,12 +9151,12 @@
         </p:nvSpPr>
         <p:spPr>
           <a:xfrm>
-            <a:off x="4434840" y="2651760"/>
-            <a:ext cx="3291840" cy="2114804"/>
+            <a:off x="4434840" y="2880360"/>
+            <a:ext cx="3291840" cy="1943481"/>
           </a:xfrm>
           <a:prstGeom prst="roundRect">
             <a:avLst>
-              <a:gd name="adj" fmla="val 2594"/>
+              <a:gd name="adj" fmla="val 2823"/>
             </a:avLst>
           </a:prstGeom>
           <a:solidFill>
@@ -9178,7 +9178,7 @@
         </p:nvSpPr>
         <p:spPr>
           <a:xfrm>
-            <a:off x="4709160" y="2926080"/>
+            <a:off x="4709160" y="3154680"/>
             <a:ext cx="2743200" cy="518160"/>
           </a:xfrm>
           <a:prstGeom prst="rect">
@@ -9220,8 +9220,8 @@
         </p:nvSpPr>
         <p:spPr>
           <a:xfrm>
-            <a:off x="4709160" y="3572256"/>
-            <a:ext cx="2743200" cy="938276"/>
+            <a:off x="4709160" y="3800856"/>
+            <a:ext cx="2743200" cy="766953"/>
           </a:xfrm>
           <a:prstGeom prst="rect">
             <a:avLst/>
@@ -9235,12 +9235,12 @@
           <a:p>
             <a:pPr indent="0" marL="0">
               <a:lnSpc>
-                <a:spcPts val="1775"/>
+                <a:spcPts val="1917"/>
               </a:lnSpc>
               <a:buNone/>
             </a:pPr>
             <a:r>
-              <a:rPr lang="en-US" sz="1250" dirty="0">
+              <a:rPr lang="en-US" sz="1350" dirty="0">
                 <a:solidFill>
                   <a:srgbClr val="5B6270"/>
                 </a:solidFill>
@@ -9248,9 +9248,9 @@
                 <a:ea typeface="Public Sans" pitchFamily="34" charset="-122"/>
                 <a:cs typeface="Public Sans" pitchFamily="34" charset="-120"/>
               </a:rPr>
-              <a:t>Departments for the parts of your job, an executive answering for each, specialists under them, and skills that hold your method.</a:t>
-            </a:r>
-            <a:endParaRPr lang="en-US" sz="1250" dirty="0"/>
+              <a:t>Departments for the parts of your job. An executive answering for each, specialists under them.</a:t>
+            </a:r>
+            <a:endParaRPr lang="en-US" sz="1350" dirty="0"/>
           </a:p>
         </p:txBody>
       </p:sp>
@@ -9262,12 +9262,12 @@
         </p:nvSpPr>
         <p:spPr>
           <a:xfrm>
-            <a:off x="8092440" y="2651760"/>
-            <a:ext cx="3291840" cy="2114804"/>
+            <a:off x="8092440" y="2880360"/>
+            <a:ext cx="3291840" cy="1943481"/>
           </a:xfrm>
           <a:prstGeom prst="roundRect">
             <a:avLst>
-              <a:gd name="adj" fmla="val 2594"/>
+              <a:gd name="adj" fmla="val 2823"/>
             </a:avLst>
           </a:prstGeom>
           <a:solidFill>
@@ -9289,7 +9289,7 @@
         </p:nvSpPr>
         <p:spPr>
           <a:xfrm>
-            <a:off x="8366760" y="2926080"/>
+            <a:off x="8366760" y="3154680"/>
             <a:ext cx="2743200" cy="259080"/>
           </a:xfrm>
           <a:prstGeom prst="rect">
@@ -9331,8 +9331,8 @@
         </p:nvSpPr>
         <p:spPr>
           <a:xfrm>
-            <a:off x="8366760" y="3313176"/>
-            <a:ext cx="2743200" cy="1197356"/>
+            <a:off x="8366760" y="3541776"/>
+            <a:ext cx="2743200" cy="1026033"/>
           </a:xfrm>
           <a:prstGeom prst="rect">
             <a:avLst/>
@@ -9346,12 +9346,12 @@
           <a:p>
             <a:pPr indent="0" marL="0">
               <a:lnSpc>
-                <a:spcPts val="1775"/>
+                <a:spcPts val="1917"/>
               </a:lnSpc>
               <a:buNone/>
             </a:pPr>
             <a:r>
-              <a:rPr lang="en-US" sz="1250" dirty="0">
+              <a:rPr lang="en-US" sz="1350" dirty="0">
                 <a:solidFill>
                   <a:srgbClr val="5B6270"/>
                 </a:solidFill>
@@ -9359,9 +9359,9 @@
                 <a:ea typeface="Public Sans" pitchFamily="34" charset="-122"/>
                 <a:cs typeface="Public Sans" pitchFamily="34" charset="-120"/>
               </a:rPr>
-              <a:t>Agents, skills, workflows, projects, schedules. You will have made one of each by the end, so the next one is just more of the same.</a:t>
-            </a:r>
-            <a:endParaRPr lang="en-US" sz="1250" dirty="0"/>
+              <a:t>Agents, skills, workflows, projects. One of each by the end — so the next one is just more of the same.</a:t>
+            </a:r>
+            <a:endParaRPr lang="en-US" sz="1350" dirty="0"/>
           </a:p>
         </p:txBody>
       </p:sp>
@@ -9373,7 +9373,7 @@
         </p:nvSpPr>
         <p:spPr>
           <a:xfrm>
-            <a:off x="777240" y="5669280"/>
+            <a:off x="777240" y="5281041"/>
             <a:ext cx="10607040" cy="411480"/>
           </a:xfrm>
           <a:prstGeom prst="rect">
@@ -9398,7 +9398,7 @@
                 <a:ea typeface="Public Sans" pitchFamily="34" charset="-122"/>
                 <a:cs typeface="Public Sans" pitchFamily="34" charset="-120"/>
               </a:rPr>
-              <a:t>Everything you build today is yours, on your own machine, and none of it needs us afterwards.</a:t>
+              <a:t>All of it yours, on your own machine, needing nobody afterwards.</a:t>
             </a:r>
             <a:endParaRPr lang="en-US" sz="1450" dirty="0"/>
           </a:p>
@@ -9431,7 +9431,7 @@
             <a:r>
               <a:rPr lang="en-US" sz="950" spc="100" kern="0" dirty="0">
                 <a:solidFill>
-                  <a:srgbClr val="9198A6"/>
+                  <a:srgbClr val="6B6D72"/>
                 </a:solidFill>
                 <a:latin typeface="Courier New" pitchFamily="34" charset="0"/>
                 <a:ea typeface="Courier New" pitchFamily="34" charset="-122"/>
@@ -9623,12 +9623,12 @@
           <a:p>
             <a:pPr indent="0" marL="0">
               <a:lnSpc>
-                <a:spcPts val="2100"/>
+                <a:spcPts val="2300"/>
               </a:lnSpc>
               <a:buNone/>
             </a:pPr>
             <a:r>
-              <a:rPr lang="en-US" sz="1500" dirty="0">
+              <a:rPr lang="en-US" sz="1600" dirty="0">
                 <a:solidFill>
                   <a:srgbClr val="A8ADBA"/>
                 </a:solidFill>
@@ -9636,9 +9636,9 @@
                 <a:ea typeface="Public Sans" pitchFamily="34" charset="-122"/>
                 <a:cs typeface="Public Sans" pitchFamily="34" charset="-120"/>
               </a:rPr>
-              <a:t>Your vault is not a nicer set of notes. It is a structure an LLM can read, navigate and act on — written in the shape a machine needs, which happens to also be readable by a person.</a:t>
-            </a:r>
-            <a:endParaRPr lang="en-US" sz="1500" dirty="0"/>
+              <a:t>Not a nicer set of notes — a structure an LLM can read, navigate and act on. Readable by a person is the side effect.</a:t>
+            </a:r>
+            <a:endParaRPr lang="en-US" sz="1600" dirty="0"/>
           </a:p>
         </p:txBody>
       </p:sp>
@@ -9651,11 +9651,11 @@
         <p:spPr>
           <a:xfrm>
             <a:off x="777240" y="3200400"/>
-            <a:ext cx="3291840" cy="1922907"/>
+            <a:ext cx="3291840" cy="1977009"/>
           </a:xfrm>
           <a:prstGeom prst="roundRect">
             <a:avLst>
-              <a:gd name="adj" fmla="val 2853"/>
+              <a:gd name="adj" fmla="val 2775"/>
             </a:avLst>
           </a:prstGeom>
           <a:solidFill>
@@ -9759,7 +9759,7 @@
         <p:spPr>
           <a:xfrm>
             <a:off x="1051560" y="4154424"/>
-            <a:ext cx="2743200" cy="712851"/>
+            <a:ext cx="2743200" cy="766953"/>
           </a:xfrm>
           <a:prstGeom prst="rect">
             <a:avLst/>
@@ -9773,12 +9773,12 @@
           <a:p>
             <a:pPr indent="0" marL="0">
               <a:lnSpc>
-                <a:spcPts val="1775"/>
+                <a:spcPts val="1917"/>
               </a:lnSpc>
               <a:buNone/>
             </a:pPr>
             <a:r>
-              <a:rPr lang="en-US" sz="1250" dirty="0">
+              <a:rPr lang="en-US" sz="1350" dirty="0">
                 <a:solidFill>
                   <a:srgbClr val="A8ADBA"/>
                 </a:solidFill>
@@ -9786,9 +9786,9 @@
                 <a:ea typeface="Public Sans" pitchFamily="34" charset="-122"/>
                 <a:cs typeface="Public Sans" pitchFamily="34" charset="-120"/>
               </a:rPr>
-              <a:t>So an agent never has to choose between two versions of the truth — and neither do you.</a:t>
-            </a:r>
-            <a:endParaRPr lang="en-US" sz="1250" dirty="0"/>
+              <a:t>No agent ever has to choose between two versions of the truth. Neither do you.</a:t>
+            </a:r>
+            <a:endParaRPr lang="en-US" sz="1350" dirty="0"/>
           </a:p>
         </p:txBody>
       </p:sp>
@@ -9801,11 +9801,11 @@
         <p:spPr>
           <a:xfrm>
             <a:off x="4434840" y="3200400"/>
-            <a:ext cx="3291840" cy="1922907"/>
+            <a:ext cx="3291840" cy="1977009"/>
           </a:xfrm>
           <a:prstGeom prst="roundRect">
             <a:avLst>
-              <a:gd name="adj" fmla="val 2853"/>
+              <a:gd name="adj" fmla="val 2775"/>
             </a:avLst>
           </a:prstGeom>
           <a:solidFill>
@@ -9909,7 +9909,7 @@
         <p:spPr>
           <a:xfrm>
             <a:off x="4709160" y="4154424"/>
-            <a:ext cx="2743200" cy="712851"/>
+            <a:ext cx="2743200" cy="766953"/>
           </a:xfrm>
           <a:prstGeom prst="rect">
             <a:avLst/>
@@ -9923,12 +9923,12 @@
           <a:p>
             <a:pPr indent="0" marL="0">
               <a:lnSpc>
-                <a:spcPts val="1775"/>
+                <a:spcPts val="1917"/>
               </a:lnSpc>
               <a:buNone/>
             </a:pPr>
             <a:r>
-              <a:rPr lang="en-US" sz="1250" dirty="0">
+              <a:rPr lang="en-US" sz="1350" dirty="0">
                 <a:solidFill>
                   <a:srgbClr val="A8ADBA"/>
                 </a:solidFill>
@@ -9936,9 +9936,9 @@
                 <a:ea typeface="Public Sans" pitchFamily="34" charset="-122"/>
                 <a:cs typeface="Public Sans" pitchFamily="34" charset="-120"/>
               </a:rPr>
-              <a:t>Plain-text fields it can filter, count and reason over, instead of guessing from prose.</a:t>
-            </a:r>
-            <a:endParaRPr lang="en-US" sz="1250" dirty="0"/>
+              <a:t>Fields it can filter and count, instead of guessing from prose.</a:t>
+            </a:r>
+            <a:endParaRPr lang="en-US" sz="1350" dirty="0"/>
           </a:p>
         </p:txBody>
       </p:sp>
@@ -9951,11 +9951,11 @@
         <p:spPr>
           <a:xfrm>
             <a:off x="8092440" y="3200400"/>
-            <a:ext cx="3291840" cy="1922907"/>
+            <a:ext cx="3291840" cy="1977009"/>
           </a:xfrm>
           <a:prstGeom prst="roundRect">
             <a:avLst>
-              <a:gd name="adj" fmla="val 2853"/>
+              <a:gd name="adj" fmla="val 2775"/>
             </a:avLst>
           </a:prstGeom>
           <a:solidFill>
@@ -10059,7 +10059,7 @@
         <p:spPr>
           <a:xfrm>
             <a:off x="8366760" y="4154424"/>
-            <a:ext cx="2743200" cy="712851"/>
+            <a:ext cx="2743200" cy="766953"/>
           </a:xfrm>
           <a:prstGeom prst="rect">
             <a:avLst/>
@@ -10073,12 +10073,12 @@
           <a:p>
             <a:pPr indent="0" marL="0">
               <a:lnSpc>
-                <a:spcPts val="1775"/>
+                <a:spcPts val="1917"/>
               </a:lnSpc>
               <a:buNone/>
             </a:pPr>
             <a:r>
-              <a:rPr lang="en-US" sz="1250" dirty="0">
+              <a:rPr lang="en-US" sz="1350" dirty="0">
                 <a:solidFill>
                   <a:srgbClr val="A8ADBA"/>
                 </a:solidFill>
@@ -10086,9 +10086,9 @@
                 <a:ea typeface="Public Sans" pitchFamily="34" charset="-122"/>
                 <a:cs typeface="Public Sans" pitchFamily="34" charset="-120"/>
               </a:rPr>
-              <a:t>The graph is how it finds context. Copy-paste breaks it; a link makes it navigable.</a:t>
-            </a:r>
-            <a:endParaRPr lang="en-US" sz="1250" dirty="0"/>
+              <a:t>The graph is how it finds context. Copy-paste breaks it.</a:t>
+            </a:r>
+            <a:endParaRPr lang="en-US" sz="1350" dirty="0"/>
           </a:p>
         </p:txBody>
       </p:sp>
@@ -10119,7 +10119,7 @@
             <a:r>
               <a:rPr lang="en-US" sz="950" spc="100" kern="0" dirty="0">
                 <a:solidFill>
-                  <a:srgbClr val="7E8492"/>
+                  <a:srgbClr val="8A90A0"/>
                 </a:solidFill>
                 <a:latin typeface="Courier New" pitchFamily="34" charset="0"/>
                 <a:ea typeface="Courier New" pitchFamily="34" charset="-122"/>
@@ -10190,7 +10190,7 @@
             <a:r>
               <a:rPr lang="en-US" sz="1100" spc="200" kern="0" dirty="0">
                 <a:solidFill>
-                  <a:srgbClr val="7367F0"/>
+                  <a:srgbClr val="6055D8"/>
                 </a:solidFill>
                 <a:latin typeface="Courier New" pitchFamily="34" charset="0"/>
                 <a:ea typeface="Courier New" pitchFamily="34" charset="-122"/>
@@ -10249,12 +10249,12 @@
           <a:p>
             <a:pPr indent="0" marL="0">
               <a:lnSpc>
-                <a:spcPts val="3596"/>
+                <a:spcPts val="3712"/>
               </a:lnSpc>
               <a:buNone/>
             </a:pPr>
             <a:r>
-              <a:rPr lang="en-US" sz="3100" b="1" dirty="0">
+              <a:rPr lang="en-US" sz="3200" b="1" dirty="0">
                 <a:solidFill>
                   <a:srgbClr val="15171F"/>
                 </a:solidFill>
@@ -10262,9 +10262,9 @@
                 <a:ea typeface="Public Sans" pitchFamily="34" charset="-122"/>
                 <a:cs typeface="Public Sans" pitchFamily="34" charset="-120"/>
               </a:rPr>
-              <a:t>Obsidian: your vault, and why it is worth five minutes</a:t>
-            </a:r>
-            <a:endParaRPr lang="en-US" sz="3100" dirty="0"/>
+              <a:t>Obsidian: worth the five minutes</a:t>
+            </a:r>
+            <a:endParaRPr lang="en-US" sz="3200" dirty="0"/>
           </a:p>
         </p:txBody>
       </p:sp>
@@ -10291,12 +10291,12 @@
           <a:p>
             <a:pPr indent="0" marL="0">
               <a:lnSpc>
-                <a:spcPts val="2100"/>
+                <a:spcPts val="2300"/>
               </a:lnSpc>
               <a:buNone/>
             </a:pPr>
             <a:r>
-              <a:rPr lang="en-US" sz="1500" dirty="0">
+              <a:rPr lang="en-US" sz="1600" dirty="0">
                 <a:solidFill>
                   <a:srgbClr val="5B6270"/>
                 </a:solidFill>
@@ -10304,9 +10304,9 @@
                 <a:ea typeface="Public Sans" pitchFamily="34" charset="-122"/>
                 <a:cs typeface="Public Sans" pitchFamily="34" charset="-120"/>
               </a:rPr>
-              <a:t>Obsidian does not store anything. It reads a folder — and when you create a vault, it makes that folder for you.</a:t>
-            </a:r>
-            <a:endParaRPr lang="en-US" sz="1500" dirty="0"/>
+              <a:t>Obsidian stores nothing. It reads a folder — and creating a vault makes that folder for you.</a:t>
+            </a:r>
+            <a:endParaRPr lang="en-US" sz="1600" dirty="0"/>
           </a:p>
         </p:txBody>
       </p:sp>
@@ -10318,12 +10318,12 @@
         </p:nvSpPr>
         <p:spPr>
           <a:xfrm>
-            <a:off x="777240" y="2788920"/>
-            <a:ext cx="5029200" cy="2887726"/>
+            <a:off x="777240" y="3017520"/>
+            <a:ext cx="5029200" cy="2509012"/>
           </a:xfrm>
           <a:prstGeom prst="roundRect">
             <a:avLst>
-              <a:gd name="adj" fmla="val 1900"/>
+              <a:gd name="adj" fmla="val 2187"/>
             </a:avLst>
           </a:prstGeom>
           <a:solidFill>
@@ -10345,7 +10345,7 @@
         </p:nvSpPr>
         <p:spPr>
           <a:xfrm>
-            <a:off x="1051560" y="3063240"/>
+            <a:off x="1051560" y="3291840"/>
             <a:ext cx="4480560" cy="219456"/>
           </a:xfrm>
           <a:prstGeom prst="rect">
@@ -10364,7 +10364,7 @@
             <a:r>
               <a:rPr lang="en-US" sz="950" spc="140" kern="0" dirty="0">
                 <a:solidFill>
-                  <a:srgbClr val="7367F0"/>
+                  <a:srgbClr val="6055D8"/>
                 </a:solidFill>
                 <a:latin typeface="Courier New" pitchFamily="34" charset="0"/>
                 <a:ea typeface="Courier New" pitchFamily="34" charset="-122"/>
@@ -10384,7 +10384,7 @@
         </p:nvSpPr>
         <p:spPr>
           <a:xfrm>
-            <a:off x="1051560" y="3355848"/>
+            <a:off x="1051560" y="3584448"/>
             <a:ext cx="4480560" cy="259080"/>
           </a:xfrm>
           <a:prstGeom prst="rect">
@@ -10426,8 +10426,8 @@
         </p:nvSpPr>
         <p:spPr>
           <a:xfrm>
-            <a:off x="1051560" y="3742944"/>
-            <a:ext cx="4480560" cy="1677670"/>
+            <a:off x="1051560" y="3971544"/>
+            <a:ext cx="4480560" cy="1298956"/>
           </a:xfrm>
           <a:prstGeom prst="rect">
             <a:avLst/>
@@ -10441,12 +10441,12 @@
           <a:p>
             <a:pPr indent="0" marL="0">
               <a:lnSpc>
-                <a:spcPts val="1846"/>
+                <a:spcPts val="1988"/>
               </a:lnSpc>
               <a:buNone/>
             </a:pPr>
             <a:r>
-              <a:rPr lang="en-US" sz="1300" dirty="0">
+              <a:rPr lang="en-US" sz="1400" dirty="0">
                 <a:solidFill>
                   <a:srgbClr val="5B6270"/>
                 </a:solidFill>
@@ -10454,28 +10454,28 @@
                 <a:ea typeface="Public Sans" pitchFamily="34" charset="-122"/>
                 <a:cs typeface="Public Sans" pitchFamily="34" charset="-120"/>
               </a:rPr>
-              <a:t>Backlinks and the graph turn your notes into something an agent can walk: from a client, to the promise, to the workflow that delivers it.</a:t>
-            </a:r>
-            <a:endParaRPr lang="en-US" sz="1300" dirty="0"/>
+              <a:t>Backlinks and the graph give an agent something to walk: client, to promise, to the workflow that delivers it.</a:t>
+            </a:r>
+            <a:endParaRPr lang="en-US" sz="1400" dirty="0"/>
           </a:p>
           <a:p>
             <a:pPr indent="0" marL="0">
               <a:lnSpc>
-                <a:spcPts val="1846"/>
+                <a:spcPts val="1988"/>
               </a:lnSpc>
               <a:buNone/>
             </a:pPr>
-            <a:endParaRPr lang="en-US" sz="1300" dirty="0"/>
+            <a:endParaRPr lang="en-US" sz="1400" dirty="0"/>
           </a:p>
           <a:p>
             <a:pPr indent="0" marL="0">
               <a:lnSpc>
-                <a:spcPts val="1846"/>
+                <a:spcPts val="1988"/>
               </a:lnSpc>
               <a:buNone/>
             </a:pPr>
             <a:r>
-              <a:rPr lang="en-US" sz="1300" dirty="0">
+              <a:rPr lang="en-US" sz="1400" dirty="0">
                 <a:solidFill>
                   <a:srgbClr val="5B6270"/>
                 </a:solidFill>
@@ -10483,9 +10483,9 @@
                 <a:ea typeface="Public Sans" pitchFamily="34" charset="-122"/>
                 <a:cs typeface="Public Sans" pitchFamily="34" charset="-120"/>
               </a:rPr>
-              <a:t>Plus the plugin shelf — Dataview and the rest — which lets a page answer a question instead of just sitting there.</a:t>
-            </a:r>
-            <a:endParaRPr lang="en-US" sz="1300" dirty="0"/>
+              <a:t>Plus Dataview and the rest of the plugin shelf.</a:t>
+            </a:r>
+            <a:endParaRPr lang="en-US" sz="1400" dirty="0"/>
           </a:p>
         </p:txBody>
       </p:sp>
@@ -10497,12 +10497,12 @@
         </p:nvSpPr>
         <p:spPr>
           <a:xfrm>
-            <a:off x="6172200" y="2788920"/>
-            <a:ext cx="5029200" cy="2887726"/>
+            <a:off x="6172200" y="3017520"/>
+            <a:ext cx="5029200" cy="2509012"/>
           </a:xfrm>
           <a:prstGeom prst="roundRect">
             <a:avLst>
-              <a:gd name="adj" fmla="val 1900"/>
+              <a:gd name="adj" fmla="val 2187"/>
             </a:avLst>
           </a:prstGeom>
           <a:solidFill>
@@ -10524,7 +10524,7 @@
         </p:nvSpPr>
         <p:spPr>
           <a:xfrm>
-            <a:off x="6446520" y="3063240"/>
+            <a:off x="6446520" y="3291840"/>
             <a:ext cx="4480560" cy="219456"/>
           </a:xfrm>
           <a:prstGeom prst="rect">
@@ -10543,7 +10543,7 @@
             <a:r>
               <a:rPr lang="en-US" sz="950" spc="140" kern="0" dirty="0">
                 <a:solidFill>
-                  <a:srgbClr val="7367F0"/>
+                  <a:srgbClr val="6055D8"/>
                 </a:solidFill>
                 <a:latin typeface="Courier New" pitchFamily="34" charset="0"/>
                 <a:ea typeface="Courier New" pitchFamily="34" charset="-122"/>
@@ -10563,7 +10563,7 @@
         </p:nvSpPr>
         <p:spPr>
           <a:xfrm>
-            <a:off x="6446520" y="3355848"/>
+            <a:off x="6446520" y="3584448"/>
             <a:ext cx="4480560" cy="259080"/>
           </a:xfrm>
           <a:prstGeom prst="rect">
@@ -10605,8 +10605,8 @@
         </p:nvSpPr>
         <p:spPr>
           <a:xfrm>
-            <a:off x="6446520" y="3742944"/>
-            <a:ext cx="4480560" cy="1677670"/>
+            <a:off x="6446520" y="3971544"/>
+            <a:ext cx="4480560" cy="1298956"/>
           </a:xfrm>
           <a:prstGeom prst="rect">
             <a:avLst/>
@@ -10620,12 +10620,12 @@
           <a:p>
             <a:pPr indent="0" marL="0">
               <a:lnSpc>
-                <a:spcPts val="1846"/>
+                <a:spcPts val="1988"/>
               </a:lnSpc>
               <a:buNone/>
             </a:pPr>
             <a:r>
-              <a:rPr lang="en-US" sz="1300" dirty="0">
+              <a:rPr lang="en-US" sz="1400" dirty="0">
                 <a:solidFill>
                   <a:srgbClr val="5B6270"/>
                 </a:solidFill>
@@ -10633,28 +10633,28 @@
                 <a:ea typeface="Public Sans" pitchFamily="34" charset="-122"/>
                 <a:cs typeface="Public Sans" pitchFamily="34" charset="-120"/>
               </a:rPr>
-              <a:t>Make an ordinary folder under C:\AI instead and carry on — the vault is plain Markdown, and every step in this hour runs.</a:t>
-            </a:r>
-            <a:endParaRPr lang="en-US" sz="1300" dirty="0"/>
+              <a:t>An ordinary folder under C:\AI runs every step of this hour.</a:t>
+            </a:r>
+            <a:endParaRPr lang="en-US" sz="1400" dirty="0"/>
           </a:p>
           <a:p>
             <a:pPr indent="0" marL="0">
               <a:lnSpc>
-                <a:spcPts val="1846"/>
+                <a:spcPts val="1988"/>
               </a:lnSpc>
               <a:buNone/>
             </a:pPr>
-            <a:endParaRPr lang="en-US" sz="1300" dirty="0"/>
+            <a:endParaRPr lang="en-US" sz="1400" dirty="0"/>
           </a:p>
           <a:p>
             <a:pPr indent="0" marL="0">
               <a:lnSpc>
-                <a:spcPts val="1846"/>
+                <a:spcPts val="1988"/>
               </a:lnSpc>
               <a:buNone/>
             </a:pPr>
             <a:r>
-              <a:rPr lang="en-US" sz="1300" dirty="0">
+              <a:rPr lang="en-US" sz="1400" dirty="0">
                 <a:solidFill>
                   <a:srgbClr val="5B6270"/>
                 </a:solidFill>
@@ -10662,9 +10662,9 @@
                 <a:ea typeface="Public Sans" pitchFamily="34" charset="-122"/>
                 <a:cs typeface="Public Sans" pitchFamily="34" charset="-120"/>
               </a:rPr>
-              <a:t>What you lose is the retrieval side: the graph, the backlinks, the plugins. Install it tonight and nothing has to be redone.</a:t>
-            </a:r>
-            <a:endParaRPr lang="en-US" sz="1300" dirty="0"/>
+              <a:t>What you lose is the graph, the backlinks, the plugins. Install it tonight and nothing gets redone.</a:t>
+            </a:r>
+            <a:endParaRPr lang="en-US" sz="1400" dirty="0"/>
           </a:p>
         </p:txBody>
       </p:sp>
@@ -10695,7 +10695,7 @@
             <a:r>
               <a:rPr lang="en-US" sz="950" spc="100" kern="0" dirty="0">
                 <a:solidFill>
-                  <a:srgbClr val="9198A6"/>
+                  <a:srgbClr val="6B6D72"/>
                 </a:solidFill>
                 <a:latin typeface="Courier New" pitchFamily="34" charset="0"/>
                 <a:ea typeface="Courier New" pitchFamily="34" charset="-122"/>
@@ -10766,7 +10766,7 @@
             <a:r>
               <a:rPr lang="en-US" sz="1100" spc="200" kern="0" dirty="0">
                 <a:solidFill>
-                  <a:srgbClr val="7367F0"/>
+                  <a:srgbClr val="6055D8"/>
                 </a:solidFill>
                 <a:latin typeface="Courier New" pitchFamily="34" charset="0"/>
                 <a:ea typeface="Courier New" pitchFamily="34" charset="-122"/>
@@ -10912,11 +10912,11 @@
         <p:spPr>
           <a:xfrm>
             <a:off x="777240" y="1938528"/>
-            <a:ext cx="10637215" cy="1566672"/>
+            <a:ext cx="10637215" cy="1236472"/>
           </a:xfrm>
           <a:prstGeom prst="roundRect">
             <a:avLst>
-              <a:gd name="adj" fmla="val 3502"/>
+              <a:gd name="adj" fmla="val 4437"/>
             </a:avLst>
           </a:prstGeom>
           <a:solidFill>
@@ -10939,7 +10939,7 @@
         <p:spPr>
           <a:xfrm>
             <a:off x="1143000" y="1938528"/>
-            <a:ext cx="9905695" cy="1566672"/>
+            <a:ext cx="9905695" cy="1236472"/>
           </a:xfrm>
           <a:prstGeom prst="rect">
             <a:avLst/>
@@ -10960,7 +10960,7 @@
             <a:r>
               <a:rPr lang="en-US" sz="1050" spc="160" kern="0" dirty="0">
                 <a:solidFill>
-                  <a:srgbClr val="7367F0"/>
+                  <a:srgbClr val="6055D8"/>
                 </a:solidFill>
                 <a:latin typeface="Courier New" pitchFamily="34" charset="0"/>
                 <a:ea typeface="Courier New" pitchFamily="34" charset="-122"/>
@@ -10992,7 +10992,7 @@
                 <a:ea typeface="Public Sans" pitchFamily="34" charset="-122"/>
                 <a:cs typeface="Public Sans" pitchFamily="34" charset="-120"/>
               </a:rPr>
-              <a:t>In Obsidian: Create new vault. Name it after yourself or your team, and put it under C:\AI. No Obsidian? Make an empty folder there instead.</a:t>
+              <a:t>In Obsidian: Create new vault. Put it under C:\AI. No Obsidian? An empty folder there instead.</a:t>
             </a:r>
             <a:endParaRPr lang="en-US" sz="1050" dirty="0"/>
           </a:p>
@@ -11006,7 +11006,7 @@
         </p:nvSpPr>
         <p:spPr>
           <a:xfrm>
-            <a:off x="777240" y="3669792"/>
+            <a:off x="777240" y="3339592"/>
             <a:ext cx="10637215" cy="321564"/>
           </a:xfrm>
           <a:prstGeom prst="rect">
@@ -11065,12 +11065,12 @@
         </p:nvSpPr>
         <p:spPr>
           <a:xfrm>
-            <a:off x="777240" y="4247388"/>
-            <a:ext cx="10607040" cy="1700276"/>
+            <a:off x="777240" y="3917188"/>
+            <a:ext cx="10607040" cy="1499108"/>
           </a:xfrm>
           <a:prstGeom prst="roundRect">
             <a:avLst>
-              <a:gd name="adj" fmla="val 3227"/>
+              <a:gd name="adj" fmla="val 3660"/>
             </a:avLst>
           </a:prstGeom>
           <a:solidFill>
@@ -11092,7 +11092,7 @@
         </p:nvSpPr>
         <p:spPr>
           <a:xfrm>
-            <a:off x="1051560" y="4521708"/>
+            <a:off x="1051560" y="4191508"/>
             <a:ext cx="10058400" cy="219456"/>
           </a:xfrm>
           <a:prstGeom prst="rect">
@@ -11111,7 +11111,7 @@
             <a:r>
               <a:rPr lang="en-US" sz="950" spc="140" kern="0" dirty="0">
                 <a:solidFill>
-                  <a:srgbClr val="7367F0"/>
+                  <a:srgbClr val="6055D8"/>
                 </a:solidFill>
                 <a:latin typeface="Courier New" pitchFamily="34" charset="0"/>
                 <a:ea typeface="Courier New" pitchFamily="34" charset="-122"/>
@@ -11131,8 +11131,8 @@
         </p:nvSpPr>
         <p:spPr>
           <a:xfrm>
-            <a:off x="1051560" y="4814316"/>
-            <a:ext cx="10058400" cy="243840"/>
+            <a:off x="1051560" y="4484116"/>
+            <a:ext cx="10058400" cy="259080"/>
           </a:xfrm>
           <a:prstGeom prst="rect">
             <a:avLst/>
@@ -11146,12 +11146,12 @@
           <a:p>
             <a:pPr indent="0" marL="0">
               <a:lnSpc>
-                <a:spcPts val="1920"/>
+                <a:spcPts val="2040"/>
               </a:lnSpc>
               <a:buNone/>
             </a:pPr>
             <a:r>
-              <a:rPr lang="en-US" sz="1600" b="1" dirty="0">
+              <a:rPr lang="en-US" sz="1700" b="1" dirty="0">
                 <a:solidFill>
                   <a:srgbClr val="15171F"/>
                 </a:solidFill>
@@ -11161,7 +11161,7 @@
               </a:rPr>
               <a:t>Because you keep it</a:t>
             </a:r>
-            <a:endParaRPr lang="en-US" sz="1600" dirty="0"/>
+            <a:endParaRPr lang="en-US" sz="1700" dirty="0"/>
           </a:p>
         </p:txBody>
       </p:sp>
@@ -11173,8 +11173,8 @@
         </p:nvSpPr>
         <p:spPr>
           <a:xfrm>
-            <a:off x="1051560" y="5186172"/>
-            <a:ext cx="10058400" cy="505460"/>
+            <a:off x="1051560" y="4871212"/>
+            <a:ext cx="10058400" cy="289052"/>
           </a:xfrm>
           <a:prstGeom prst="rect">
             <a:avLst/>
@@ -11188,12 +11188,12 @@
           <a:p>
             <a:pPr indent="0" marL="0">
               <a:lnSpc>
-                <a:spcPts val="1846"/>
+                <a:spcPts val="1988"/>
               </a:lnSpc>
               <a:buNone/>
             </a:pPr>
             <a:r>
-              <a:rPr lang="en-US" sz="1300" dirty="0">
+              <a:rPr lang="en-US" sz="1400" dirty="0">
                 <a:solidFill>
                   <a:srgbClr val="5B6270"/>
                 </a:solidFill>
@@ -11201,9 +11201,9 @@
                 <a:ea typeface="Public Sans" pitchFamily="34" charset="-122"/>
                 <a:cs typeface="Public Sans" pitchFamily="34" charset="-120"/>
               </a:rPr>
-              <a:t>Everything today is plain text files in that folder. No database, no account, nothing hosted. If we never speak again it still opens — and you can read every file of it in Notepad.</a:t>
-            </a:r>
-            <a:endParaRPr lang="en-US" sz="1300" dirty="0"/>
+              <a:t>Plain text files in a folder. No database, nothing hosted. Every file of it opens in Notepad, today and in ten years.</a:t>
+            </a:r>
+            <a:endParaRPr lang="en-US" sz="1400" dirty="0"/>
           </a:p>
         </p:txBody>
       </p:sp>
@@ -11234,7 +11234,7 @@
             <a:r>
               <a:rPr lang="en-US" sz="950" spc="100" kern="0" dirty="0">
                 <a:solidFill>
-                  <a:srgbClr val="9198A6"/>
+                  <a:srgbClr val="6B6D72"/>
                 </a:solidFill>
                 <a:latin typeface="Courier New" pitchFamily="34" charset="0"/>
                 <a:ea typeface="Courier New" pitchFamily="34" charset="-122"/>
@@ -11305,7 +11305,7 @@
             <a:r>
               <a:rPr lang="en-US" sz="1100" spc="200" kern="0" dirty="0">
                 <a:solidFill>
-                  <a:srgbClr val="7367F0"/>
+                  <a:srgbClr val="6055D8"/>
                 </a:solidFill>
                 <a:latin typeface="Courier New" pitchFamily="34" charset="0"/>
                 <a:ea typeface="Courier New" pitchFamily="34" charset="-122"/>
@@ -11451,11 +11451,11 @@
         <p:spPr>
           <a:xfrm>
             <a:off x="777240" y="1938528"/>
-            <a:ext cx="10637215" cy="1566672"/>
+            <a:ext cx="10637215" cy="1236472"/>
           </a:xfrm>
           <a:prstGeom prst="roundRect">
             <a:avLst>
-              <a:gd name="adj" fmla="val 3502"/>
+              <a:gd name="adj" fmla="val 4437"/>
             </a:avLst>
           </a:prstGeom>
           <a:solidFill>
@@ -11478,7 +11478,7 @@
         <p:spPr>
           <a:xfrm>
             <a:off x="1143000" y="1938528"/>
-            <a:ext cx="9905695" cy="1566672"/>
+            <a:ext cx="9905695" cy="1236472"/>
           </a:xfrm>
           <a:prstGeom prst="rect">
             <a:avLst/>
@@ -11499,7 +11499,7 @@
             <a:r>
               <a:rPr lang="en-US" sz="1050" spc="160" kern="0" dirty="0">
                 <a:solidFill>
-                  <a:srgbClr val="7367F0"/>
+                  <a:srgbClr val="6055D8"/>
                 </a:solidFill>
                 <a:latin typeface="Courier New" pitchFamily="34" charset="0"/>
                 <a:ea typeface="Courier New" pitchFamily="34" charset="-122"/>
@@ -11531,7 +11531,7 @@
                 <a:ea typeface="Public Sans" pitchFamily="34" charset="-122"/>
                 <a:cs typeface="Public Sans" pitchFamily="34" charset="-120"/>
               </a:rPr>
-              <a:t>In Claude, create a project and name it after your work. Then connect the folder you just made to that project, and approve it.</a:t>
+              <a:t>Create a project in Claude. Connect the folder you just made to it, and approve it.</a:t>
             </a:r>
             <a:endParaRPr lang="en-US" sz="1050" dirty="0"/>
           </a:p>
@@ -11545,7 +11545,7 @@
         </p:nvSpPr>
         <p:spPr>
           <a:xfrm>
-            <a:off x="777240" y="3669792"/>
+            <a:off x="777240" y="3339592"/>
             <a:ext cx="10637215" cy="321564"/>
           </a:xfrm>
           <a:prstGeom prst="rect">
@@ -11604,12 +11604,12 @@
         </p:nvSpPr>
         <p:spPr>
           <a:xfrm>
-            <a:off x="777240" y="4247388"/>
-            <a:ext cx="10607040" cy="1700276"/>
+            <a:off x="777240" y="3917188"/>
+            <a:ext cx="10607040" cy="1499108"/>
           </a:xfrm>
           <a:prstGeom prst="roundRect">
             <a:avLst>
-              <a:gd name="adj" fmla="val 3227"/>
+              <a:gd name="adj" fmla="val 3660"/>
             </a:avLst>
           </a:prstGeom>
           <a:solidFill>
@@ -11631,7 +11631,7 @@
         </p:nvSpPr>
         <p:spPr>
           <a:xfrm>
-            <a:off x="1051560" y="4521708"/>
+            <a:off x="1051560" y="4191508"/>
             <a:ext cx="10058400" cy="219456"/>
           </a:xfrm>
           <a:prstGeom prst="rect">
@@ -11650,7 +11650,7 @@
             <a:r>
               <a:rPr lang="en-US" sz="950" spc="140" kern="0" dirty="0">
                 <a:solidFill>
-                  <a:srgbClr val="7367F0"/>
+                  <a:srgbClr val="6055D8"/>
                 </a:solidFill>
                 <a:latin typeface="Courier New" pitchFamily="34" charset="0"/>
                 <a:ea typeface="Courier New" pitchFamily="34" charset="-122"/>
@@ -11670,8 +11670,8 @@
         </p:nvSpPr>
         <p:spPr>
           <a:xfrm>
-            <a:off x="1051560" y="4814316"/>
-            <a:ext cx="10058400" cy="243840"/>
+            <a:off x="1051560" y="4484116"/>
+            <a:ext cx="10058400" cy="259080"/>
           </a:xfrm>
           <a:prstGeom prst="rect">
             <a:avLst/>
@@ -11685,12 +11685,12 @@
           <a:p>
             <a:pPr indent="0" marL="0">
               <a:lnSpc>
-                <a:spcPts val="1920"/>
+                <a:spcPts val="2040"/>
               </a:lnSpc>
               <a:buNone/>
             </a:pPr>
             <a:r>
-              <a:rPr lang="en-US" sz="1600" b="1" dirty="0">
+              <a:rPr lang="en-US" sz="1700" b="1" dirty="0">
                 <a:solidFill>
                   <a:srgbClr val="15171F"/>
                 </a:solidFill>
@@ -11700,7 +11700,7 @@
               </a:rPr>
               <a:t>Because a project remembers</a:t>
             </a:r>
-            <a:endParaRPr lang="en-US" sz="1600" dirty="0"/>
+            <a:endParaRPr lang="en-US" sz="1700" dirty="0"/>
           </a:p>
         </p:txBody>
       </p:sp>
@@ -11712,8 +11712,8 @@
         </p:nvSpPr>
         <p:spPr>
           <a:xfrm>
-            <a:off x="1051560" y="5186172"/>
-            <a:ext cx="10058400" cy="505460"/>
+            <a:off x="1051560" y="4871212"/>
+            <a:ext cx="10058400" cy="289052"/>
           </a:xfrm>
           <a:prstGeom prst="rect">
             <a:avLst/>
@@ -11727,12 +11727,12 @@
           <a:p>
             <a:pPr indent="0" marL="0">
               <a:lnSpc>
-                <a:spcPts val="1846"/>
+                <a:spcPts val="1988"/>
               </a:lnSpc>
               <a:buNone/>
             </a:pPr>
             <a:r>
-              <a:rPr lang="en-US" sz="1300" dirty="0">
+              <a:rPr lang="en-US" sz="1400" dirty="0">
                 <a:solidFill>
                   <a:srgbClr val="5B6270"/>
                 </a:solidFill>
@@ -11740,9 +11740,9 @@
                 <a:ea typeface="Public Sans" pitchFamily="34" charset="-122"/>
                 <a:cs typeface="Public Sans" pitchFamily="34" charset="-120"/>
               </a:rPr>
-              <a:t>Every conversation inside it reads and writes the same folder. Next week starts where today ended instead of starting from nothing — which is the thing that has been annoying you every morning.</a:t>
-            </a:r>
-            <a:endParaRPr lang="en-US" sz="1300" dirty="0"/>
+              <a:t>Every conversation inside it reads and writes the same folder. Next week starts where today ended.</a:t>
+            </a:r>
+            <a:endParaRPr lang="en-US" sz="1400" dirty="0"/>
           </a:p>
         </p:txBody>
       </p:sp>
@@ -11773,7 +11773,7 @@
             <a:r>
               <a:rPr lang="en-US" sz="950" spc="100" kern="0" dirty="0">
                 <a:solidFill>
-                  <a:srgbClr val="9198A6"/>
+                  <a:srgbClr val="6B6D72"/>
                 </a:solidFill>
                 <a:latin typeface="Courier New" pitchFamily="34" charset="0"/>
                 <a:ea typeface="Courier New" pitchFamily="34" charset="-122"/>
@@ -12038,7 +12038,7 @@
             <a:r>
               <a:rPr lang="en-US" sz="1050" spc="160" kern="0" dirty="0">
                 <a:solidFill>
-                  <a:srgbClr val="7367F0"/>
+                  <a:srgbClr val="A59CFF"/>
                 </a:solidFill>
                 <a:latin typeface="Courier New" pitchFamily="34" charset="0"/>
                 <a:ea typeface="Courier New" pitchFamily="34" charset="-122"/>
@@ -12277,7 +12277,7 @@
                 <a:ea typeface="Public Sans" pitchFamily="34" charset="-122"/>
                 <a:cs typeface="Public Sans" pitchFamily="34" charset="-120"/>
               </a:rPr>
-              <a:t>Job titles, Norse gods, Friends, the Kardashians — or three names of your own.
+              <a:t>Job titles, Norse gods, Friends, the Kardashians — or your own.
 </a:t>
             </a:r>
             <a:pPr indent="0" marL="0">
@@ -12312,7 +12312,7 @@
                 <a:ea typeface="Public Sans" pitchFamily="34" charset="-122"/>
                 <a:cs typeface="Public Sans" pitchFamily="34" charset="-120"/>
               </a:rPr>
-              <a:t>“then copy the starter folder into mine instead.” Same vault, one minute.</a:t>
+              <a:t>“then copy the starter folder into mine instead.”</a:t>
             </a:r>
             <a:endParaRPr lang="en-US" sz="1350" dirty="0"/>
           </a:p>
@@ -12345,7 +12345,7 @@
             <a:r>
               <a:rPr lang="en-US" sz="950" spc="100" kern="0" dirty="0">
                 <a:solidFill>
-                  <a:srgbClr val="7E8492"/>
+                  <a:srgbClr val="8A90A0"/>
                 </a:solidFill>
                 <a:latin typeface="Courier New" pitchFamily="34" charset="0"/>
                 <a:ea typeface="Courier New" pitchFamily="34" charset="-122"/>
@@ -12416,7 +12416,7 @@
             <a:r>
               <a:rPr lang="en-US" sz="1100" spc="200" kern="0" dirty="0">
                 <a:solidFill>
-                  <a:srgbClr val="7367F0"/>
+                  <a:srgbClr val="6055D8"/>
                 </a:solidFill>
                 <a:latin typeface="Courier New" pitchFamily="34" charset="0"/>
                 <a:ea typeface="Courier New" pitchFamily="34" charset="-122"/>
@@ -12610,7 +12610,7 @@
             <a:r>
               <a:rPr lang="en-US" sz="1050" spc="160" kern="0" dirty="0">
                 <a:solidFill>
-                  <a:srgbClr val="7367F0"/>
+                  <a:srgbClr val="6055D8"/>
                 </a:solidFill>
                 <a:latin typeface="Courier New" pitchFamily="34" charset="0"/>
                 <a:ea typeface="Courier New" pitchFamily="34" charset="-122"/>
@@ -12642,7 +12642,7 @@
                 <a:ea typeface="Public Sans" pitchFamily="34" charset="-122"/>
                 <a:cs typeface="Public Sans" pitchFamily="34" charset="-120"/>
               </a:rPr>
-              <a:t>Say: open my dashboard. Claude finds the page it just built and opens it in your browser.</a:t>
+              <a:t>Say: open my dashboard. Claude finds the page it just built and opens it.</a:t>
             </a:r>
             <a:endParaRPr lang="en-US" sz="1050" dirty="0"/>
           </a:p>
@@ -12716,11 +12716,11 @@
         <p:spPr>
           <a:xfrm>
             <a:off x="777240" y="3917188"/>
-            <a:ext cx="5029200" cy="1934718"/>
+            <a:ext cx="5029200" cy="1751584"/>
           </a:xfrm>
           <a:prstGeom prst="roundRect">
             <a:avLst>
-              <a:gd name="adj" fmla="val 2836"/>
+              <a:gd name="adj" fmla="val 3132"/>
             </a:avLst>
           </a:prstGeom>
           <a:solidFill>
@@ -12761,7 +12761,7 @@
             <a:r>
               <a:rPr lang="en-US" sz="950" spc="140" kern="0" dirty="0">
                 <a:solidFill>
-                  <a:srgbClr val="7367F0"/>
+                  <a:srgbClr val="6055D8"/>
                 </a:solidFill>
                 <a:latin typeface="Courier New" pitchFamily="34" charset="0"/>
                 <a:ea typeface="Courier New" pitchFamily="34" charset="-122"/>
@@ -12782,7 +12782,7 @@
         <p:spPr>
           <a:xfrm>
             <a:off x="1051560" y="4484116"/>
-            <a:ext cx="4480560" cy="243840"/>
+            <a:ext cx="4480560" cy="259080"/>
           </a:xfrm>
           <a:prstGeom prst="rect">
             <a:avLst/>
@@ -12796,12 +12796,12 @@
           <a:p>
             <a:pPr indent="0" marL="0">
               <a:lnSpc>
-                <a:spcPts val="1920"/>
+                <a:spcPts val="2040"/>
               </a:lnSpc>
               <a:buNone/>
             </a:pPr>
             <a:r>
-              <a:rPr lang="en-US" sz="1600" b="1" dirty="0">
+              <a:rPr lang="en-US" sz="1700" b="1" dirty="0">
                 <a:solidFill>
                   <a:srgbClr val="15171F"/>
                 </a:solidFill>
@@ -12811,7 +12811,7 @@
               </a:rPr>
               <a:t>A file in your own folder</a:t>
             </a:r>
-            <a:endParaRPr lang="en-US" sz="1600" dirty="0"/>
+            <a:endParaRPr lang="en-US" sz="1700" dirty="0"/>
           </a:p>
         </p:txBody>
       </p:sp>
@@ -12823,8 +12823,8 @@
         </p:nvSpPr>
         <p:spPr>
           <a:xfrm>
-            <a:off x="1051560" y="4855972"/>
-            <a:ext cx="4480560" cy="739902"/>
+            <a:off x="1051560" y="4871212"/>
+            <a:ext cx="4480560" cy="541528"/>
           </a:xfrm>
           <a:prstGeom prst="rect">
             <a:avLst/>
@@ -12838,12 +12838,12 @@
           <a:p>
             <a:pPr indent="0" marL="0">
               <a:lnSpc>
-                <a:spcPts val="1846"/>
+                <a:spcPts val="1988"/>
               </a:lnSpc>
               <a:buNone/>
             </a:pPr>
             <a:r>
-              <a:rPr lang="en-US" sz="1300" dirty="0">
+              <a:rPr lang="en-US" sz="1400" dirty="0">
                 <a:solidFill>
                   <a:srgbClr val="5B6270"/>
                 </a:solidFill>
@@ -12851,9 +12851,9 @@
                 <a:ea typeface="Public Sans" pitchFamily="34" charset="-122"/>
                 <a:cs typeface="Public Sans" pitchFamily="34" charset="-120"/>
               </a:rPr>
-              <a:t>05 - Operations / picture / ai_operations.html. Nothing is hosted; it opens with no internet. Bookmark it.</a:t>
-            </a:r>
-            <a:endParaRPr lang="en-US" sz="1300" dirty="0"/>
+              <a:t>05 - Operations / picture / ai_operations.html. No internet needed. Bookmark it.</a:t>
+            </a:r>
+            <a:endParaRPr lang="en-US" sz="1400" dirty="0"/>
           </a:p>
         </p:txBody>
       </p:sp>
@@ -12866,11 +12866,11 @@
         <p:spPr>
           <a:xfrm>
             <a:off x="6172200" y="3917188"/>
-            <a:ext cx="5029200" cy="1934718"/>
+            <a:ext cx="5029200" cy="1751584"/>
           </a:xfrm>
           <a:prstGeom prst="roundRect">
             <a:avLst>
-              <a:gd name="adj" fmla="val 2836"/>
+              <a:gd name="adj" fmla="val 3132"/>
             </a:avLst>
           </a:prstGeom>
           <a:solidFill>
@@ -12911,7 +12911,7 @@
             <a:r>
               <a:rPr lang="en-US" sz="950" spc="140" kern="0" dirty="0">
                 <a:solidFill>
-                  <a:srgbClr val="7367F0"/>
+                  <a:srgbClr val="6055D8"/>
                 </a:solidFill>
                 <a:latin typeface="Courier New" pitchFamily="34" charset="0"/>
                 <a:ea typeface="Courier New" pitchFamily="34" charset="-122"/>
@@ -12932,7 +12932,7 @@
         <p:spPr>
           <a:xfrm>
             <a:off x="6446520" y="4484116"/>
-            <a:ext cx="4480560" cy="243840"/>
+            <a:ext cx="4480560" cy="259080"/>
           </a:xfrm>
           <a:prstGeom prst="rect">
             <a:avLst/>
@@ -12946,12 +12946,12 @@
           <a:p>
             <a:pPr indent="0" marL="0">
               <a:lnSpc>
-                <a:spcPts val="1920"/>
+                <a:spcPts val="2040"/>
               </a:lnSpc>
               <a:buNone/>
             </a:pPr>
             <a:r>
-              <a:rPr lang="en-US" sz="1600" b="1" dirty="0">
+              <a:rPr lang="en-US" sz="1700" b="1" dirty="0">
                 <a:solidFill>
                   <a:srgbClr val="15171F"/>
                 </a:solidFill>
@@ -12961,7 +12961,7 @@
               </a:rPr>
               <a:t>It was counted, not typed</a:t>
             </a:r>
-            <a:endParaRPr lang="en-US" sz="1600" dirty="0"/>
+            <a:endParaRPr lang="en-US" sz="1700" dirty="0"/>
           </a:p>
         </p:txBody>
       </p:sp>
@@ -12973,8 +12973,8 @@
         </p:nvSpPr>
         <p:spPr>
           <a:xfrm>
-            <a:off x="6446520" y="4855972"/>
-            <a:ext cx="4480560" cy="739902"/>
+            <a:off x="6446520" y="4871212"/>
+            <a:ext cx="4480560" cy="541528"/>
           </a:xfrm>
           <a:prstGeom prst="rect">
             <a:avLst/>
@@ -12988,12 +12988,12 @@
           <a:p>
             <a:pPr indent="0" marL="0">
               <a:lnSpc>
-                <a:spcPts val="1846"/>
+                <a:spcPts val="1988"/>
               </a:lnSpc>
               <a:buNone/>
             </a:pPr>
             <a:r>
-              <a:rPr lang="en-US" sz="1300" dirty="0">
+              <a:rPr lang="en-US" sz="1400" dirty="0">
                 <a:solidFill>
                   <a:srgbClr val="5B6270"/>
                 </a:solidFill>
@@ -13001,9 +13001,9 @@
                 <a:ea typeface="Public Sans" pitchFamily="34" charset="-122"/>
                 <a:cs typeface="Public Sans" pitchFamily="34" charset="-120"/>
               </a:rPr>
-              <a:t>Every number on it was counted off your notes when it was built. Nobody maintains it, so it cannot quietly go stale while everyone still believes it.</a:t>
-            </a:r>
-            <a:endParaRPr lang="en-US" sz="1300" dirty="0"/>
+              <a:t>Every number was counted off your notes. Nobody maintains it, so it cannot quietly go stale.</a:t>
+            </a:r>
+            <a:endParaRPr lang="en-US" sz="1400" dirty="0"/>
           </a:p>
         </p:txBody>
       </p:sp>
@@ -13034,7 +13034,7 @@
             <a:r>
               <a:rPr lang="en-US" sz="950" spc="100" kern="0" dirty="0">
                 <a:solidFill>
-                  <a:srgbClr val="9198A6"/>
+                  <a:srgbClr val="6B6D72"/>
                 </a:solidFill>
                 <a:latin typeface="Courier New" pitchFamily="34" charset="0"/>
                 <a:ea typeface="Courier New" pitchFamily="34" charset="-122"/>

</xml_diff>

<commit_message>
Deck: the fifth tab, and a workflow clicked open
Every screenshot in the deck is re-shot against the site as it is now.
The checkpoint slide names five tabs because there are five, step six
says the skill lands on the Skills tab, and the workflows slide is now a
workflow opened on screen with its steps drawn beside two short cards —
the thing to do live rather than describe.

Co-Authored-By: Claude Opus 5 <noreply@anthropic.com>
Claude-Session: https://claude.ai/code/session_01GU6RhWctnBpcS6dNZ87S1b
</commit_message>
<xml_diff>
--- a/docs/Personal AI Assistant — Installation.pptx
+++ b/docs/Personal AI Assistant — Installation.pptx
@@ -1135,7 +1135,7 @@
           <a:p>
             <a:r>
               <a:rPr lang="en-US" dirty="0"/>
-              <a:t>Point at the zero. Counted rather than reported, so it cannot be quietly optimistic. Ask how many of their own written processes would survive that column.</a:t>
+              <a:t>This is the one to click live rather than describe. Open a workflow on the projector and let the steps appear. Then point at the filled numbers against the outlined ones: the outlined ones are the parts still waiting on a person, and that is the honest picture of how automated this actually is.</a:t>
             </a:r>
             <a:endParaRPr lang="en-US" dirty="0"/>
           </a:p>
@@ -2745,7 +2745,7 @@
         <p:spPr>
           <a:xfrm>
             <a:off x="777240" y="1719072"/>
-            <a:ext cx="8129016" cy="3977640"/>
+            <a:ext cx="8129016" cy="4005072"/>
           </a:xfrm>
           <a:prstGeom prst="rect">
             <a:avLst/>
@@ -2760,12 +2760,12 @@
         </p:nvSpPr>
         <p:spPr>
           <a:xfrm>
-            <a:off x="9262872" y="3540252"/>
-            <a:ext cx="2258568" cy="2156460"/>
+            <a:off x="9262872" y="1719072"/>
+            <a:ext cx="2258568" cy="1669161"/>
           </a:xfrm>
           <a:prstGeom prst="roundRect">
             <a:avLst>
-              <a:gd name="adj" fmla="val 2544"/>
+              <a:gd name="adj" fmla="val 3287"/>
             </a:avLst>
           </a:prstGeom>
           <a:solidFill>
@@ -2787,8 +2787,8 @@
         </p:nvSpPr>
         <p:spPr>
           <a:xfrm>
-            <a:off x="9537192" y="3814572"/>
-            <a:ext cx="1709928" cy="487680"/>
+            <a:off x="9537192" y="1993392"/>
+            <a:ext cx="1709928" cy="243840"/>
           </a:xfrm>
           <a:prstGeom prst="rect">
             <a:avLst/>
@@ -2815,7 +2815,7 @@
                 <a:ea typeface="Public Sans" pitchFamily="34" charset="-122"/>
                 <a:cs typeface="Public Sans" pitchFamily="34" charset="-120"/>
               </a:rPr>
-              <a:t>Honest on day one</a:t>
+              <a:t>Five tabs</a:t>
             </a:r>
             <a:endParaRPr lang="en-US" sz="1600" dirty="0"/>
           </a:p>
@@ -2829,8 +2829,8 @@
         </p:nvSpPr>
         <p:spPr>
           <a:xfrm>
-            <a:off x="9537192" y="4430268"/>
-            <a:ext cx="1709928" cy="1010412"/>
+            <a:off x="9537192" y="2365248"/>
+            <a:ext cx="1709928" cy="766953"/>
           </a:xfrm>
           <a:prstGeom prst="rect">
             <a:avLst/>
@@ -2857,7 +2857,7 @@
                 <a:ea typeface="Public Sans" pitchFamily="34" charset="-122"/>
                 <a:cs typeface="Public Sans" pitchFamily="34" charset="-120"/>
               </a:rPr>
-              <a:t>Two departments, three executives — and it says so. Your job is next.</a:t>
+              <a:t>Dashboard, agent organization, skills, workflows, projects.</a:t>
             </a:r>
             <a:endParaRPr lang="en-US" sz="1350" dirty="0"/>
           </a:p>
@@ -2871,12 +2871,12 @@
         </p:nvSpPr>
         <p:spPr>
           <a:xfrm>
-            <a:off x="9262872" y="1719072"/>
-            <a:ext cx="2258568" cy="1669161"/>
+            <a:off x="9262872" y="3680841"/>
+            <a:ext cx="2258568" cy="2156460"/>
           </a:xfrm>
           <a:prstGeom prst="roundRect">
             <a:avLst>
-              <a:gd name="adj" fmla="val 3287"/>
+              <a:gd name="adj" fmla="val 2544"/>
             </a:avLst>
           </a:prstGeom>
           <a:solidFill>
@@ -2898,8 +2898,8 @@
         </p:nvSpPr>
         <p:spPr>
           <a:xfrm>
-            <a:off x="9537192" y="1993392"/>
-            <a:ext cx="1709928" cy="243840"/>
+            <a:off x="9537192" y="3955161"/>
+            <a:ext cx="1709928" cy="487680"/>
           </a:xfrm>
           <a:prstGeom prst="rect">
             <a:avLst/>
@@ -2926,7 +2926,7 @@
                 <a:ea typeface="Public Sans" pitchFamily="34" charset="-122"/>
                 <a:cs typeface="Public Sans" pitchFamily="34" charset="-120"/>
               </a:rPr>
-              <a:t>Four tabs</a:t>
+              <a:t>Honest on day one</a:t>
             </a:r>
             <a:endParaRPr lang="en-US" sz="1600" dirty="0"/>
           </a:p>
@@ -2940,8 +2940,8 @@
         </p:nvSpPr>
         <p:spPr>
           <a:xfrm>
-            <a:off x="9537192" y="2365248"/>
-            <a:ext cx="1709928" cy="766953"/>
+            <a:off x="9537192" y="4570857"/>
+            <a:ext cx="1709928" cy="1010412"/>
           </a:xfrm>
           <a:prstGeom prst="rect">
             <a:avLst/>
@@ -2968,7 +2968,7 @@
                 <a:ea typeface="Public Sans" pitchFamily="34" charset="-122"/>
                 <a:cs typeface="Public Sans" pitchFamily="34" charset="-120"/>
               </a:rPr>
-              <a:t>Dashboard, agent organization, workflows, projects.</a:t>
+              <a:t>Two departments, three executives — and it says so. Your job is next.</a:t>
             </a:r>
             <a:endParaRPr lang="en-US" sz="1350" dirty="0"/>
           </a:p>
@@ -4604,8 +4604,8 @@
         </p:blipFill>
         <p:spPr>
           <a:xfrm>
-            <a:off x="1892808" y="2304288"/>
-            <a:ext cx="8412480" cy="3749040"/>
+            <a:off x="1984248" y="2304288"/>
+            <a:ext cx="8229600" cy="3703320"/>
           </a:xfrm>
           <a:prstGeom prst="rect">
             <a:avLst/>
@@ -4995,7 +4995,7 @@
                 <a:ea typeface="Public Sans" pitchFamily="34" charset="-122"/>
                 <a:cs typeface="Public Sans" pitchFamily="34" charset="-120"/>
               </a:rPr>
-              <a:t>a skill appears in your vault and the executive reaches for it by name.</a:t>
+              <a:t>a skill appears in your vault, and on the Skills tab under that executive.</a:t>
             </a:r>
             <a:endParaRPr lang="en-US" sz="1450" dirty="0"/>
           </a:p>
@@ -5010,11 +5010,11 @@
         <p:spPr>
           <a:xfrm>
             <a:off x="777240" y="3917188"/>
-            <a:ext cx="5029200" cy="1751584"/>
+            <a:ext cx="5029200" cy="2004060"/>
           </a:xfrm>
           <a:prstGeom prst="roundRect">
             <a:avLst>
-              <a:gd name="adj" fmla="val 3132"/>
+              <a:gd name="adj" fmla="val 2738"/>
             </a:avLst>
           </a:prstGeom>
           <a:solidFill>
@@ -5118,7 +5118,7 @@
         <p:spPr>
           <a:xfrm>
             <a:off x="1051560" y="4871212"/>
-            <a:ext cx="4480560" cy="541528"/>
+            <a:ext cx="4480560" cy="794004"/>
           </a:xfrm>
           <a:prstGeom prst="rect">
             <a:avLst/>
@@ -5145,7 +5145,7 @@
                 <a:ea typeface="Public Sans" pitchFamily="34" charset="-122"/>
                 <a:cs typeface="Public Sans" pitchFamily="34" charset="-120"/>
               </a:rPr>
-              <a:t>When to use it, the steps, where it stops. So it works your way, not its own.</a:t>
+              <a:t>When to use it, the steps, where it stops. The catalog reads itself off the folder, so it is listed the moment it exists.</a:t>
             </a:r>
             <a:endParaRPr lang="en-US" sz="1400" dirty="0"/>
           </a:p>
@@ -5160,11 +5160,11 @@
         <p:spPr>
           <a:xfrm>
             <a:off x="6172200" y="3917188"/>
-            <a:ext cx="5029200" cy="1751584"/>
+            <a:ext cx="5029200" cy="2004060"/>
           </a:xfrm>
           <a:prstGeom prst="roundRect">
             <a:avLst>
-              <a:gd name="adj" fmla="val 3132"/>
+              <a:gd name="adj" fmla="val 2738"/>
             </a:avLst>
           </a:prstGeom>
           <a:solidFill>
@@ -5268,7 +5268,7 @@
         <p:spPr>
           <a:xfrm>
             <a:off x="6446520" y="4871212"/>
-            <a:ext cx="4480560" cy="541528"/>
+            <a:ext cx="4480560" cy="794004"/>
           </a:xfrm>
           <a:prstGeom prst="rect">
             <a:avLst/>
@@ -6174,7 +6174,7 @@
         </p:nvSpPr>
         <p:spPr>
           <a:xfrm>
-            <a:off x="777240" y="1572768"/>
+            <a:off x="777240" y="1627632"/>
             <a:ext cx="10637215" cy="566928"/>
           </a:xfrm>
           <a:prstGeom prst="rect">
@@ -6202,7 +6202,7 @@
                 <a:ea typeface="Public Sans" pitchFamily="34" charset="-122"/>
                 <a:cs typeface="Public Sans" pitchFamily="34" charset="-120"/>
               </a:rPr>
-              <a:t>A workflow is how work happens. A project is work with an end. Both belong to a department.</a:t>
+              <a:t>A workflow is how work happens. A project is work with an end.</a:t>
             </a:r>
             <a:endParaRPr lang="en-US" sz="1600" dirty="0"/>
           </a:p>
@@ -6210,7 +6210,7 @@
       </p:sp>
       <p:pic>
         <p:nvPicPr>
-          <p:cNvPr id="6" name="Image 1" descr="/tmp/claude-0/-home-claude/e62a35b1-5075-553d-b086-acebfebc41ba/scratchpad/deck/n-blocks.png">    </p:cNvPr>
+          <p:cNvPr id="6" name="Image 1" descr="/tmp/claude-0/-home-claude/e62a35b1-5075-553d-b086-acebfebc41ba/scratchpad/deck/n-steps.png">    </p:cNvPr>
           <p:cNvPicPr>
             <a:picLocks noChangeAspect="1"/>
           </p:cNvPicPr>
@@ -6224,8 +6224,8 @@
         </p:blipFill>
         <p:spPr>
           <a:xfrm>
-            <a:off x="777240" y="2212848"/>
-            <a:ext cx="10607040" cy="1801368"/>
+            <a:off x="777240" y="2286000"/>
+            <a:ext cx="6172200" cy="3794760"/>
           </a:xfrm>
           <a:prstGeom prst="rect">
             <a:avLst/>
@@ -6240,12 +6240,12 @@
         </p:nvSpPr>
         <p:spPr>
           <a:xfrm>
-            <a:off x="777240" y="4315968"/>
-            <a:ext cx="5029200" cy="1751584"/>
+            <a:off x="7242048" y="2286000"/>
+            <a:ext cx="4169664" cy="1961769"/>
           </a:xfrm>
           <a:prstGeom prst="roundRect">
             <a:avLst>
-              <a:gd name="adj" fmla="val 3132"/>
+              <a:gd name="adj" fmla="val 2797"/>
             </a:avLst>
           </a:prstGeom>
           <a:solidFill>
@@ -6267,8 +6267,8 @@
         </p:nvSpPr>
         <p:spPr>
           <a:xfrm>
-            <a:off x="1051560" y="4590288"/>
-            <a:ext cx="4480560" cy="219456"/>
+            <a:off x="7516368" y="2560320"/>
+            <a:ext cx="3621024" cy="219456"/>
           </a:xfrm>
           <a:prstGeom prst="rect">
             <a:avLst/>
@@ -6292,7 +6292,7 @@
                 <a:ea typeface="Courier New" pitchFamily="34" charset="-122"/>
                 <a:cs typeface="Courier New" pitchFamily="34" charset="-120"/>
               </a:rPr>
-              <a:t>TWO MARKS, NOT ONE</a:t>
+              <a:t>CLICK ONE OPEN</a:t>
             </a:r>
             <a:endParaRPr lang="en-US" sz="950" dirty="0"/>
           </a:p>
@@ -6306,8 +6306,8 @@
         </p:nvSpPr>
         <p:spPr>
           <a:xfrm>
-            <a:off x="1051560" y="4882896"/>
-            <a:ext cx="4480560" cy="259080"/>
+            <a:off x="7516368" y="2852928"/>
+            <a:ext cx="3621024" cy="243840"/>
           </a:xfrm>
           <a:prstGeom prst="rect">
             <a:avLst/>
@@ -6321,12 +6321,12 @@
           <a:p>
             <a:pPr indent="0" marL="0">
               <a:lnSpc>
-                <a:spcPts val="2040"/>
+                <a:spcPts val="1920"/>
               </a:lnSpc>
               <a:buNone/>
             </a:pPr>
             <a:r>
-              <a:rPr lang="en-US" sz="1700" b="1" dirty="0">
+              <a:rPr lang="en-US" sz="1600" b="1" dirty="0">
                 <a:solidFill>
                   <a:srgbClr val="15171F"/>
                 </a:solidFill>
@@ -6334,9 +6334,9 @@
                 <a:ea typeface="Public Sans" pitchFamily="34" charset="-122"/>
                 <a:cs typeface="Public Sans" pitchFamily="34" charset="-120"/>
               </a:rPr>
-              <a:t>Written down is not working</a:t>
-            </a:r>
-            <a:endParaRPr lang="en-US" sz="1700" dirty="0"/>
+              <a:t>The steps draw themselves</a:t>
+            </a:r>
+            <a:endParaRPr lang="en-US" sz="1600" dirty="0"/>
           </a:p>
         </p:txBody>
       </p:sp>
@@ -6348,8 +6348,8 @@
         </p:nvSpPr>
         <p:spPr>
           <a:xfrm>
-            <a:off x="1051560" y="5269992"/>
-            <a:ext cx="4480560" cy="541528"/>
+            <a:off x="7516368" y="3224784"/>
+            <a:ext cx="3621024" cy="766953"/>
           </a:xfrm>
           <a:prstGeom prst="rect">
             <a:avLst/>
@@ -6363,12 +6363,12 @@
           <a:p>
             <a:pPr indent="0" marL="0">
               <a:lnSpc>
-                <a:spcPts val="1988"/>
+                <a:spcPts val="1917"/>
               </a:lnSpc>
               <a:buNone/>
             </a:pPr>
             <a:r>
-              <a:rPr lang="en-US" sz="1400" dirty="0">
+              <a:rPr lang="en-US" sz="1350" dirty="0">
                 <a:solidFill>
                   <a:srgbClr val="5B6270"/>
                 </a:solidFill>
@@ -6376,9 +6376,9 @@
                 <a:ea typeface="Public Sans" pitchFamily="34" charset="-122"/>
                 <a:cs typeface="Public Sans" pitchFamily="34" charset="-120"/>
               </a:rPr>
-              <a:t>Is the note true? Only after one real case. Does it run end to end? Different question.</a:t>
-            </a:r>
-            <a:endParaRPr lang="en-US" sz="1400" dirty="0"/>
+              <a:t>Out of that note’s own step table. No diagram anywhere can say something the note does not.</a:t>
+            </a:r>
+            <a:endParaRPr lang="en-US" sz="1350" dirty="0"/>
           </a:p>
         </p:txBody>
       </p:sp>
@@ -6390,12 +6390,12 @@
         </p:nvSpPr>
         <p:spPr>
           <a:xfrm>
-            <a:off x="6172200" y="4315968"/>
-            <a:ext cx="5029200" cy="1751584"/>
+            <a:off x="7242048" y="4522089"/>
+            <a:ext cx="4169664" cy="1718310"/>
           </a:xfrm>
           <a:prstGeom prst="roundRect">
             <a:avLst>
-              <a:gd name="adj" fmla="val 3132"/>
+              <a:gd name="adj" fmla="val 3193"/>
             </a:avLst>
           </a:prstGeom>
           <a:solidFill>
@@ -6417,8 +6417,8 @@
         </p:nvSpPr>
         <p:spPr>
           <a:xfrm>
-            <a:off x="6446520" y="4590288"/>
-            <a:ext cx="4480560" cy="219456"/>
+            <a:off x="7516368" y="4796409"/>
+            <a:ext cx="3621024" cy="219456"/>
           </a:xfrm>
           <a:prstGeom prst="rect">
             <a:avLst/>
@@ -6442,7 +6442,7 @@
                 <a:ea typeface="Courier New" pitchFamily="34" charset="-122"/>
                 <a:cs typeface="Courier New" pitchFamily="34" charset="-120"/>
               </a:rPr>
-              <a:t>THE NUMBER TO LOOK AT</a:t>
+              <a:t>TWO MARKS, NOT ONE</a:t>
             </a:r>
             <a:endParaRPr lang="en-US" sz="950" dirty="0"/>
           </a:p>
@@ -6456,8 +6456,8 @@
         </p:nvSpPr>
         <p:spPr>
           <a:xfrm>
-            <a:off x="6446520" y="4882896"/>
-            <a:ext cx="4480560" cy="259080"/>
+            <a:off x="7516368" y="5089017"/>
+            <a:ext cx="3621024" cy="243840"/>
           </a:xfrm>
           <a:prstGeom prst="rect">
             <a:avLst/>
@@ -6471,12 +6471,12 @@
           <a:p>
             <a:pPr indent="0" marL="0">
               <a:lnSpc>
-                <a:spcPts val="2040"/>
+                <a:spcPts val="1920"/>
               </a:lnSpc>
               <a:buNone/>
             </a:pPr>
             <a:r>
-              <a:rPr lang="en-US" sz="1700" b="1" dirty="0">
+              <a:rPr lang="en-US" sz="1600" b="1" dirty="0">
                 <a:solidFill>
                   <a:srgbClr val="15171F"/>
                 </a:solidFill>
@@ -6484,9 +6484,9 @@
                 <a:ea typeface="Public Sans" pitchFamily="34" charset="-122"/>
                 <a:cs typeface="Public Sans" pitchFamily="34" charset="-120"/>
               </a:rPr>
-              <a:t>One workflow, none running</a:t>
-            </a:r>
-            <a:endParaRPr lang="en-US" sz="1700" dirty="0"/>
+              <a:t>Written down is not working</a:t>
+            </a:r>
+            <a:endParaRPr lang="en-US" sz="1600" dirty="0"/>
           </a:p>
         </p:txBody>
       </p:sp>
@@ -6498,8 +6498,8 @@
         </p:nvSpPr>
         <p:spPr>
           <a:xfrm>
-            <a:off x="6446520" y="5269992"/>
-            <a:ext cx="4480560" cy="541528"/>
+            <a:off x="7516368" y="5460873"/>
+            <a:ext cx="3621024" cy="523494"/>
           </a:xfrm>
           <a:prstGeom prst="rect">
             <a:avLst/>
@@ -6513,12 +6513,12 @@
           <a:p>
             <a:pPr indent="0" marL="0">
               <a:lnSpc>
-                <a:spcPts val="1988"/>
+                <a:spcPts val="1917"/>
               </a:lnSpc>
               <a:buNone/>
             </a:pPr>
             <a:r>
-              <a:rPr lang="en-US" sz="1400" dirty="0">
+              <a:rPr lang="en-US" sz="1350" dirty="0">
                 <a:solidFill>
                   <a:srgbClr val="5B6270"/>
                 </a:solidFill>
@@ -6526,9 +6526,9 @@
                 <a:ea typeface="Public Sans" pitchFamily="34" charset="-122"/>
                 <a:cs typeface="Public Sans" pitchFamily="34" charset="-120"/>
               </a:rPr>
-              <a:t>Uncomfortable, true, and nobody had to admit it. It was counted.</a:t>
-            </a:r>
-            <a:endParaRPr lang="en-US" sz="1400" dirty="0"/>
+              <a:t>Is the note true? Only after one real case. Does it run end to end? A different question.</a:t>
+            </a:r>
+            <a:endParaRPr lang="en-US" sz="1350" dirty="0"/>
           </a:p>
         </p:txBody>
       </p:sp>
@@ -12701,7 +12701,7 @@
                 <a:ea typeface="Public Sans" pitchFamily="34" charset="-122"/>
                 <a:cs typeface="Public Sans" pitchFamily="34" charset="-120"/>
               </a:rPr>
-              <a:t>a page opens with four tabs: Dashboard, Agent organization, Workflows, Projects.</a:t>
+              <a:t>a page opens with five tabs: Dashboard, Agent organization, Skills, Workflows, Projects.</a:t>
             </a:r>
             <a:endParaRPr lang="en-US" sz="1450" dirty="0"/>
           </a:p>

</xml_diff>

<commit_message>
Deck: write a workflow together, and a map of where things live
A step 8 the room does as a group, on something everybody recognises:
the five questions, and the fifth one is the point. Everyone has written
a procedure that leaves out what happens when it goes wrong.

And a map. The four steps that make something now say where it lands,
and a new slide lays out all eleven paths in two columns, split by the
distinction the whole framework turns on: black is what you and your
agents write, grey is what is counted and drawn from it, and you never
edit a grey one.

Co-Authored-By: Claude Opus 5 <noreply@anthropic.com>
Claude-Session: https://claude.ai/code/session_01GU6RhWctnBpcS6dNZ87S1b
</commit_message>
<xml_diff>
--- a/docs/Personal AI Assistant — Installation.pptx
+++ b/docs/Personal AI Assistant — Installation.pptx
@@ -23,9 +23,11 @@
     <p:sldId id="271" r:id="rId17"/>
     <p:sldId id="272" r:id="rId18"/>
     <p:sldId id="273" r:id="rId19"/>
+    <p:sldId id="274" r:id="rId20"/>
+    <p:sldId id="275" r:id="rId21"/>
   </p:sldIdLst>
   <p:notesMasterIdLst>
-    <p:notesMasterId r:id="rId20"/>
+    <p:notesMasterId r:id="rId22"/>
   </p:notesMasterIdLst>
   <p:sldSz cx="12192000" cy="6858000"/>
   <p:notesSz cx="6858000" cy="12192000"/>
@@ -1135,7 +1137,7 @@
           <a:p>
             <a:r>
               <a:rPr lang="en-US" dirty="0"/>
-              <a:t>This is the one to click live rather than describe. Open a workflow on the projector and let the steps appear. Then point at the filled numbers against the outlined ones: the outlined ones are the parts still waiting on a person, and that is the honest picture of how automated this actually is.</a:t>
+              <a:t>Do this one out loud, as a group, on something everybody in the room recognises — onboarding someone, closing the month, handling a complaint. Ask the five questions and let them answer. The fifth question is where the real process lives, and it is the one every written procedure they have ever seen leaves out. Then let them each do their own.</a:t>
             </a:r>
             <a:endParaRPr lang="en-US" dirty="0"/>
           </a:p>
@@ -1223,7 +1225,7 @@
           <a:p>
             <a:r>
               <a:rPr lang="en-US" dirty="0"/>
-              <a:t>Slow down here. Read the six out loud. An hour ago every one of these was a thing they would have said needed an IT project.</a:t>
+              <a:t>This is the one to click live rather than describe. Open a workflow on the projector and let the steps appear. Then point at the filled numbers against the outlined ones: the outlined ones are the parts still waiting on a person, and that is the honest picture of how automated this actually is.</a:t>
             </a:r>
             <a:endParaRPr lang="en-US" dirty="0"/>
           </a:p>
@@ -1311,7 +1313,7 @@
           <a:p>
             <a:r>
               <a:rPr lang="en-US" dirty="0"/>
-              <a:t>Send them away with one instruction, not four: open the project instead of a new chat. Everything else is downstream of that habit. Then offer to come back in a month and look at what they built.</a:t>
+              <a:t>The slide to photograph. Everything here is a plain text file they own, in a folder they can open in Notepad. Make the grey/black distinction out loud: black is written by you or your agents, grey is counted and drawn from the black. The one rule that follows from it is the only rule they need to remember about the machinery — never edit a generated file, because the next build overwrites it and the fact you wanted goes with it.</a:t>
             </a:r>
             <a:endParaRPr lang="en-US" dirty="0"/>
           </a:p>
@@ -1335,6 +1337,94 @@
             <a:fld id="{F7021451-1387-4CA6-816F-3879F97B5CBC}" type="slidenum">
               <a:rPr lang="en-US"/>
               <a:t>18</a:t>
+            </a:fld>
+            <a:endParaRPr lang="en-US"/>
+          </a:p>
+        </p:txBody>
+      </p:sp>
+    </p:spTree>
+    <p:extLst>
+      <p:ext uri="{BB962C8B-B14F-4D97-AF65-F5344CB8AC3E}">
+        <p14:creationId xmlns:p14="http://schemas.microsoft.com/office/powerpoint/2010/main" val="1024086991"/>
+      </p:ext>
+    </p:extLst>
+  </p:cSld>
+  <p:clrMapOvr>
+    <a:masterClrMapping/>
+  </p:clrMapOvr>
+</p:notes>
+</file>
+
+<file path=ppt/notesSlides/notesSlide19.xml><?xml version="1.0" encoding="utf-8"?>
+<p:notes xmlns:a="http://schemas.openxmlformats.org/drawingml/2006/main" xmlns:r="http://schemas.openxmlformats.org/officeDocument/2006/relationships" xmlns:p="http://schemas.openxmlformats.org/presentationml/2006/main">
+  <p:cSld>
+    <p:spTree>
+      <p:nvGrpSpPr>
+        <p:cNvPr id="1" name=""/>
+        <p:cNvGrpSpPr/>
+        <p:nvPr/>
+      </p:nvGrpSpPr>
+      <p:grpSpPr>
+        <a:xfrm>
+          <a:off x="0" y="0"/>
+          <a:ext cx="0" cy="0"/>
+          <a:chOff x="0" y="0"/>
+          <a:chExt cx="0" cy="0"/>
+        </a:xfrm>
+      </p:grpSpPr>
+      <p:sp>
+        <p:nvSpPr>
+          <p:cNvPr id="2" name="Slide Image Placeholder 1"/>
+          <p:cNvSpPr>
+            <a:spLocks noGrp="1" noRot="1" noChangeAspect="1"/>
+          </p:cNvSpPr>
+          <p:nvPr>
+            <p:ph type="sldImg"/>
+          </p:nvPr>
+        </p:nvSpPr>
+        <p:spPr/>
+      </p:sp>
+      <p:sp>
+        <p:nvSpPr>
+          <p:cNvPr id="3" name="Notes Placeholder 2"/>
+          <p:cNvSpPr>
+            <a:spLocks noGrp="1"/>
+          </p:cNvSpPr>
+          <p:nvPr>
+            <p:ph type="body" idx="1"/>
+          </p:nvPr>
+        </p:nvSpPr>
+        <p:spPr/>
+        <p:txBody>
+          <a:bodyPr/>
+          <a:lstStyle/>
+          <a:p>
+            <a:r>
+              <a:rPr lang="en-US" dirty="0"/>
+              <a:t>Slow down here. Read the six out loud. An hour ago every one of these was a thing they would have said needed an IT project.</a:t>
+            </a:r>
+            <a:endParaRPr lang="en-US" dirty="0"/>
+          </a:p>
+        </p:txBody>
+      </p:sp>
+      <p:sp>
+        <p:nvSpPr>
+          <p:cNvPr id="4" name="Slide Number Placeholder 3"/>
+          <p:cNvSpPr>
+            <a:spLocks noGrp="1"/>
+          </p:cNvSpPr>
+          <p:nvPr>
+            <p:ph type="sldNum" sz="quarter" idx="10"/>
+          </p:nvPr>
+        </p:nvSpPr>
+        <p:spPr/>
+        <p:txBody>
+          <a:bodyPr/>
+          <a:lstStyle/>
+          <a:p>
+            <a:fld id="{F7021451-1387-4CA6-816F-3879F97B5CBC}" type="slidenum">
+              <a:rPr lang="en-US"/>
+              <a:t>19</a:t>
             </a:fld>
             <a:endParaRPr lang="en-US"/>
           </a:p>
@@ -1423,6 +1513,94 @@
             <a:fld id="{F7021451-1387-4CA6-816F-3879F97B5CBC}" type="slidenum">
               <a:rPr lang="en-US"/>
               <a:t>2</a:t>
+            </a:fld>
+            <a:endParaRPr lang="en-US"/>
+          </a:p>
+        </p:txBody>
+      </p:sp>
+    </p:spTree>
+    <p:extLst>
+      <p:ext uri="{BB962C8B-B14F-4D97-AF65-F5344CB8AC3E}">
+        <p14:creationId xmlns:p14="http://schemas.microsoft.com/office/powerpoint/2010/main" val="1024086991"/>
+      </p:ext>
+    </p:extLst>
+  </p:cSld>
+  <p:clrMapOvr>
+    <a:masterClrMapping/>
+  </p:clrMapOvr>
+</p:notes>
+</file>
+
+<file path=ppt/notesSlides/notesSlide20.xml><?xml version="1.0" encoding="utf-8"?>
+<p:notes xmlns:a="http://schemas.openxmlformats.org/drawingml/2006/main" xmlns:r="http://schemas.openxmlformats.org/officeDocument/2006/relationships" xmlns:p="http://schemas.openxmlformats.org/presentationml/2006/main">
+  <p:cSld>
+    <p:spTree>
+      <p:nvGrpSpPr>
+        <p:cNvPr id="1" name=""/>
+        <p:cNvGrpSpPr/>
+        <p:nvPr/>
+      </p:nvGrpSpPr>
+      <p:grpSpPr>
+        <a:xfrm>
+          <a:off x="0" y="0"/>
+          <a:ext cx="0" cy="0"/>
+          <a:chOff x="0" y="0"/>
+          <a:chExt cx="0" cy="0"/>
+        </a:xfrm>
+      </p:grpSpPr>
+      <p:sp>
+        <p:nvSpPr>
+          <p:cNvPr id="2" name="Slide Image Placeholder 1"/>
+          <p:cNvSpPr>
+            <a:spLocks noGrp="1" noRot="1" noChangeAspect="1"/>
+          </p:cNvSpPr>
+          <p:nvPr>
+            <p:ph type="sldImg"/>
+          </p:nvPr>
+        </p:nvSpPr>
+        <p:spPr/>
+      </p:sp>
+      <p:sp>
+        <p:nvSpPr>
+          <p:cNvPr id="3" name="Notes Placeholder 2"/>
+          <p:cNvSpPr>
+            <a:spLocks noGrp="1"/>
+          </p:cNvSpPr>
+          <p:nvPr>
+            <p:ph type="body" idx="1"/>
+          </p:nvPr>
+        </p:nvSpPr>
+        <p:spPr/>
+        <p:txBody>
+          <a:bodyPr/>
+          <a:lstStyle/>
+          <a:p>
+            <a:r>
+              <a:rPr lang="en-US" dirty="0"/>
+              <a:t>Send them away with one instruction, not four: open the project instead of a new chat. Everything else is downstream of that habit. Then offer to come back in a month and look at what they built.</a:t>
+            </a:r>
+            <a:endParaRPr lang="en-US" dirty="0"/>
+          </a:p>
+        </p:txBody>
+      </p:sp>
+      <p:sp>
+        <p:nvSpPr>
+          <p:cNvPr id="4" name="Slide Number Placeholder 3"/>
+          <p:cNvSpPr>
+            <a:spLocks noGrp="1"/>
+          </p:cNvSpPr>
+          <p:nvPr>
+            <p:ph type="sldNum" sz="quarter" idx="10"/>
+          </p:nvPr>
+        </p:nvSpPr>
+        <p:spPr/>
+        <p:txBody>
+          <a:bodyPr/>
+          <a:lstStyle/>
+          <a:p>
+            <a:fld id="{F7021451-1387-4CA6-816F-3879F97B5CBC}" type="slidenum">
+              <a:rPr lang="en-US"/>
+              <a:t>20</a:t>
             </a:fld>
             <a:endParaRPr lang="en-US"/>
           </a:p>
@@ -3365,13 +3543,66 @@
       </p:sp>
       <p:sp>
         <p:nvSpPr>
-          <p:cNvPr id="10" name="Shape 7"/>
+          <p:cNvPr id="10" name="Text 7"/>
+          <p:cNvSpPr txBox="1"/>
+          <p:nvPr/>
+        </p:nvSpPr>
+        <p:spPr>
+          <a:xfrm>
+            <a:off x="777240" y="3752596"/>
+            <a:ext cx="10637215" cy="274320"/>
+          </a:xfrm>
+          <a:prstGeom prst="rect">
+            <a:avLst/>
+          </a:prstGeom>
+          <a:noFill/>
+          <a:ln/>
+        </p:spPr>
+        <p:txBody>
+          <a:bodyPr wrap="square" lIns="0" tIns="0" rIns="0" bIns="0" rtlCol="0" anchor="ctr"/>
+          <a:lstStyle/>
+          <a:p>
+            <a:pPr indent="0" marL="0">
+              <a:buNone/>
+            </a:pPr>
+            <a:r>
+              <a:rPr lang="en-US" sz="1000" spc="140" kern="0" dirty="0">
+                <a:solidFill>
+                  <a:srgbClr val="6055D8"/>
+                </a:solidFill>
+                <a:latin typeface="Courier New" pitchFamily="34" charset="0"/>
+                <a:ea typeface="Courier New" pitchFamily="34" charset="-122"/>
+                <a:cs typeface="Courier New" pitchFamily="34" charset="-120"/>
+              </a:rPr>
+              <a:t>IT LANDS IN   </a:t>
+            </a:r>
+            <a:pPr indent="0" marL="0">
+              <a:buNone/>
+            </a:pPr>
+            <a:r>
+              <a:rPr lang="en-US" sz="1300" dirty="0">
+                <a:solidFill>
+                  <a:srgbClr val="5B6270"/>
+                </a:solidFill>
+                <a:latin typeface="Courier New" pitchFamily="34" charset="0"/>
+                <a:ea typeface="Courier New" pitchFamily="34" charset="-122"/>
+                <a:cs typeface="Courier New" pitchFamily="34" charset="-120"/>
+              </a:rPr>
+              <a:t>01 - Company/Departments/   ·   its executive in   01 - Company/Roles/</a:t>
+            </a:r>
+            <a:endParaRPr lang="en-US" sz="1000" dirty="0"/>
+          </a:p>
+        </p:txBody>
+      </p:sp>
+      <p:sp>
+        <p:nvSpPr>
+          <p:cNvPr id="11" name="Shape 8"/>
           <p:cNvSpPr/>
           <p:nvPr/>
         </p:nvSpPr>
         <p:spPr>
           <a:xfrm>
-            <a:off x="777240" y="3917188"/>
+            <a:off x="777240" y="4246372"/>
             <a:ext cx="5029200" cy="1769618"/>
           </a:xfrm>
           <a:prstGeom prst="roundRect">
@@ -3392,13 +3623,13 @@
       </p:sp>
       <p:sp>
         <p:nvSpPr>
-          <p:cNvPr id="11" name="Text 8"/>
-          <p:cNvSpPr txBox="1"/>
-          <p:nvPr/>
-        </p:nvSpPr>
-        <p:spPr>
-          <a:xfrm>
-            <a:off x="1051560" y="4191508"/>
+          <p:cNvPr id="12" name="Text 9"/>
+          <p:cNvSpPr txBox="1"/>
+          <p:nvPr/>
+        </p:nvSpPr>
+        <p:spPr>
+          <a:xfrm>
+            <a:off x="1051560" y="4520692"/>
             <a:ext cx="4480560" cy="219456"/>
           </a:xfrm>
           <a:prstGeom prst="rect">
@@ -3431,13 +3662,13 @@
       </p:sp>
       <p:sp>
         <p:nvSpPr>
-          <p:cNvPr id="12" name="Text 9"/>
-          <p:cNvSpPr txBox="1"/>
-          <p:nvPr/>
-        </p:nvSpPr>
-        <p:spPr>
-          <a:xfrm>
-            <a:off x="1051560" y="4484116"/>
+          <p:cNvPr id="13" name="Text 10"/>
+          <p:cNvSpPr txBox="1"/>
+          <p:nvPr/>
+        </p:nvSpPr>
+        <p:spPr>
+          <a:xfrm>
+            <a:off x="1051560" y="4813300"/>
             <a:ext cx="4480560" cy="259080"/>
           </a:xfrm>
           <a:prstGeom prst="rect">
@@ -3473,13 +3704,13 @@
       </p:sp>
       <p:sp>
         <p:nvSpPr>
-          <p:cNvPr id="13" name="Text 10"/>
-          <p:cNvSpPr txBox="1"/>
-          <p:nvPr/>
-        </p:nvSpPr>
-        <p:spPr>
-          <a:xfrm>
-            <a:off x="1051560" y="4871212"/>
+          <p:cNvPr id="14" name="Text 11"/>
+          <p:cNvSpPr txBox="1"/>
+          <p:nvPr/>
+        </p:nvSpPr>
+        <p:spPr>
+          <a:xfrm>
+            <a:off x="1051560" y="5200396"/>
             <a:ext cx="4480560" cy="559562"/>
           </a:xfrm>
           <a:prstGeom prst="rect">
@@ -3515,13 +3746,13 @@
       </p:sp>
       <p:sp>
         <p:nvSpPr>
-          <p:cNvPr id="14" name="Shape 11"/>
+          <p:cNvPr id="15" name="Shape 12"/>
           <p:cNvSpPr/>
           <p:nvPr/>
         </p:nvSpPr>
         <p:spPr>
           <a:xfrm>
-            <a:off x="6172200" y="3917188"/>
+            <a:off x="6172200" y="4246372"/>
             <a:ext cx="5029200" cy="1769618"/>
           </a:xfrm>
           <a:prstGeom prst="roundRect">
@@ -3542,13 +3773,13 @@
       </p:sp>
       <p:sp>
         <p:nvSpPr>
-          <p:cNvPr id="15" name="Text 12"/>
-          <p:cNvSpPr txBox="1"/>
-          <p:nvPr/>
-        </p:nvSpPr>
-        <p:spPr>
-          <a:xfrm>
-            <a:off x="6446520" y="4191508"/>
+          <p:cNvPr id="16" name="Text 13"/>
+          <p:cNvSpPr txBox="1"/>
+          <p:nvPr/>
+        </p:nvSpPr>
+        <p:spPr>
+          <a:xfrm>
+            <a:off x="6446520" y="4520692"/>
             <a:ext cx="4480560" cy="219456"/>
           </a:xfrm>
           <a:prstGeom prst="rect">
@@ -3581,13 +3812,13 @@
       </p:sp>
       <p:sp>
         <p:nvSpPr>
-          <p:cNvPr id="16" name="Text 13"/>
-          <p:cNvSpPr txBox="1"/>
-          <p:nvPr/>
-        </p:nvSpPr>
-        <p:spPr>
-          <a:xfrm>
-            <a:off x="6446520" y="4484116"/>
+          <p:cNvPr id="17" name="Text 14"/>
+          <p:cNvSpPr txBox="1"/>
+          <p:nvPr/>
+        </p:nvSpPr>
+        <p:spPr>
+          <a:xfrm>
+            <a:off x="6446520" y="4813300"/>
             <a:ext cx="4480560" cy="259080"/>
           </a:xfrm>
           <a:prstGeom prst="rect">
@@ -3623,13 +3854,13 @@
       </p:sp>
       <p:sp>
         <p:nvSpPr>
-          <p:cNvPr id="17" name="Text 14"/>
-          <p:cNvSpPr txBox="1"/>
-          <p:nvPr/>
-        </p:nvSpPr>
-        <p:spPr>
-          <a:xfrm>
-            <a:off x="6446520" y="4871212"/>
+          <p:cNvPr id="18" name="Text 15"/>
+          <p:cNvSpPr txBox="1"/>
+          <p:nvPr/>
+        </p:nvSpPr>
+        <p:spPr>
+          <a:xfrm>
+            <a:off x="6446520" y="5200396"/>
             <a:ext cx="4480560" cy="559562"/>
           </a:xfrm>
           <a:prstGeom prst="rect">
@@ -3665,7 +3896,7 @@
       </p:sp>
       <p:sp>
         <p:nvSpPr>
-          <p:cNvPr id="18" name="Text 15"/>
+          <p:cNvPr id="19" name="Text 16"/>
           <p:cNvSpPr txBox="1"/>
           <p:nvPr/>
         </p:nvSpPr>
@@ -5003,18 +5234,71 @@
       </p:sp>
       <p:sp>
         <p:nvSpPr>
-          <p:cNvPr id="10" name="Shape 7"/>
+          <p:cNvPr id="10" name="Text 7"/>
+          <p:cNvSpPr txBox="1"/>
+          <p:nvPr/>
+        </p:nvSpPr>
+        <p:spPr>
+          <a:xfrm>
+            <a:off x="777240" y="3752596"/>
+            <a:ext cx="10637215" cy="274320"/>
+          </a:xfrm>
+          <a:prstGeom prst="rect">
+            <a:avLst/>
+          </a:prstGeom>
+          <a:noFill/>
+          <a:ln/>
+        </p:spPr>
+        <p:txBody>
+          <a:bodyPr wrap="square" lIns="0" tIns="0" rIns="0" bIns="0" rtlCol="0" anchor="ctr"/>
+          <a:lstStyle/>
+          <a:p>
+            <a:pPr indent="0" marL="0">
+              <a:buNone/>
+            </a:pPr>
+            <a:r>
+              <a:rPr lang="en-US" sz="1000" spc="140" kern="0" dirty="0">
+                <a:solidFill>
+                  <a:srgbClr val="6055D8"/>
+                </a:solidFill>
+                <a:latin typeface="Courier New" pitchFamily="34" charset="0"/>
+                <a:ea typeface="Courier New" pitchFamily="34" charset="-122"/>
+                <a:cs typeface="Courier New" pitchFamily="34" charset="-120"/>
+              </a:rPr>
+              <a:t>IT LANDS IN   </a:t>
+            </a:r>
+            <a:pPr indent="0" marL="0">
+              <a:buNone/>
+            </a:pPr>
+            <a:r>
+              <a:rPr lang="en-US" sz="1300" dirty="0">
+                <a:solidFill>
+                  <a:srgbClr val="5B6270"/>
+                </a:solidFill>
+                <a:latin typeface="Courier New" pitchFamily="34" charset="0"/>
+                <a:ea typeface="Courier New" pitchFamily="34" charset="-122"/>
+                <a:cs typeface="Courier New" pitchFamily="34" charset="-120"/>
+              </a:rPr>
+              <a:t>.claude/skills/{your-skill}/SKILL.md</a:t>
+            </a:r>
+            <a:endParaRPr lang="en-US" sz="1000" dirty="0"/>
+          </a:p>
+        </p:txBody>
+      </p:sp>
+      <p:sp>
+        <p:nvSpPr>
+          <p:cNvPr id="11" name="Shape 8"/>
           <p:cNvSpPr/>
           <p:nvPr/>
         </p:nvSpPr>
         <p:spPr>
           <a:xfrm>
-            <a:off x="777240" y="3917188"/>
-            <a:ext cx="5029200" cy="2004060"/>
+            <a:off x="777240" y="4246372"/>
+            <a:ext cx="5029200" cy="1751584"/>
           </a:xfrm>
           <a:prstGeom prst="roundRect">
             <a:avLst>
-              <a:gd name="adj" fmla="val 2738"/>
+              <a:gd name="adj" fmla="val 3132"/>
             </a:avLst>
           </a:prstGeom>
           <a:solidFill>
@@ -5030,13 +5314,13 @@
       </p:sp>
       <p:sp>
         <p:nvSpPr>
-          <p:cNvPr id="11" name="Text 8"/>
-          <p:cNvSpPr txBox="1"/>
-          <p:nvPr/>
-        </p:nvSpPr>
-        <p:spPr>
-          <a:xfrm>
-            <a:off x="1051560" y="4191508"/>
+          <p:cNvPr id="12" name="Text 9"/>
+          <p:cNvSpPr txBox="1"/>
+          <p:nvPr/>
+        </p:nvSpPr>
+        <p:spPr>
+          <a:xfrm>
+            <a:off x="1051560" y="4520692"/>
             <a:ext cx="4480560" cy="219456"/>
           </a:xfrm>
           <a:prstGeom prst="rect">
@@ -5069,13 +5353,13 @@
       </p:sp>
       <p:sp>
         <p:nvSpPr>
-          <p:cNvPr id="12" name="Text 9"/>
-          <p:cNvSpPr txBox="1"/>
-          <p:nvPr/>
-        </p:nvSpPr>
-        <p:spPr>
-          <a:xfrm>
-            <a:off x="1051560" y="4484116"/>
+          <p:cNvPr id="13" name="Text 10"/>
+          <p:cNvSpPr txBox="1"/>
+          <p:nvPr/>
+        </p:nvSpPr>
+        <p:spPr>
+          <a:xfrm>
+            <a:off x="1051560" y="4813300"/>
             <a:ext cx="4480560" cy="259080"/>
           </a:xfrm>
           <a:prstGeom prst="rect">
@@ -5111,14 +5395,14 @@
       </p:sp>
       <p:sp>
         <p:nvSpPr>
-          <p:cNvPr id="13" name="Text 10"/>
-          <p:cNvSpPr txBox="1"/>
-          <p:nvPr/>
-        </p:nvSpPr>
-        <p:spPr>
-          <a:xfrm>
-            <a:off x="1051560" y="4871212"/>
-            <a:ext cx="4480560" cy="794004"/>
+          <p:cNvPr id="14" name="Text 11"/>
+          <p:cNvSpPr txBox="1"/>
+          <p:nvPr/>
+        </p:nvSpPr>
+        <p:spPr>
+          <a:xfrm>
+            <a:off x="1051560" y="5200396"/>
+            <a:ext cx="4480560" cy="541528"/>
           </a:xfrm>
           <a:prstGeom prst="rect">
             <a:avLst/>
@@ -5145,7 +5429,7 @@
                 <a:ea typeface="Public Sans" pitchFamily="34" charset="-122"/>
                 <a:cs typeface="Public Sans" pitchFamily="34" charset="-120"/>
               </a:rPr>
-              <a:t>When to use it, the steps, where it stops. The catalog reads itself off the folder, so it is listed the moment it exists.</a:t>
+              <a:t>When to use it, the steps, where it stops. The catalog lists it the moment it exists.</a:t>
             </a:r>
             <a:endParaRPr lang="en-US" sz="1400" dirty="0"/>
           </a:p>
@@ -5153,18 +5437,18 @@
       </p:sp>
       <p:sp>
         <p:nvSpPr>
-          <p:cNvPr id="14" name="Shape 11"/>
+          <p:cNvPr id="15" name="Shape 12"/>
           <p:cNvSpPr/>
           <p:nvPr/>
         </p:nvSpPr>
         <p:spPr>
           <a:xfrm>
-            <a:off x="6172200" y="3917188"/>
-            <a:ext cx="5029200" cy="2004060"/>
+            <a:off x="6172200" y="4246372"/>
+            <a:ext cx="5029200" cy="1751584"/>
           </a:xfrm>
           <a:prstGeom prst="roundRect">
             <a:avLst>
-              <a:gd name="adj" fmla="val 2738"/>
+              <a:gd name="adj" fmla="val 3132"/>
             </a:avLst>
           </a:prstGeom>
           <a:solidFill>
@@ -5180,13 +5464,13 @@
       </p:sp>
       <p:sp>
         <p:nvSpPr>
-          <p:cNvPr id="15" name="Text 12"/>
-          <p:cNvSpPr txBox="1"/>
-          <p:nvPr/>
-        </p:nvSpPr>
-        <p:spPr>
-          <a:xfrm>
-            <a:off x="6446520" y="4191508"/>
+          <p:cNvPr id="16" name="Text 13"/>
+          <p:cNvSpPr txBox="1"/>
+          <p:nvPr/>
+        </p:nvSpPr>
+        <p:spPr>
+          <a:xfrm>
+            <a:off x="6446520" y="4520692"/>
             <a:ext cx="4480560" cy="219456"/>
           </a:xfrm>
           <a:prstGeom prst="rect">
@@ -5219,13 +5503,13 @@
       </p:sp>
       <p:sp>
         <p:nvSpPr>
-          <p:cNvPr id="16" name="Text 13"/>
-          <p:cNvSpPr txBox="1"/>
-          <p:nvPr/>
-        </p:nvSpPr>
-        <p:spPr>
-          <a:xfrm>
-            <a:off x="6446520" y="4484116"/>
+          <p:cNvPr id="17" name="Text 14"/>
+          <p:cNvSpPr txBox="1"/>
+          <p:nvPr/>
+        </p:nvSpPr>
+        <p:spPr>
+          <a:xfrm>
+            <a:off x="6446520" y="4813300"/>
             <a:ext cx="4480560" cy="259080"/>
           </a:xfrm>
           <a:prstGeom prst="rect">
@@ -5261,14 +5545,14 @@
       </p:sp>
       <p:sp>
         <p:nvSpPr>
-          <p:cNvPr id="17" name="Text 14"/>
-          <p:cNvSpPr txBox="1"/>
-          <p:nvPr/>
-        </p:nvSpPr>
-        <p:spPr>
-          <a:xfrm>
-            <a:off x="6446520" y="4871212"/>
-            <a:ext cx="4480560" cy="794004"/>
+          <p:cNvPr id="18" name="Text 15"/>
+          <p:cNvSpPr txBox="1"/>
+          <p:nvPr/>
+        </p:nvSpPr>
+        <p:spPr>
+          <a:xfrm>
+            <a:off x="6446520" y="5200396"/>
+            <a:ext cx="4480560" cy="541528"/>
           </a:xfrm>
           <a:prstGeom prst="rect">
             <a:avLst/>
@@ -5303,7 +5587,7 @@
       </p:sp>
       <p:sp>
         <p:nvSpPr>
-          <p:cNvPr id="18" name="Text 15"/>
+          <p:cNvPr id="19" name="Text 16"/>
           <p:cNvSpPr txBox="1"/>
           <p:nvPr/>
         </p:nvSpPr>
@@ -5692,13 +5976,66 @@
       </p:sp>
       <p:sp>
         <p:nvSpPr>
-          <p:cNvPr id="10" name="Shape 7"/>
+          <p:cNvPr id="10" name="Text 7"/>
+          <p:cNvSpPr txBox="1"/>
+          <p:nvPr/>
+        </p:nvSpPr>
+        <p:spPr>
+          <a:xfrm>
+            <a:off x="777240" y="3752596"/>
+            <a:ext cx="10637215" cy="274320"/>
+          </a:xfrm>
+          <a:prstGeom prst="rect">
+            <a:avLst/>
+          </a:prstGeom>
+          <a:noFill/>
+          <a:ln/>
+        </p:spPr>
+        <p:txBody>
+          <a:bodyPr wrap="square" lIns="0" tIns="0" rIns="0" bIns="0" rtlCol="0" anchor="ctr"/>
+          <a:lstStyle/>
+          <a:p>
+            <a:pPr indent="0" marL="0">
+              <a:buNone/>
+            </a:pPr>
+            <a:r>
+              <a:rPr lang="en-US" sz="1000" spc="140" kern="0" dirty="0">
+                <a:solidFill>
+                  <a:srgbClr val="6055D8"/>
+                </a:solidFill>
+                <a:latin typeface="Courier New" pitchFamily="34" charset="0"/>
+                <a:ea typeface="Courier New" pitchFamily="34" charset="-122"/>
+                <a:cs typeface="Courier New" pitchFamily="34" charset="-120"/>
+              </a:rPr>
+              <a:t>IT LANDS IN   </a:t>
+            </a:r>
+            <a:pPr indent="0" marL="0">
+              <a:buNone/>
+            </a:pPr>
+            <a:r>
+              <a:rPr lang="en-US" sz="1300" dirty="0">
+                <a:solidFill>
+                  <a:srgbClr val="5B6270"/>
+                </a:solidFill>
+                <a:latin typeface="Courier New" pitchFamily="34" charset="0"/>
+                <a:ea typeface="Courier New" pitchFamily="34" charset="-122"/>
+                <a:cs typeface="Courier New" pitchFamily="34" charset="-120"/>
+              </a:rPr>
+              <a:t>01 - Company/Roles/{Name}.md   with   kind: specialist</a:t>
+            </a:r>
+            <a:endParaRPr lang="en-US" sz="1000" dirty="0"/>
+          </a:p>
+        </p:txBody>
+      </p:sp>
+      <p:sp>
+        <p:nvSpPr>
+          <p:cNvPr id="11" name="Shape 8"/>
           <p:cNvSpPr/>
           <p:nvPr/>
         </p:nvSpPr>
         <p:spPr>
           <a:xfrm>
-            <a:off x="777240" y="3917188"/>
+            <a:off x="777240" y="4246372"/>
             <a:ext cx="5029200" cy="1751584"/>
           </a:xfrm>
           <a:prstGeom prst="roundRect">
@@ -5719,13 +6056,13 @@
       </p:sp>
       <p:sp>
         <p:nvSpPr>
-          <p:cNvPr id="11" name="Text 8"/>
-          <p:cNvSpPr txBox="1"/>
-          <p:nvPr/>
-        </p:nvSpPr>
-        <p:spPr>
-          <a:xfrm>
-            <a:off x="1051560" y="4191508"/>
+          <p:cNvPr id="12" name="Text 9"/>
+          <p:cNvSpPr txBox="1"/>
+          <p:nvPr/>
+        </p:nvSpPr>
+        <p:spPr>
+          <a:xfrm>
+            <a:off x="1051560" y="4520692"/>
             <a:ext cx="4480560" cy="219456"/>
           </a:xfrm>
           <a:prstGeom prst="rect">
@@ -5758,13 +6095,13 @@
       </p:sp>
       <p:sp>
         <p:nvSpPr>
-          <p:cNvPr id="12" name="Text 9"/>
-          <p:cNvSpPr txBox="1"/>
-          <p:nvPr/>
-        </p:nvSpPr>
-        <p:spPr>
-          <a:xfrm>
-            <a:off x="1051560" y="4484116"/>
+          <p:cNvPr id="13" name="Text 10"/>
+          <p:cNvSpPr txBox="1"/>
+          <p:nvPr/>
+        </p:nvSpPr>
+        <p:spPr>
+          <a:xfrm>
+            <a:off x="1051560" y="4813300"/>
             <a:ext cx="4480560" cy="259080"/>
           </a:xfrm>
           <a:prstGeom prst="rect">
@@ -5800,13 +6137,13 @@
       </p:sp>
       <p:sp>
         <p:nvSpPr>
-          <p:cNvPr id="13" name="Text 10"/>
-          <p:cNvSpPr txBox="1"/>
-          <p:nvPr/>
-        </p:nvSpPr>
-        <p:spPr>
-          <a:xfrm>
-            <a:off x="1051560" y="4871212"/>
+          <p:cNvPr id="14" name="Text 11"/>
+          <p:cNvSpPr txBox="1"/>
+          <p:nvPr/>
+        </p:nvSpPr>
+        <p:spPr>
+          <a:xfrm>
+            <a:off x="1051560" y="5200396"/>
             <a:ext cx="4480560" cy="541528"/>
           </a:xfrm>
           <a:prstGeom prst="rect">
@@ -5842,13 +6179,13 @@
       </p:sp>
       <p:sp>
         <p:nvSpPr>
-          <p:cNvPr id="14" name="Shape 11"/>
+          <p:cNvPr id="15" name="Shape 12"/>
           <p:cNvSpPr/>
           <p:nvPr/>
         </p:nvSpPr>
         <p:spPr>
           <a:xfrm>
-            <a:off x="6172200" y="3917188"/>
+            <a:off x="6172200" y="4246372"/>
             <a:ext cx="5029200" cy="1751584"/>
           </a:xfrm>
           <a:prstGeom prst="roundRect">
@@ -5869,13 +6206,13 @@
       </p:sp>
       <p:sp>
         <p:nvSpPr>
-          <p:cNvPr id="15" name="Text 12"/>
-          <p:cNvSpPr txBox="1"/>
-          <p:nvPr/>
-        </p:nvSpPr>
-        <p:spPr>
-          <a:xfrm>
-            <a:off x="6446520" y="4191508"/>
+          <p:cNvPr id="16" name="Text 13"/>
+          <p:cNvSpPr txBox="1"/>
+          <p:nvPr/>
+        </p:nvSpPr>
+        <p:spPr>
+          <a:xfrm>
+            <a:off x="6446520" y="4520692"/>
             <a:ext cx="4480560" cy="219456"/>
           </a:xfrm>
           <a:prstGeom prst="rect">
@@ -5908,13 +6245,13 @@
       </p:sp>
       <p:sp>
         <p:nvSpPr>
-          <p:cNvPr id="16" name="Text 13"/>
-          <p:cNvSpPr txBox="1"/>
-          <p:nvPr/>
-        </p:nvSpPr>
-        <p:spPr>
-          <a:xfrm>
-            <a:off x="6446520" y="4484116"/>
+          <p:cNvPr id="17" name="Text 14"/>
+          <p:cNvSpPr txBox="1"/>
+          <p:nvPr/>
+        </p:nvSpPr>
+        <p:spPr>
+          <a:xfrm>
+            <a:off x="6446520" y="4813300"/>
             <a:ext cx="4480560" cy="259080"/>
           </a:xfrm>
           <a:prstGeom prst="rect">
@@ -5950,13 +6287,13 @@
       </p:sp>
       <p:sp>
         <p:nvSpPr>
-          <p:cNvPr id="17" name="Text 14"/>
-          <p:cNvSpPr txBox="1"/>
-          <p:nvPr/>
-        </p:nvSpPr>
-        <p:spPr>
-          <a:xfrm>
-            <a:off x="6446520" y="4871212"/>
+          <p:cNvPr id="18" name="Text 15"/>
+          <p:cNvSpPr txBox="1"/>
+          <p:nvPr/>
+        </p:nvSpPr>
+        <p:spPr>
+          <a:xfrm>
+            <a:off x="6446520" y="5200396"/>
             <a:ext cx="4480560" cy="541528"/>
           </a:xfrm>
           <a:prstGeom prst="rect">
@@ -5992,7 +6329,7 @@
       </p:sp>
       <p:sp>
         <p:nvSpPr>
-          <p:cNvPr id="18" name="Text 15"/>
+          <p:cNvPr id="19" name="Text 16"/>
           <p:cNvSpPr txBox="1"/>
           <p:nvPr/>
         </p:nvSpPr>
@@ -6094,7 +6431,7 @@
                 <a:ea typeface="Courier New" pitchFamily="34" charset="-122"/>
                 <a:cs typeface="Courier New" pitchFamily="34" charset="-120"/>
               </a:rPr>
-              <a:t>WHAT THE LAYER PRODUCES</a:t>
+              <a:t>HANDS ON · TOGETHER</a:t>
             </a:r>
             <a:endParaRPr lang="en-US" sz="1100" dirty="0"/>
           </a:p>
@@ -6126,14 +6463,73 @@
       </p:pic>
       <p:sp>
         <p:nvSpPr>
-          <p:cNvPr id="4" name="Text 1"/>
-          <p:cNvSpPr txBox="1"/>
+          <p:cNvPr id="4" name="Shape 1"/>
+          <p:cNvSpPr/>
           <p:nvPr/>
         </p:nvSpPr>
         <p:spPr>
           <a:xfrm>
             <a:off x="777240" y="868680"/>
-            <a:ext cx="9951415" cy="914400"/>
+            <a:ext cx="868680" cy="868680"/>
+          </a:xfrm>
+          <a:prstGeom prst="ellipse">
+            <a:avLst/>
+          </a:prstGeom>
+          <a:solidFill>
+            <a:srgbClr val="7367F0"/>
+          </a:solidFill>
+          <a:ln/>
+        </p:spPr>
+      </p:sp>
+      <p:sp>
+        <p:nvSpPr>
+          <p:cNvPr id="5" name="Text 2"/>
+          <p:cNvSpPr txBox="1"/>
+          <p:nvPr/>
+        </p:nvSpPr>
+        <p:spPr>
+          <a:xfrm>
+            <a:off x="777240" y="868680"/>
+            <a:ext cx="868680" cy="868680"/>
+          </a:xfrm>
+          <a:prstGeom prst="rect">
+            <a:avLst/>
+          </a:prstGeom>
+          <a:noFill/>
+          <a:ln/>
+        </p:spPr>
+        <p:txBody>
+          <a:bodyPr wrap="square" lIns="0" tIns="0" rIns="0" bIns="0" rtlCol="0" anchor="ctr"/>
+          <a:lstStyle/>
+          <a:p>
+            <a:pPr algn="ctr" indent="0" marL="0">
+              <a:buNone/>
+            </a:pPr>
+            <a:r>
+              <a:rPr lang="en-US" sz="3400" b="1" dirty="0">
+                <a:solidFill>
+                  <a:srgbClr val="FFFFFF"/>
+                </a:solidFill>
+                <a:latin typeface="Public Sans" pitchFamily="34" charset="0"/>
+                <a:ea typeface="Public Sans" pitchFamily="34" charset="-122"/>
+                <a:cs typeface="Public Sans" pitchFamily="34" charset="-120"/>
+              </a:rPr>
+              <a:t>8</a:t>
+            </a:r>
+            <a:endParaRPr lang="en-US" sz="3400" dirty="0"/>
+          </a:p>
+        </p:txBody>
+      </p:sp>
+      <p:sp>
+        <p:nvSpPr>
+          <p:cNvPr id="6" name="Text 3"/>
+          <p:cNvSpPr txBox="1"/>
+          <p:nvPr/>
+        </p:nvSpPr>
+        <p:spPr>
+          <a:xfrm>
+            <a:off x="2011680" y="868680"/>
+            <a:ext cx="9402775" cy="868680"/>
           </a:xfrm>
           <a:prstGeom prst="rect">
             <a:avLst/>
@@ -6147,7 +6543,7 @@
           <a:p>
             <a:pPr indent="0" marL="0">
               <a:lnSpc>
-                <a:spcPts val="3596"/>
+                <a:spcPts val="3600"/>
               </a:lnSpc>
               <a:buNone/>
             </a:pPr>
@@ -6160,7 +6556,7 @@
                 <a:ea typeface="Public Sans" pitchFamily="34" charset="-122"/>
                 <a:cs typeface="Public Sans" pitchFamily="34" charset="-120"/>
               </a:rPr>
-              <a:t>Workflows and projects belong to a department</a:t>
+              <a:t>Write one workflow down</a:t>
             </a:r>
             <a:endParaRPr lang="en-US" sz="3100" dirty="0"/>
           </a:p>
@@ -6168,84 +6564,225 @@
       </p:sp>
       <p:sp>
         <p:nvSpPr>
-          <p:cNvPr id="5" name="Text 2"/>
-          <p:cNvSpPr txBox="1"/>
-          <p:nvPr/>
-        </p:nvSpPr>
-        <p:spPr>
-          <a:xfrm>
-            <a:off x="777240" y="1627632"/>
-            <a:ext cx="10637215" cy="566928"/>
-          </a:xfrm>
-          <a:prstGeom prst="rect">
-            <a:avLst/>
-          </a:prstGeom>
-          <a:noFill/>
-          <a:ln/>
-        </p:spPr>
-        <p:txBody>
-          <a:bodyPr wrap="square" lIns="0" tIns="0" rIns="0" bIns="0" rtlCol="0" anchor="ctr"/>
-          <a:lstStyle/>
-          <a:p>
-            <a:pPr indent="0" marL="0">
-              <a:lnSpc>
-                <a:spcPts val="2300"/>
-              </a:lnSpc>
-              <a:buNone/>
-            </a:pPr>
-            <a:r>
-              <a:rPr lang="en-US" sz="1600" dirty="0">
-                <a:solidFill>
-                  <a:srgbClr val="5B6270"/>
-                </a:solidFill>
-                <a:latin typeface="Public Sans" pitchFamily="34" charset="0"/>
-                <a:ea typeface="Public Sans" pitchFamily="34" charset="-122"/>
-                <a:cs typeface="Public Sans" pitchFamily="34" charset="-120"/>
-              </a:rPr>
-              <a:t>A workflow is how work happens. A project is work with an end.</a:t>
-            </a:r>
-            <a:endParaRPr lang="en-US" sz="1600" dirty="0"/>
-          </a:p>
-        </p:txBody>
-      </p:sp>
-      <p:pic>
-        <p:nvPicPr>
-          <p:cNvPr id="6" name="Image 1" descr="/tmp/claude-0/-home-claude/e62a35b1-5075-553d-b086-acebfebc41ba/scratchpad/deck/n-steps.png">    </p:cNvPr>
-          <p:cNvPicPr>
-            <a:picLocks noChangeAspect="1"/>
-          </p:cNvPicPr>
-          <p:nvPr/>
-        </p:nvPicPr>
-        <p:blipFill>
-          <a:blip r:embed="rId2"/>
-          <a:stretch>
-            <a:fillRect/>
-          </a:stretch>
-        </p:blipFill>
-        <p:spPr>
-          <a:xfrm>
-            <a:off x="777240" y="2286000"/>
-            <a:ext cx="6172200" cy="3794760"/>
-          </a:xfrm>
-          <a:prstGeom prst="rect">
-            <a:avLst/>
-          </a:prstGeom>
-        </p:spPr>
-      </p:pic>
-      <p:sp>
-        <p:nvSpPr>
-          <p:cNvPr id="7" name="Shape 3"/>
+          <p:cNvPr id="7" name="Shape 4"/>
           <p:cNvSpPr/>
           <p:nvPr/>
         </p:nvSpPr>
         <p:spPr>
           <a:xfrm>
-            <a:off x="7242048" y="2286000"/>
-            <a:ext cx="4169664" cy="1961769"/>
+            <a:off x="777240" y="1938528"/>
+            <a:ext cx="10637215" cy="1236472"/>
           </a:xfrm>
           <a:prstGeom prst="roundRect">
             <a:avLst>
-              <a:gd name="adj" fmla="val 2797"/>
+              <a:gd name="adj" fmla="val 4437"/>
+            </a:avLst>
+          </a:prstGeom>
+          <a:solidFill>
+            <a:srgbClr val="F0EEFC"/>
+          </a:solidFill>
+          <a:ln w="17780">
+            <a:solidFill>
+              <a:srgbClr val="C4BDFF"/>
+            </a:solidFill>
+            <a:prstDash val="solid"/>
+          </a:ln>
+        </p:spPr>
+      </p:sp>
+      <p:sp>
+        <p:nvSpPr>
+          <p:cNvPr id="8" name="Text 5"/>
+          <p:cNvSpPr txBox="1"/>
+          <p:nvPr/>
+        </p:nvSpPr>
+        <p:spPr>
+          <a:xfrm>
+            <a:off x="1143000" y="1938528"/>
+            <a:ext cx="9905695" cy="1236472"/>
+          </a:xfrm>
+          <a:prstGeom prst="rect">
+            <a:avLst/>
+          </a:prstGeom>
+          <a:noFill/>
+          <a:ln/>
+        </p:spPr>
+        <p:txBody>
+          <a:bodyPr wrap="square" lIns="0" tIns="0" rIns="0" bIns="0" rtlCol="0" anchor="ctr"/>
+          <a:lstStyle/>
+          <a:p>
+            <a:pPr indent="0" marL="0">
+              <a:lnSpc>
+                <a:spcPts val="2600"/>
+              </a:lnSpc>
+              <a:buNone/>
+            </a:pPr>
+            <a:r>
+              <a:rPr lang="en-US" sz="1050" spc="160" kern="0" dirty="0">
+                <a:solidFill>
+                  <a:srgbClr val="6055D8"/>
+                </a:solidFill>
+                <a:latin typeface="Courier New" pitchFamily="34" charset="0"/>
+                <a:ea typeface="Courier New" pitchFamily="34" charset="-122"/>
+                <a:cs typeface="Courier New" pitchFamily="34" charset="-120"/>
+              </a:rPr>
+              <a:t>DO THIS NOW   </a:t>
+            </a:r>
+            <a:pPr indent="0" marL="0">
+              <a:lnSpc>
+                <a:spcPts val="2600"/>
+              </a:lnSpc>
+              <a:buNone/>
+            </a:pPr>
+            <a:endParaRPr lang="en-US" sz="1050" dirty="0"/>
+          </a:p>
+          <a:p>
+            <a:pPr indent="0" marL="0">
+              <a:lnSpc>
+                <a:spcPts val="2600"/>
+              </a:lnSpc>
+              <a:buNone/>
+            </a:pPr>
+            <a:r>
+              <a:rPr lang="en-US" sz="1700" b="1" dirty="0">
+                <a:solidFill>
+                  <a:srgbClr val="15171F"/>
+                </a:solidFill>
+                <a:latin typeface="Public Sans" pitchFamily="34" charset="0"/>
+                <a:ea typeface="Public Sans" pitchFamily="34" charset="-122"/>
+                <a:cs typeface="Public Sans" pitchFamily="34" charset="-120"/>
+              </a:rPr>
+              <a:t>Pick something you do the same way every time. Say: write down how it happens.</a:t>
+            </a:r>
+            <a:endParaRPr lang="en-US" sz="1050" dirty="0"/>
+          </a:p>
+        </p:txBody>
+      </p:sp>
+      <p:sp>
+        <p:nvSpPr>
+          <p:cNvPr id="9" name="Text 6"/>
+          <p:cNvSpPr txBox="1"/>
+          <p:nvPr/>
+        </p:nvSpPr>
+        <p:spPr>
+          <a:xfrm>
+            <a:off x="777240" y="3339592"/>
+            <a:ext cx="10637215" cy="588264"/>
+          </a:xfrm>
+          <a:prstGeom prst="rect">
+            <a:avLst/>
+          </a:prstGeom>
+          <a:noFill/>
+          <a:ln/>
+        </p:spPr>
+        <p:txBody>
+          <a:bodyPr wrap="square" lIns="0" tIns="0" rIns="0" bIns="0" rtlCol="0" anchor="ctr"/>
+          <a:lstStyle/>
+          <a:p>
+            <a:pPr indent="0" marL="0">
+              <a:lnSpc>
+                <a:spcPts val="2100"/>
+              </a:lnSpc>
+              <a:buNone/>
+            </a:pPr>
+            <a:r>
+              <a:rPr lang="en-US" sz="1450" b="1" dirty="0">
+                <a:solidFill>
+                  <a:srgbClr val="15171F"/>
+                </a:solidFill>
+                <a:latin typeface="Public Sans" pitchFamily="34" charset="0"/>
+                <a:ea typeface="Public Sans" pitchFamily="34" charset="-122"/>
+                <a:cs typeface="Public Sans" pitchFamily="34" charset="-120"/>
+              </a:rPr>
+              <a:t>You will know it worked when  </a:t>
+            </a:r>
+            <a:pPr indent="0" marL="0">
+              <a:lnSpc>
+                <a:spcPts val="2100"/>
+              </a:lnSpc>
+              <a:buNone/>
+            </a:pPr>
+            <a:r>
+              <a:rPr lang="en-US" sz="1450" dirty="0">
+                <a:solidFill>
+                  <a:srgbClr val="5B6270"/>
+                </a:solidFill>
+                <a:latin typeface="Public Sans" pitchFamily="34" charset="0"/>
+                <a:ea typeface="Public Sans" pitchFamily="34" charset="-122"/>
+                <a:cs typeface="Public Sans" pitchFamily="34" charset="-120"/>
+              </a:rPr>
+              <a:t>a workflow note appears with a step table, both marks set, and the honest ones set to not-yet.</a:t>
+            </a:r>
+            <a:endParaRPr lang="en-US" sz="1450" dirty="0"/>
+          </a:p>
+        </p:txBody>
+      </p:sp>
+      <p:sp>
+        <p:nvSpPr>
+          <p:cNvPr id="10" name="Text 7"/>
+          <p:cNvSpPr txBox="1"/>
+          <p:nvPr/>
+        </p:nvSpPr>
+        <p:spPr>
+          <a:xfrm>
+            <a:off x="777240" y="4019296"/>
+            <a:ext cx="10637215" cy="274320"/>
+          </a:xfrm>
+          <a:prstGeom prst="rect">
+            <a:avLst/>
+          </a:prstGeom>
+          <a:noFill/>
+          <a:ln/>
+        </p:spPr>
+        <p:txBody>
+          <a:bodyPr wrap="square" lIns="0" tIns="0" rIns="0" bIns="0" rtlCol="0" anchor="ctr"/>
+          <a:lstStyle/>
+          <a:p>
+            <a:pPr indent="0" marL="0">
+              <a:buNone/>
+            </a:pPr>
+            <a:r>
+              <a:rPr lang="en-US" sz="1000" spc="140" kern="0" dirty="0">
+                <a:solidFill>
+                  <a:srgbClr val="6055D8"/>
+                </a:solidFill>
+                <a:latin typeface="Courier New" pitchFamily="34" charset="0"/>
+                <a:ea typeface="Courier New" pitchFamily="34" charset="-122"/>
+                <a:cs typeface="Courier New" pitchFamily="34" charset="-120"/>
+              </a:rPr>
+              <a:t>IT LANDS IN   </a:t>
+            </a:r>
+            <a:pPr indent="0" marL="0">
+              <a:buNone/>
+            </a:pPr>
+            <a:r>
+              <a:rPr lang="en-US" sz="1300" dirty="0">
+                <a:solidFill>
+                  <a:srgbClr val="5B6270"/>
+                </a:solidFill>
+                <a:latin typeface="Courier New" pitchFamily="34" charset="0"/>
+                <a:ea typeface="Courier New" pitchFamily="34" charset="-122"/>
+                <a:cs typeface="Courier New" pitchFamily="34" charset="-120"/>
+              </a:rPr>
+              <a:t>01 - Company/Workflows/{What It Does}.md</a:t>
+            </a:r>
+            <a:endParaRPr lang="en-US" sz="1000" dirty="0"/>
+          </a:p>
+        </p:txBody>
+      </p:sp>
+      <p:sp>
+        <p:nvSpPr>
+          <p:cNvPr id="11" name="Shape 8"/>
+          <p:cNvSpPr/>
+          <p:nvPr/>
+        </p:nvSpPr>
+        <p:spPr>
+          <a:xfrm>
+            <a:off x="777240" y="4513072"/>
+            <a:ext cx="5029200" cy="1751584"/>
+          </a:xfrm>
+          <a:prstGeom prst="roundRect">
+            <a:avLst>
+              <a:gd name="adj" fmla="val 3132"/>
             </a:avLst>
           </a:prstGeom>
           <a:solidFill>
@@ -6261,14 +6798,14 @@
       </p:sp>
       <p:sp>
         <p:nvSpPr>
-          <p:cNvPr id="8" name="Text 4"/>
-          <p:cNvSpPr txBox="1"/>
-          <p:nvPr/>
-        </p:nvSpPr>
-        <p:spPr>
-          <a:xfrm>
-            <a:off x="7516368" y="2560320"/>
-            <a:ext cx="3621024" cy="219456"/>
+          <p:cNvPr id="12" name="Text 9"/>
+          <p:cNvSpPr txBox="1"/>
+          <p:nvPr/>
+        </p:nvSpPr>
+        <p:spPr>
+          <a:xfrm>
+            <a:off x="1051560" y="4787392"/>
+            <a:ext cx="4480560" cy="219456"/>
           </a:xfrm>
           <a:prstGeom prst="rect">
             <a:avLst/>
@@ -6292,7 +6829,7 @@
                 <a:ea typeface="Courier New" pitchFamily="34" charset="-122"/>
                 <a:cs typeface="Courier New" pitchFamily="34" charset="-120"/>
               </a:rPr>
-              <a:t>CLICK ONE OPEN</a:t>
+              <a:t>IT ASKS FIVE QUESTIONS</a:t>
             </a:r>
             <a:endParaRPr lang="en-US" sz="950" dirty="0"/>
           </a:p>
@@ -6300,14 +6837,14 @@
       </p:sp>
       <p:sp>
         <p:nvSpPr>
-          <p:cNvPr id="9" name="Text 5"/>
-          <p:cNvSpPr txBox="1"/>
-          <p:nvPr/>
-        </p:nvSpPr>
-        <p:spPr>
-          <a:xfrm>
-            <a:off x="7516368" y="2852928"/>
-            <a:ext cx="3621024" cy="243840"/>
+          <p:cNvPr id="13" name="Text 10"/>
+          <p:cNvSpPr txBox="1"/>
+          <p:nvPr/>
+        </p:nvSpPr>
+        <p:spPr>
+          <a:xfrm>
+            <a:off x="1051560" y="5080000"/>
+            <a:ext cx="4480560" cy="259080"/>
           </a:xfrm>
           <a:prstGeom prst="rect">
             <a:avLst/>
@@ -6321,12 +6858,12 @@
           <a:p>
             <a:pPr indent="0" marL="0">
               <a:lnSpc>
-                <a:spcPts val="1920"/>
+                <a:spcPts val="2040"/>
               </a:lnSpc>
               <a:buNone/>
             </a:pPr>
             <a:r>
-              <a:rPr lang="en-US" sz="1600" b="1" dirty="0">
+              <a:rPr lang="en-US" sz="1700" b="1" dirty="0">
                 <a:solidFill>
                   <a:srgbClr val="15171F"/>
                 </a:solidFill>
@@ -6334,22 +6871,22 @@
                 <a:ea typeface="Public Sans" pitchFamily="34" charset="-122"/>
                 <a:cs typeface="Public Sans" pitchFamily="34" charset="-120"/>
               </a:rPr>
-              <a:t>The steps draw themselves</a:t>
-            </a:r>
-            <a:endParaRPr lang="en-US" sz="1600" dirty="0"/>
-          </a:p>
-        </p:txBody>
-      </p:sp>
-      <p:sp>
-        <p:nvSpPr>
-          <p:cNvPr id="10" name="Text 6"/>
-          <p:cNvSpPr txBox="1"/>
-          <p:nvPr/>
-        </p:nvSpPr>
-        <p:spPr>
-          <a:xfrm>
-            <a:off x="7516368" y="3224784"/>
-            <a:ext cx="3621024" cy="766953"/>
+              <a:t>The fifth is the one that matters</a:t>
+            </a:r>
+            <a:endParaRPr lang="en-US" sz="1700" dirty="0"/>
+          </a:p>
+        </p:txBody>
+      </p:sp>
+      <p:sp>
+        <p:nvSpPr>
+          <p:cNvPr id="14" name="Text 11"/>
+          <p:cNvSpPr txBox="1"/>
+          <p:nvPr/>
+        </p:nvSpPr>
+        <p:spPr>
+          <a:xfrm>
+            <a:off x="1051560" y="5467096"/>
+            <a:ext cx="4480560" cy="541528"/>
           </a:xfrm>
           <a:prstGeom prst="rect">
             <a:avLst/>
@@ -6363,12 +6900,12 @@
           <a:p>
             <a:pPr indent="0" marL="0">
               <a:lnSpc>
-                <a:spcPts val="1917"/>
+                <a:spcPts val="1988"/>
               </a:lnSpc>
               <a:buNone/>
             </a:pPr>
             <a:r>
-              <a:rPr lang="en-US" sz="1350" dirty="0">
+              <a:rPr lang="en-US" sz="1400" dirty="0">
                 <a:solidFill>
                   <a:srgbClr val="5B6270"/>
                 </a:solidFill>
@@ -6376,26 +6913,26 @@
                 <a:ea typeface="Public Sans" pitchFamily="34" charset="-122"/>
                 <a:cs typeface="Public Sans" pitchFamily="34" charset="-120"/>
               </a:rPr>
-              <a:t>Out of that note’s own step table. No diagram anywhere can say something the note does not.</a:t>
-            </a:r>
-            <a:endParaRPr lang="en-US" sz="1350" dirty="0"/>
-          </a:p>
-        </p:txBody>
-      </p:sp>
-      <p:sp>
-        <p:nvSpPr>
-          <p:cNvPr id="11" name="Shape 7"/>
+              <a:t>Who starts it · what they need · where it stops · who it waits on · what goes wrong.</a:t>
+            </a:r>
+            <a:endParaRPr lang="en-US" sz="1400" dirty="0"/>
+          </a:p>
+        </p:txBody>
+      </p:sp>
+      <p:sp>
+        <p:nvSpPr>
+          <p:cNvPr id="15" name="Shape 12"/>
           <p:cNvSpPr/>
           <p:nvPr/>
         </p:nvSpPr>
         <p:spPr>
           <a:xfrm>
-            <a:off x="7242048" y="4522089"/>
-            <a:ext cx="4169664" cy="1718310"/>
+            <a:off x="6172200" y="4513072"/>
+            <a:ext cx="5029200" cy="1751584"/>
           </a:xfrm>
           <a:prstGeom prst="roundRect">
             <a:avLst>
-              <a:gd name="adj" fmla="val 3193"/>
+              <a:gd name="adj" fmla="val 3132"/>
             </a:avLst>
           </a:prstGeom>
           <a:solidFill>
@@ -6411,14 +6948,14 @@
       </p:sp>
       <p:sp>
         <p:nvSpPr>
-          <p:cNvPr id="12" name="Text 8"/>
-          <p:cNvSpPr txBox="1"/>
-          <p:nvPr/>
-        </p:nvSpPr>
-        <p:spPr>
-          <a:xfrm>
-            <a:off x="7516368" y="4796409"/>
-            <a:ext cx="3621024" cy="219456"/>
+          <p:cNvPr id="16" name="Text 13"/>
+          <p:cNvSpPr txBox="1"/>
+          <p:nvPr/>
+        </p:nvSpPr>
+        <p:spPr>
+          <a:xfrm>
+            <a:off x="6446520" y="4787392"/>
+            <a:ext cx="4480560" cy="219456"/>
           </a:xfrm>
           <a:prstGeom prst="rect">
             <a:avLst/>
@@ -6442,7 +6979,7 @@
                 <a:ea typeface="Courier New" pitchFamily="34" charset="-122"/>
                 <a:cs typeface="Courier New" pitchFamily="34" charset="-120"/>
               </a:rPr>
-              <a:t>TWO MARKS, NOT ONE</a:t>
+              <a:t>WRITE TODAY, NOT THE PLAN</a:t>
             </a:r>
             <a:endParaRPr lang="en-US" sz="950" dirty="0"/>
           </a:p>
@@ -6450,14 +6987,14 @@
       </p:sp>
       <p:sp>
         <p:nvSpPr>
-          <p:cNvPr id="13" name="Text 9"/>
-          <p:cNvSpPr txBox="1"/>
-          <p:nvPr/>
-        </p:nvSpPr>
-        <p:spPr>
-          <a:xfrm>
-            <a:off x="7516368" y="5089017"/>
-            <a:ext cx="3621024" cy="243840"/>
+          <p:cNvPr id="17" name="Text 14"/>
+          <p:cNvSpPr txBox="1"/>
+          <p:nvPr/>
+        </p:nvSpPr>
+        <p:spPr>
+          <a:xfrm>
+            <a:off x="6446520" y="5080000"/>
+            <a:ext cx="4480560" cy="259080"/>
           </a:xfrm>
           <a:prstGeom prst="rect">
             <a:avLst/>
@@ -6471,12 +7008,12 @@
           <a:p>
             <a:pPr indent="0" marL="0">
               <a:lnSpc>
-                <a:spcPts val="1920"/>
+                <a:spcPts val="2040"/>
               </a:lnSpc>
               <a:buNone/>
             </a:pPr>
             <a:r>
-              <a:rPr lang="en-US" sz="1600" b="1" dirty="0">
+              <a:rPr lang="en-US" sz="1700" b="1" dirty="0">
                 <a:solidFill>
                   <a:srgbClr val="15171F"/>
                 </a:solidFill>
@@ -6484,22 +7021,22 @@
                 <a:ea typeface="Public Sans" pitchFamily="34" charset="-122"/>
                 <a:cs typeface="Public Sans" pitchFamily="34" charset="-120"/>
               </a:rPr>
-              <a:t>Written down is not working</a:t>
-            </a:r>
-            <a:endParaRPr lang="en-US" sz="1600" dirty="0"/>
-          </a:p>
-        </p:txBody>
-      </p:sp>
-      <p:sp>
-        <p:nvSpPr>
-          <p:cNvPr id="14" name="Text 10"/>
-          <p:cNvSpPr txBox="1"/>
-          <p:nvPr/>
-        </p:nvSpPr>
-        <p:spPr>
-          <a:xfrm>
-            <a:off x="7516368" y="5460873"/>
-            <a:ext cx="3621024" cy="523494"/>
+              <a:t>Including the messy step</a:t>
+            </a:r>
+            <a:endParaRPr lang="en-US" sz="1700" dirty="0"/>
+          </a:p>
+        </p:txBody>
+      </p:sp>
+      <p:sp>
+        <p:nvSpPr>
+          <p:cNvPr id="18" name="Text 15"/>
+          <p:cNvSpPr txBox="1"/>
+          <p:nvPr/>
+        </p:nvSpPr>
+        <p:spPr>
+          <a:xfrm>
+            <a:off x="6446520" y="5467096"/>
+            <a:ext cx="4480560" cy="541528"/>
           </a:xfrm>
           <a:prstGeom prst="rect">
             <a:avLst/>
@@ -6513,12 +7050,12 @@
           <a:p>
             <a:pPr indent="0" marL="0">
               <a:lnSpc>
-                <a:spcPts val="1917"/>
+                <a:spcPts val="1988"/>
               </a:lnSpc>
               <a:buNone/>
             </a:pPr>
             <a:r>
-              <a:rPr lang="en-US" sz="1350" dirty="0">
+              <a:rPr lang="en-US" sz="1400" dirty="0">
                 <a:solidFill>
                   <a:srgbClr val="5B6270"/>
                 </a:solidFill>
@@ -6526,15 +7063,15 @@
                 <a:ea typeface="Public Sans" pitchFamily="34" charset="-122"/>
                 <a:cs typeface="Public Sans" pitchFamily="34" charset="-120"/>
               </a:rPr>
-              <a:t>Is the note true? Only after one real case. Does it run end to end? A different question.</a:t>
-            </a:r>
-            <a:endParaRPr lang="en-US" sz="1350" dirty="0"/>
-          </a:p>
-        </p:txBody>
-      </p:sp>
-      <p:sp>
-        <p:nvSpPr>
-          <p:cNvPr id="15" name="Text 11"/>
+              <a:t>If a step is you copying a number between two screens, that is the step.</a:t>
+            </a:r>
+            <a:endParaRPr lang="en-US" sz="1400" dirty="0"/>
+          </a:p>
+        </p:txBody>
+      </p:sp>
+      <p:sp>
+        <p:nvSpPr>
+          <p:cNvPr id="19" name="Text 16"/>
           <p:cNvSpPr txBox="1"/>
           <p:nvPr/>
         </p:nvSpPr>
@@ -6582,6 +7119,1766 @@
 <file path=ppt/slides/slide17.xml><?xml version="1.0" encoding="utf-8"?>
 <p:sld xmlns:a="http://schemas.openxmlformats.org/drawingml/2006/main" xmlns:r="http://schemas.openxmlformats.org/officeDocument/2006/relationships" xmlns:p="http://schemas.openxmlformats.org/presentationml/2006/main">
   <p:cSld name="Slide 17">
+    <p:bg>
+      <p:bgPr>
+        <a:solidFill>
+          <a:srgbClr val="FFFFFF"/>
+        </a:solidFill>
+      </p:bgPr>
+    </p:bg>
+    <p:spTree>
+      <p:nvGrpSpPr>
+        <p:cNvPr id="1" name=""/>
+        <p:cNvGrpSpPr/>
+        <p:nvPr/>
+      </p:nvGrpSpPr>
+      <p:grpSpPr>
+        <a:xfrm>
+          <a:off x="0" y="0"/>
+          <a:ext cx="0" cy="0"/>
+          <a:chOff x="0" y="0"/>
+          <a:chExt cx="0" cy="0"/>
+        </a:xfrm>
+      </p:grpSpPr>
+      <p:sp>
+        <p:nvSpPr>
+          <p:cNvPr id="2" name="Text 0"/>
+          <p:cNvSpPr txBox="1"/>
+          <p:nvPr/>
+        </p:nvSpPr>
+        <p:spPr>
+          <a:xfrm>
+            <a:off x="777240" y="420624"/>
+            <a:ext cx="8229600" cy="274320"/>
+          </a:xfrm>
+          <a:prstGeom prst="rect">
+            <a:avLst/>
+          </a:prstGeom>
+          <a:noFill/>
+          <a:ln/>
+        </p:spPr>
+        <p:txBody>
+          <a:bodyPr wrap="square" lIns="0" tIns="0" rIns="0" bIns="0" rtlCol="0" anchor="ctr"/>
+          <a:lstStyle/>
+          <a:p>
+            <a:pPr indent="0" marL="0">
+              <a:buNone/>
+            </a:pPr>
+            <a:r>
+              <a:rPr lang="en-US" sz="1100" spc="200" kern="0" dirty="0">
+                <a:solidFill>
+                  <a:srgbClr val="6055D8"/>
+                </a:solidFill>
+                <a:latin typeface="Courier New" pitchFamily="34" charset="0"/>
+                <a:ea typeface="Courier New" pitchFamily="34" charset="-122"/>
+                <a:cs typeface="Courier New" pitchFamily="34" charset="-120"/>
+              </a:rPr>
+              <a:t>WHAT THE LAYER PRODUCES</a:t>
+            </a:r>
+            <a:endParaRPr lang="en-US" sz="1100" dirty="0"/>
+          </a:p>
+        </p:txBody>
+      </p:sp>
+      <p:pic>
+        <p:nvPicPr>
+          <p:cNvPr id="3" name="Image 0" descr="/tmp/claude-0/-home-claude/e62a35b1-5075-553d-b086-acebfebc41ba/scratchpad/brand/meshpro-emblem-white.png">    </p:cNvPr>
+          <p:cNvPicPr>
+            <a:picLocks noChangeAspect="1"/>
+          </p:cNvPicPr>
+          <p:nvPr/>
+        </p:nvPicPr>
+        <p:blipFill>
+          <a:blip r:embed="rId1"/>
+          <a:stretch>
+            <a:fillRect/>
+          </a:stretch>
+        </p:blipFill>
+        <p:spPr>
+          <a:xfrm>
+            <a:off x="11140135" y="411480"/>
+            <a:ext cx="384048" cy="374904"/>
+          </a:xfrm>
+          <a:prstGeom prst="rect">
+            <a:avLst/>
+          </a:prstGeom>
+        </p:spPr>
+      </p:pic>
+      <p:sp>
+        <p:nvSpPr>
+          <p:cNvPr id="4" name="Text 1"/>
+          <p:cNvSpPr txBox="1"/>
+          <p:nvPr/>
+        </p:nvSpPr>
+        <p:spPr>
+          <a:xfrm>
+            <a:off x="777240" y="868680"/>
+            <a:ext cx="9951415" cy="914400"/>
+          </a:xfrm>
+          <a:prstGeom prst="rect">
+            <a:avLst/>
+          </a:prstGeom>
+          <a:noFill/>
+          <a:ln/>
+        </p:spPr>
+        <p:txBody>
+          <a:bodyPr wrap="square" lIns="0" tIns="0" rIns="0" bIns="0" rtlCol="0" anchor="ctr"/>
+          <a:lstStyle/>
+          <a:p>
+            <a:pPr indent="0" marL="0">
+              <a:lnSpc>
+                <a:spcPts val="3596"/>
+              </a:lnSpc>
+              <a:buNone/>
+            </a:pPr>
+            <a:r>
+              <a:rPr lang="en-US" sz="3100" b="1" dirty="0">
+                <a:solidFill>
+                  <a:srgbClr val="15171F"/>
+                </a:solidFill>
+                <a:latin typeface="Public Sans" pitchFamily="34" charset="0"/>
+                <a:ea typeface="Public Sans" pitchFamily="34" charset="-122"/>
+                <a:cs typeface="Public Sans" pitchFamily="34" charset="-120"/>
+              </a:rPr>
+              <a:t>Workflows and projects belong to a department</a:t>
+            </a:r>
+            <a:endParaRPr lang="en-US" sz="3100" dirty="0"/>
+          </a:p>
+        </p:txBody>
+      </p:sp>
+      <p:sp>
+        <p:nvSpPr>
+          <p:cNvPr id="5" name="Text 2"/>
+          <p:cNvSpPr txBox="1"/>
+          <p:nvPr/>
+        </p:nvSpPr>
+        <p:spPr>
+          <a:xfrm>
+            <a:off x="777240" y="1627632"/>
+            <a:ext cx="10637215" cy="566928"/>
+          </a:xfrm>
+          <a:prstGeom prst="rect">
+            <a:avLst/>
+          </a:prstGeom>
+          <a:noFill/>
+          <a:ln/>
+        </p:spPr>
+        <p:txBody>
+          <a:bodyPr wrap="square" lIns="0" tIns="0" rIns="0" bIns="0" rtlCol="0" anchor="ctr"/>
+          <a:lstStyle/>
+          <a:p>
+            <a:pPr indent="0" marL="0">
+              <a:lnSpc>
+                <a:spcPts val="2300"/>
+              </a:lnSpc>
+              <a:buNone/>
+            </a:pPr>
+            <a:r>
+              <a:rPr lang="en-US" sz="1600" dirty="0">
+                <a:solidFill>
+                  <a:srgbClr val="5B6270"/>
+                </a:solidFill>
+                <a:latin typeface="Public Sans" pitchFamily="34" charset="0"/>
+                <a:ea typeface="Public Sans" pitchFamily="34" charset="-122"/>
+                <a:cs typeface="Public Sans" pitchFamily="34" charset="-120"/>
+              </a:rPr>
+              <a:t>A workflow is how work happens. A project is work with an end.</a:t>
+            </a:r>
+            <a:endParaRPr lang="en-US" sz="1600" dirty="0"/>
+          </a:p>
+        </p:txBody>
+      </p:sp>
+      <p:pic>
+        <p:nvPicPr>
+          <p:cNvPr id="6" name="Image 1" descr="/tmp/claude-0/-home-claude/e62a35b1-5075-553d-b086-acebfebc41ba/scratchpad/deck/n-steps.png">    </p:cNvPr>
+          <p:cNvPicPr>
+            <a:picLocks noChangeAspect="1"/>
+          </p:cNvPicPr>
+          <p:nvPr/>
+        </p:nvPicPr>
+        <p:blipFill>
+          <a:blip r:embed="rId2"/>
+          <a:stretch>
+            <a:fillRect/>
+          </a:stretch>
+        </p:blipFill>
+        <p:spPr>
+          <a:xfrm>
+            <a:off x="777240" y="2286000"/>
+            <a:ext cx="6172200" cy="3794760"/>
+          </a:xfrm>
+          <a:prstGeom prst="rect">
+            <a:avLst/>
+          </a:prstGeom>
+        </p:spPr>
+      </p:pic>
+      <p:sp>
+        <p:nvSpPr>
+          <p:cNvPr id="7" name="Shape 3"/>
+          <p:cNvSpPr/>
+          <p:nvPr/>
+        </p:nvSpPr>
+        <p:spPr>
+          <a:xfrm>
+            <a:off x="7242048" y="2231136"/>
+            <a:ext cx="4169664" cy="1961769"/>
+          </a:xfrm>
+          <a:prstGeom prst="roundRect">
+            <a:avLst>
+              <a:gd name="adj" fmla="val 2797"/>
+            </a:avLst>
+          </a:prstGeom>
+          <a:solidFill>
+            <a:srgbClr val="F4F5F8"/>
+          </a:solidFill>
+          <a:ln w="12700">
+            <a:solidFill>
+              <a:srgbClr val="E4E6EC"/>
+            </a:solidFill>
+            <a:prstDash val="solid"/>
+          </a:ln>
+        </p:spPr>
+      </p:sp>
+      <p:sp>
+        <p:nvSpPr>
+          <p:cNvPr id="8" name="Text 4"/>
+          <p:cNvSpPr txBox="1"/>
+          <p:nvPr/>
+        </p:nvSpPr>
+        <p:spPr>
+          <a:xfrm>
+            <a:off x="7516368" y="2505456"/>
+            <a:ext cx="3621024" cy="219456"/>
+          </a:xfrm>
+          <a:prstGeom prst="rect">
+            <a:avLst/>
+          </a:prstGeom>
+          <a:noFill/>
+          <a:ln/>
+        </p:spPr>
+        <p:txBody>
+          <a:bodyPr wrap="square" lIns="0" tIns="0" rIns="0" bIns="0" rtlCol="0" anchor="ctr"/>
+          <a:lstStyle/>
+          <a:p>
+            <a:pPr indent="0" marL="0">
+              <a:buNone/>
+            </a:pPr>
+            <a:r>
+              <a:rPr lang="en-US" sz="950" spc="140" kern="0" dirty="0">
+                <a:solidFill>
+                  <a:srgbClr val="6055D8"/>
+                </a:solidFill>
+                <a:latin typeface="Courier New" pitchFamily="34" charset="0"/>
+                <a:ea typeface="Courier New" pitchFamily="34" charset="-122"/>
+                <a:cs typeface="Courier New" pitchFamily="34" charset="-120"/>
+              </a:rPr>
+              <a:t>CLICK ONE OPEN</a:t>
+            </a:r>
+            <a:endParaRPr lang="en-US" sz="950" dirty="0"/>
+          </a:p>
+        </p:txBody>
+      </p:sp>
+      <p:sp>
+        <p:nvSpPr>
+          <p:cNvPr id="9" name="Text 5"/>
+          <p:cNvSpPr txBox="1"/>
+          <p:nvPr/>
+        </p:nvSpPr>
+        <p:spPr>
+          <a:xfrm>
+            <a:off x="7516368" y="2798064"/>
+            <a:ext cx="3621024" cy="243840"/>
+          </a:xfrm>
+          <a:prstGeom prst="rect">
+            <a:avLst/>
+          </a:prstGeom>
+          <a:noFill/>
+          <a:ln/>
+        </p:spPr>
+        <p:txBody>
+          <a:bodyPr wrap="square" lIns="0" tIns="0" rIns="0" bIns="0" rtlCol="0" anchor="t"/>
+          <a:lstStyle/>
+          <a:p>
+            <a:pPr indent="0" marL="0">
+              <a:lnSpc>
+                <a:spcPts val="1920"/>
+              </a:lnSpc>
+              <a:buNone/>
+            </a:pPr>
+            <a:r>
+              <a:rPr lang="en-US" sz="1600" b="1" dirty="0">
+                <a:solidFill>
+                  <a:srgbClr val="15171F"/>
+                </a:solidFill>
+                <a:latin typeface="Public Sans" pitchFamily="34" charset="0"/>
+                <a:ea typeface="Public Sans" pitchFamily="34" charset="-122"/>
+                <a:cs typeface="Public Sans" pitchFamily="34" charset="-120"/>
+              </a:rPr>
+              <a:t>The steps draw themselves</a:t>
+            </a:r>
+            <a:endParaRPr lang="en-US" sz="1600" dirty="0"/>
+          </a:p>
+        </p:txBody>
+      </p:sp>
+      <p:sp>
+        <p:nvSpPr>
+          <p:cNvPr id="10" name="Text 6"/>
+          <p:cNvSpPr txBox="1"/>
+          <p:nvPr/>
+        </p:nvSpPr>
+        <p:spPr>
+          <a:xfrm>
+            <a:off x="7516368" y="3169920"/>
+            <a:ext cx="3621024" cy="766953"/>
+          </a:xfrm>
+          <a:prstGeom prst="rect">
+            <a:avLst/>
+          </a:prstGeom>
+          <a:noFill/>
+          <a:ln/>
+        </p:spPr>
+        <p:txBody>
+          <a:bodyPr wrap="square" lIns="0" tIns="0" rIns="0" bIns="0" rtlCol="0" anchor="t"/>
+          <a:lstStyle/>
+          <a:p>
+            <a:pPr indent="0" marL="0">
+              <a:lnSpc>
+                <a:spcPts val="1917"/>
+              </a:lnSpc>
+              <a:buNone/>
+            </a:pPr>
+            <a:r>
+              <a:rPr lang="en-US" sz="1350" dirty="0">
+                <a:solidFill>
+                  <a:srgbClr val="5B6270"/>
+                </a:solidFill>
+                <a:latin typeface="Public Sans" pitchFamily="34" charset="0"/>
+                <a:ea typeface="Public Sans" pitchFamily="34" charset="-122"/>
+                <a:cs typeface="Public Sans" pitchFamily="34" charset="-120"/>
+              </a:rPr>
+              <a:t>Out of that note’s own step table. No diagram anywhere can say something the note does not.</a:t>
+            </a:r>
+            <a:endParaRPr lang="en-US" sz="1350" dirty="0"/>
+          </a:p>
+        </p:txBody>
+      </p:sp>
+      <p:sp>
+        <p:nvSpPr>
+          <p:cNvPr id="11" name="Shape 7"/>
+          <p:cNvSpPr/>
+          <p:nvPr/>
+        </p:nvSpPr>
+        <p:spPr>
+          <a:xfrm>
+            <a:off x="7242048" y="4412361"/>
+            <a:ext cx="4169664" cy="1718310"/>
+          </a:xfrm>
+          <a:prstGeom prst="roundRect">
+            <a:avLst>
+              <a:gd name="adj" fmla="val 3193"/>
+            </a:avLst>
+          </a:prstGeom>
+          <a:solidFill>
+            <a:srgbClr val="F4F5F8"/>
+          </a:solidFill>
+          <a:ln w="12700">
+            <a:solidFill>
+              <a:srgbClr val="E4E6EC"/>
+            </a:solidFill>
+            <a:prstDash val="solid"/>
+          </a:ln>
+        </p:spPr>
+      </p:sp>
+      <p:sp>
+        <p:nvSpPr>
+          <p:cNvPr id="12" name="Text 8"/>
+          <p:cNvSpPr txBox="1"/>
+          <p:nvPr/>
+        </p:nvSpPr>
+        <p:spPr>
+          <a:xfrm>
+            <a:off x="7516368" y="4686681"/>
+            <a:ext cx="3621024" cy="219456"/>
+          </a:xfrm>
+          <a:prstGeom prst="rect">
+            <a:avLst/>
+          </a:prstGeom>
+          <a:noFill/>
+          <a:ln/>
+        </p:spPr>
+        <p:txBody>
+          <a:bodyPr wrap="square" lIns="0" tIns="0" rIns="0" bIns="0" rtlCol="0" anchor="ctr"/>
+          <a:lstStyle/>
+          <a:p>
+            <a:pPr indent="0" marL="0">
+              <a:buNone/>
+            </a:pPr>
+            <a:r>
+              <a:rPr lang="en-US" sz="950" spc="140" kern="0" dirty="0">
+                <a:solidFill>
+                  <a:srgbClr val="6055D8"/>
+                </a:solidFill>
+                <a:latin typeface="Courier New" pitchFamily="34" charset="0"/>
+                <a:ea typeface="Courier New" pitchFamily="34" charset="-122"/>
+                <a:cs typeface="Courier New" pitchFamily="34" charset="-120"/>
+              </a:rPr>
+              <a:t>TWO MARKS, NOT ONE</a:t>
+            </a:r>
+            <a:endParaRPr lang="en-US" sz="950" dirty="0"/>
+          </a:p>
+        </p:txBody>
+      </p:sp>
+      <p:sp>
+        <p:nvSpPr>
+          <p:cNvPr id="13" name="Text 9"/>
+          <p:cNvSpPr txBox="1"/>
+          <p:nvPr/>
+        </p:nvSpPr>
+        <p:spPr>
+          <a:xfrm>
+            <a:off x="7516368" y="4979289"/>
+            <a:ext cx="3621024" cy="243840"/>
+          </a:xfrm>
+          <a:prstGeom prst="rect">
+            <a:avLst/>
+          </a:prstGeom>
+          <a:noFill/>
+          <a:ln/>
+        </p:spPr>
+        <p:txBody>
+          <a:bodyPr wrap="square" lIns="0" tIns="0" rIns="0" bIns="0" rtlCol="0" anchor="t"/>
+          <a:lstStyle/>
+          <a:p>
+            <a:pPr indent="0" marL="0">
+              <a:lnSpc>
+                <a:spcPts val="1920"/>
+              </a:lnSpc>
+              <a:buNone/>
+            </a:pPr>
+            <a:r>
+              <a:rPr lang="en-US" sz="1600" b="1" dirty="0">
+                <a:solidFill>
+                  <a:srgbClr val="15171F"/>
+                </a:solidFill>
+                <a:latin typeface="Public Sans" pitchFamily="34" charset="0"/>
+                <a:ea typeface="Public Sans" pitchFamily="34" charset="-122"/>
+                <a:cs typeface="Public Sans" pitchFamily="34" charset="-120"/>
+              </a:rPr>
+              <a:t>Written down is not working</a:t>
+            </a:r>
+            <a:endParaRPr lang="en-US" sz="1600" dirty="0"/>
+          </a:p>
+        </p:txBody>
+      </p:sp>
+      <p:sp>
+        <p:nvSpPr>
+          <p:cNvPr id="14" name="Text 10"/>
+          <p:cNvSpPr txBox="1"/>
+          <p:nvPr/>
+        </p:nvSpPr>
+        <p:spPr>
+          <a:xfrm>
+            <a:off x="7516368" y="5351145"/>
+            <a:ext cx="3621024" cy="523494"/>
+          </a:xfrm>
+          <a:prstGeom prst="rect">
+            <a:avLst/>
+          </a:prstGeom>
+          <a:noFill/>
+          <a:ln/>
+        </p:spPr>
+        <p:txBody>
+          <a:bodyPr wrap="square" lIns="0" tIns="0" rIns="0" bIns="0" rtlCol="0" anchor="t"/>
+          <a:lstStyle/>
+          <a:p>
+            <a:pPr indent="0" marL="0">
+              <a:lnSpc>
+                <a:spcPts val="1917"/>
+              </a:lnSpc>
+              <a:buNone/>
+            </a:pPr>
+            <a:r>
+              <a:rPr lang="en-US" sz="1350" dirty="0">
+                <a:solidFill>
+                  <a:srgbClr val="5B6270"/>
+                </a:solidFill>
+                <a:latin typeface="Public Sans" pitchFamily="34" charset="0"/>
+                <a:ea typeface="Public Sans" pitchFamily="34" charset="-122"/>
+                <a:cs typeface="Public Sans" pitchFamily="34" charset="-120"/>
+              </a:rPr>
+              <a:t>Is the note true? Only after one real case. Does it run end to end? A different question.</a:t>
+            </a:r>
+            <a:endParaRPr lang="en-US" sz="1350" dirty="0"/>
+          </a:p>
+        </p:txBody>
+      </p:sp>
+      <p:sp>
+        <p:nvSpPr>
+          <p:cNvPr id="15" name="Text 11"/>
+          <p:cNvSpPr txBox="1"/>
+          <p:nvPr/>
+        </p:nvSpPr>
+        <p:spPr>
+          <a:xfrm>
+            <a:off x="777240" y="6291072"/>
+            <a:ext cx="10637215" cy="274320"/>
+          </a:xfrm>
+          <a:prstGeom prst="rect">
+            <a:avLst/>
+          </a:prstGeom>
+          <a:noFill/>
+          <a:ln/>
+        </p:spPr>
+        <p:txBody>
+          <a:bodyPr wrap="square" lIns="0" tIns="0" rIns="0" bIns="0" rtlCol="0" anchor="ctr"/>
+          <a:lstStyle/>
+          <a:p>
+            <a:pPr indent="0" marL="0">
+              <a:buNone/>
+            </a:pPr>
+            <a:r>
+              <a:rPr lang="en-US" sz="950" spc="100" kern="0" dirty="0">
+                <a:solidFill>
+                  <a:srgbClr val="6B6D72"/>
+                </a:solidFill>
+                <a:latin typeface="Courier New" pitchFamily="34" charset="0"/>
+                <a:ea typeface="Courier New" pitchFamily="34" charset="-122"/>
+                <a:cs typeface="Courier New" pitchFamily="34" charset="-120"/>
+              </a:rPr>
+              <a:t>17</a:t>
+            </a:r>
+            <a:endParaRPr lang="en-US" sz="950" dirty="0"/>
+          </a:p>
+        </p:txBody>
+      </p:sp>
+    </p:spTree>
+  </p:cSld>
+  <p:clrMapOvr>
+    <a:masterClrMapping/>
+  </p:clrMapOvr>
+</p:sld>
+</file>
+
+<file path=ppt/slides/slide18.xml><?xml version="1.0" encoding="utf-8"?>
+<p:sld xmlns:a="http://schemas.openxmlformats.org/drawingml/2006/main" xmlns:r="http://schemas.openxmlformats.org/officeDocument/2006/relationships" xmlns:p="http://schemas.openxmlformats.org/presentationml/2006/main">
+  <p:cSld name="Slide 18">
+    <p:bg>
+      <p:bgPr>
+        <a:solidFill>
+          <a:srgbClr val="FFFFFF"/>
+        </a:solidFill>
+      </p:bgPr>
+    </p:bg>
+    <p:spTree>
+      <p:nvGrpSpPr>
+        <p:cNvPr id="1" name=""/>
+        <p:cNvGrpSpPr/>
+        <p:nvPr/>
+      </p:nvGrpSpPr>
+      <p:grpSpPr>
+        <a:xfrm>
+          <a:off x="0" y="0"/>
+          <a:ext cx="0" cy="0"/>
+          <a:chOff x="0" y="0"/>
+          <a:chExt cx="0" cy="0"/>
+        </a:xfrm>
+      </p:grpSpPr>
+      <p:sp>
+        <p:nvSpPr>
+          <p:cNvPr id="2" name="Text 0"/>
+          <p:cNvSpPr txBox="1"/>
+          <p:nvPr/>
+        </p:nvSpPr>
+        <p:spPr>
+          <a:xfrm>
+            <a:off x="777240" y="420624"/>
+            <a:ext cx="8229600" cy="274320"/>
+          </a:xfrm>
+          <a:prstGeom prst="rect">
+            <a:avLst/>
+          </a:prstGeom>
+          <a:noFill/>
+          <a:ln/>
+        </p:spPr>
+        <p:txBody>
+          <a:bodyPr wrap="square" lIns="0" tIns="0" rIns="0" bIns="0" rtlCol="0" anchor="ctr"/>
+          <a:lstStyle/>
+          <a:p>
+            <a:pPr indent="0" marL="0">
+              <a:buNone/>
+            </a:pPr>
+            <a:r>
+              <a:rPr lang="en-US" sz="1100" spc="200" kern="0" dirty="0">
+                <a:solidFill>
+                  <a:srgbClr val="6055D8"/>
+                </a:solidFill>
+                <a:latin typeface="Courier New" pitchFamily="34" charset="0"/>
+                <a:ea typeface="Courier New" pitchFamily="34" charset="-122"/>
+                <a:cs typeface="Courier New" pitchFamily="34" charset="-120"/>
+              </a:rPr>
+              <a:t>THE MAP</a:t>
+            </a:r>
+            <a:endParaRPr lang="en-US" sz="1100" dirty="0"/>
+          </a:p>
+        </p:txBody>
+      </p:sp>
+      <p:pic>
+        <p:nvPicPr>
+          <p:cNvPr id="3" name="Image 0" descr="/tmp/claude-0/-home-claude/e62a35b1-5075-553d-b086-acebfebc41ba/scratchpad/brand/meshpro-emblem-white.png">    </p:cNvPr>
+          <p:cNvPicPr>
+            <a:picLocks noChangeAspect="1"/>
+          </p:cNvPicPr>
+          <p:nvPr/>
+        </p:nvPicPr>
+        <p:blipFill>
+          <a:blip r:embed="rId1"/>
+          <a:stretch>
+            <a:fillRect/>
+          </a:stretch>
+        </p:blipFill>
+        <p:spPr>
+          <a:xfrm>
+            <a:off x="11140135" y="411480"/>
+            <a:ext cx="384048" cy="374904"/>
+          </a:xfrm>
+          <a:prstGeom prst="rect">
+            <a:avLst/>
+          </a:prstGeom>
+        </p:spPr>
+      </p:pic>
+      <p:sp>
+        <p:nvSpPr>
+          <p:cNvPr id="4" name="Text 1"/>
+          <p:cNvSpPr txBox="1"/>
+          <p:nvPr/>
+        </p:nvSpPr>
+        <p:spPr>
+          <a:xfrm>
+            <a:off x="777240" y="868680"/>
+            <a:ext cx="9951415" cy="914400"/>
+          </a:xfrm>
+          <a:prstGeom prst="rect">
+            <a:avLst/>
+          </a:prstGeom>
+          <a:noFill/>
+          <a:ln/>
+        </p:spPr>
+        <p:txBody>
+          <a:bodyPr wrap="square" lIns="0" tIns="0" rIns="0" bIns="0" rtlCol="0" anchor="ctr"/>
+          <a:lstStyle/>
+          <a:p>
+            <a:pPr indent="0" marL="0">
+              <a:lnSpc>
+                <a:spcPts val="3712"/>
+              </a:lnSpc>
+              <a:buNone/>
+            </a:pPr>
+            <a:r>
+              <a:rPr lang="en-US" sz="3200" b="1" dirty="0">
+                <a:solidFill>
+                  <a:srgbClr val="15171F"/>
+                </a:solidFill>
+                <a:latin typeface="Public Sans" pitchFamily="34" charset="0"/>
+                <a:ea typeface="Public Sans" pitchFamily="34" charset="-122"/>
+                <a:cs typeface="Public Sans" pitchFamily="34" charset="-120"/>
+              </a:rPr>
+              <a:t>Where all of it lives</a:t>
+            </a:r>
+            <a:endParaRPr lang="en-US" sz="3200" dirty="0"/>
+          </a:p>
+        </p:txBody>
+      </p:sp>
+      <p:sp>
+        <p:nvSpPr>
+          <p:cNvPr id="5" name="Text 2"/>
+          <p:cNvSpPr txBox="1"/>
+          <p:nvPr/>
+        </p:nvSpPr>
+        <p:spPr>
+          <a:xfrm>
+            <a:off x="777240" y="1664208"/>
+            <a:ext cx="10637215" cy="566928"/>
+          </a:xfrm>
+          <a:prstGeom prst="rect">
+            <a:avLst/>
+          </a:prstGeom>
+          <a:noFill/>
+          <a:ln/>
+        </p:spPr>
+        <p:txBody>
+          <a:bodyPr wrap="square" lIns="0" tIns="0" rIns="0" bIns="0" rtlCol="0" anchor="ctr"/>
+          <a:lstStyle/>
+          <a:p>
+            <a:pPr indent="0" marL="0">
+              <a:lnSpc>
+                <a:spcPts val="2300"/>
+              </a:lnSpc>
+              <a:buNone/>
+            </a:pPr>
+            <a:r>
+              <a:rPr lang="en-US" sz="1600" dirty="0">
+                <a:solidFill>
+                  <a:srgbClr val="5B6270"/>
+                </a:solidFill>
+                <a:latin typeface="Public Sans" pitchFamily="34" charset="0"/>
+                <a:ea typeface="Public Sans" pitchFamily="34" charset="-122"/>
+                <a:cs typeface="Public Sans" pitchFamily="34" charset="-120"/>
+              </a:rPr>
+              <a:t>Plain files in your folder. Two kinds: the ones you and your agents write, and the ones that are written for you.</a:t>
+            </a:r>
+            <a:endParaRPr lang="en-US" sz="1600" dirty="0"/>
+          </a:p>
+        </p:txBody>
+      </p:sp>
+      <p:sp>
+        <p:nvSpPr>
+          <p:cNvPr id="6" name="Text 3"/>
+          <p:cNvSpPr txBox="1"/>
+          <p:nvPr/>
+        </p:nvSpPr>
+        <p:spPr>
+          <a:xfrm>
+            <a:off x="777240" y="2359152"/>
+            <a:ext cx="5257800" cy="237744"/>
+          </a:xfrm>
+          <a:prstGeom prst="rect">
+            <a:avLst/>
+          </a:prstGeom>
+          <a:noFill/>
+          <a:ln/>
+        </p:spPr>
+        <p:txBody>
+          <a:bodyPr wrap="square" lIns="0" tIns="0" rIns="0" bIns="0" rtlCol="0" anchor="ctr"/>
+          <a:lstStyle/>
+          <a:p>
+            <a:pPr indent="0" marL="0">
+              <a:buNone/>
+            </a:pPr>
+            <a:r>
+              <a:rPr lang="en-US" sz="1400" b="1" dirty="0">
+                <a:solidFill>
+                  <a:srgbClr val="15171F"/>
+                </a:solidFill>
+                <a:latin typeface="Public Sans" pitchFamily="34" charset="0"/>
+                <a:ea typeface="Public Sans" pitchFamily="34" charset="-122"/>
+                <a:cs typeface="Public Sans" pitchFamily="34" charset="-120"/>
+              </a:rPr>
+              <a:t>A department</a:t>
+            </a:r>
+            <a:endParaRPr lang="en-US" sz="1400" dirty="0"/>
+          </a:p>
+        </p:txBody>
+      </p:sp>
+      <p:sp>
+        <p:nvSpPr>
+          <p:cNvPr id="7" name="Text 4"/>
+          <p:cNvSpPr txBox="1"/>
+          <p:nvPr/>
+        </p:nvSpPr>
+        <p:spPr>
+          <a:xfrm>
+            <a:off x="777240" y="2592324"/>
+            <a:ext cx="5257800" cy="237744"/>
+          </a:xfrm>
+          <a:prstGeom prst="rect">
+            <a:avLst/>
+          </a:prstGeom>
+          <a:noFill/>
+          <a:ln/>
+        </p:spPr>
+        <p:txBody>
+          <a:bodyPr wrap="square" lIns="0" tIns="0" rIns="0" bIns="0" rtlCol="0" anchor="ctr"/>
+          <a:lstStyle/>
+          <a:p>
+            <a:pPr indent="0" marL="0">
+              <a:buNone/>
+            </a:pPr>
+            <a:r>
+              <a:rPr lang="en-US" sz="1150" dirty="0">
+                <a:solidFill>
+                  <a:srgbClr val="6055D8"/>
+                </a:solidFill>
+                <a:latin typeface="Courier New" pitchFamily="34" charset="0"/>
+                <a:ea typeface="Courier New" pitchFamily="34" charset="-122"/>
+                <a:cs typeface="Courier New" pitchFamily="34" charset="-120"/>
+              </a:rPr>
+              <a:t>01 - Company/Departments/{Name}.md</a:t>
+            </a:r>
+            <a:endParaRPr lang="en-US" sz="1150" dirty="0"/>
+          </a:p>
+        </p:txBody>
+      </p:sp>
+      <p:sp>
+        <p:nvSpPr>
+          <p:cNvPr id="8" name="Text 5"/>
+          <p:cNvSpPr txBox="1"/>
+          <p:nvPr/>
+        </p:nvSpPr>
+        <p:spPr>
+          <a:xfrm>
+            <a:off x="777240" y="2980944"/>
+            <a:ext cx="5257800" cy="237744"/>
+          </a:xfrm>
+          <a:prstGeom prst="rect">
+            <a:avLst/>
+          </a:prstGeom>
+          <a:noFill/>
+          <a:ln/>
+        </p:spPr>
+        <p:txBody>
+          <a:bodyPr wrap="square" lIns="0" tIns="0" rIns="0" bIns="0" rtlCol="0" anchor="ctr"/>
+          <a:lstStyle/>
+          <a:p>
+            <a:pPr indent="0" marL="0">
+              <a:buNone/>
+            </a:pPr>
+            <a:r>
+              <a:rPr lang="en-US" sz="1400" b="1" dirty="0">
+                <a:solidFill>
+                  <a:srgbClr val="15171F"/>
+                </a:solidFill>
+                <a:latin typeface="Public Sans" pitchFamily="34" charset="0"/>
+                <a:ea typeface="Public Sans" pitchFamily="34" charset="-122"/>
+                <a:cs typeface="Public Sans" pitchFamily="34" charset="-120"/>
+              </a:rPr>
+              <a:t>An executive</a:t>
+            </a:r>
+            <a:endParaRPr lang="en-US" sz="1400" dirty="0"/>
+          </a:p>
+        </p:txBody>
+      </p:sp>
+      <p:sp>
+        <p:nvSpPr>
+          <p:cNvPr id="9" name="Text 6"/>
+          <p:cNvSpPr txBox="1"/>
+          <p:nvPr/>
+        </p:nvSpPr>
+        <p:spPr>
+          <a:xfrm>
+            <a:off x="777240" y="3214116"/>
+            <a:ext cx="5257800" cy="237744"/>
+          </a:xfrm>
+          <a:prstGeom prst="rect">
+            <a:avLst/>
+          </a:prstGeom>
+          <a:noFill/>
+          <a:ln/>
+        </p:spPr>
+        <p:txBody>
+          <a:bodyPr wrap="square" lIns="0" tIns="0" rIns="0" bIns="0" rtlCol="0" anchor="ctr"/>
+          <a:lstStyle/>
+          <a:p>
+            <a:pPr indent="0" marL="0">
+              <a:buNone/>
+            </a:pPr>
+            <a:r>
+              <a:rPr lang="en-US" sz="1150" dirty="0">
+                <a:solidFill>
+                  <a:srgbClr val="6055D8"/>
+                </a:solidFill>
+                <a:latin typeface="Courier New" pitchFamily="34" charset="0"/>
+                <a:ea typeface="Courier New" pitchFamily="34" charset="-122"/>
+                <a:cs typeface="Courier New" pitchFamily="34" charset="-120"/>
+              </a:rPr>
+              <a:t>01 - Company/Roles/{Name}.md</a:t>
+            </a:r>
+            <a:endParaRPr lang="en-US" sz="1150" dirty="0"/>
+          </a:p>
+        </p:txBody>
+      </p:sp>
+      <p:sp>
+        <p:nvSpPr>
+          <p:cNvPr id="10" name="Text 7"/>
+          <p:cNvSpPr txBox="1"/>
+          <p:nvPr/>
+        </p:nvSpPr>
+        <p:spPr>
+          <a:xfrm>
+            <a:off x="777240" y="3602736"/>
+            <a:ext cx="5257800" cy="237744"/>
+          </a:xfrm>
+          <a:prstGeom prst="rect">
+            <a:avLst/>
+          </a:prstGeom>
+          <a:noFill/>
+          <a:ln/>
+        </p:spPr>
+        <p:txBody>
+          <a:bodyPr wrap="square" lIns="0" tIns="0" rIns="0" bIns="0" rtlCol="0" anchor="ctr"/>
+          <a:lstStyle/>
+          <a:p>
+            <a:pPr indent="0" marL="0">
+              <a:buNone/>
+            </a:pPr>
+            <a:r>
+              <a:rPr lang="en-US" sz="1400" b="1" dirty="0">
+                <a:solidFill>
+                  <a:srgbClr val="15171F"/>
+                </a:solidFill>
+                <a:latin typeface="Public Sans" pitchFamily="34" charset="0"/>
+                <a:ea typeface="Public Sans" pitchFamily="34" charset="-122"/>
+                <a:cs typeface="Public Sans" pitchFamily="34" charset="-120"/>
+              </a:rPr>
+              <a:t>A specialist</a:t>
+            </a:r>
+            <a:endParaRPr lang="en-US" sz="1400" dirty="0"/>
+          </a:p>
+        </p:txBody>
+      </p:sp>
+      <p:sp>
+        <p:nvSpPr>
+          <p:cNvPr id="11" name="Text 8"/>
+          <p:cNvSpPr txBox="1"/>
+          <p:nvPr/>
+        </p:nvSpPr>
+        <p:spPr>
+          <a:xfrm>
+            <a:off x="777240" y="3835908"/>
+            <a:ext cx="5257800" cy="237744"/>
+          </a:xfrm>
+          <a:prstGeom prst="rect">
+            <a:avLst/>
+          </a:prstGeom>
+          <a:noFill/>
+          <a:ln/>
+        </p:spPr>
+        <p:txBody>
+          <a:bodyPr wrap="square" lIns="0" tIns="0" rIns="0" bIns="0" rtlCol="0" anchor="ctr"/>
+          <a:lstStyle/>
+          <a:p>
+            <a:pPr indent="0" marL="0">
+              <a:buNone/>
+            </a:pPr>
+            <a:r>
+              <a:rPr lang="en-US" sz="1150" dirty="0">
+                <a:solidFill>
+                  <a:srgbClr val="6055D8"/>
+                </a:solidFill>
+                <a:latin typeface="Courier New" pitchFamily="34" charset="0"/>
+                <a:ea typeface="Courier New" pitchFamily="34" charset="-122"/>
+                <a:cs typeface="Courier New" pitchFamily="34" charset="-120"/>
+              </a:rPr>
+              <a:t>01 - Company/Roles/{Name}.md</a:t>
+            </a:r>
+            <a:pPr indent="0" marL="0">
+              <a:buNone/>
+            </a:pPr>
+            <a:r>
+              <a:rPr lang="en-US" sz="1150" dirty="0">
+                <a:solidFill>
+                  <a:srgbClr val="9AA1AD"/>
+                </a:solidFill>
+                <a:latin typeface="Courier New" pitchFamily="34" charset="0"/>
+                <a:ea typeface="Courier New" pitchFamily="34" charset="-122"/>
+                <a:cs typeface="Courier New" pitchFamily="34" charset="-120"/>
+              </a:rPr>
+              <a:t>   kind: specialist</a:t>
+            </a:r>
+            <a:endParaRPr lang="en-US" sz="1150" dirty="0"/>
+          </a:p>
+        </p:txBody>
+      </p:sp>
+      <p:sp>
+        <p:nvSpPr>
+          <p:cNvPr id="12" name="Text 9"/>
+          <p:cNvSpPr txBox="1"/>
+          <p:nvPr/>
+        </p:nvSpPr>
+        <p:spPr>
+          <a:xfrm>
+            <a:off x="777240" y="4224528"/>
+            <a:ext cx="5257800" cy="237744"/>
+          </a:xfrm>
+          <a:prstGeom prst="rect">
+            <a:avLst/>
+          </a:prstGeom>
+          <a:noFill/>
+          <a:ln/>
+        </p:spPr>
+        <p:txBody>
+          <a:bodyPr wrap="square" lIns="0" tIns="0" rIns="0" bIns="0" rtlCol="0" anchor="ctr"/>
+          <a:lstStyle/>
+          <a:p>
+            <a:pPr indent="0" marL="0">
+              <a:buNone/>
+            </a:pPr>
+            <a:r>
+              <a:rPr lang="en-US" sz="1400" b="1" dirty="0">
+                <a:solidFill>
+                  <a:srgbClr val="15171F"/>
+                </a:solidFill>
+                <a:latin typeface="Public Sans" pitchFamily="34" charset="0"/>
+                <a:ea typeface="Public Sans" pitchFamily="34" charset="-122"/>
+                <a:cs typeface="Public Sans" pitchFamily="34" charset="-120"/>
+              </a:rPr>
+              <a:t>A skill</a:t>
+            </a:r>
+            <a:endParaRPr lang="en-US" sz="1400" dirty="0"/>
+          </a:p>
+        </p:txBody>
+      </p:sp>
+      <p:sp>
+        <p:nvSpPr>
+          <p:cNvPr id="13" name="Text 10"/>
+          <p:cNvSpPr txBox="1"/>
+          <p:nvPr/>
+        </p:nvSpPr>
+        <p:spPr>
+          <a:xfrm>
+            <a:off x="777240" y="4457700"/>
+            <a:ext cx="5257800" cy="237744"/>
+          </a:xfrm>
+          <a:prstGeom prst="rect">
+            <a:avLst/>
+          </a:prstGeom>
+          <a:noFill/>
+          <a:ln/>
+        </p:spPr>
+        <p:txBody>
+          <a:bodyPr wrap="square" lIns="0" tIns="0" rIns="0" bIns="0" rtlCol="0" anchor="ctr"/>
+          <a:lstStyle/>
+          <a:p>
+            <a:pPr indent="0" marL="0">
+              <a:buNone/>
+            </a:pPr>
+            <a:r>
+              <a:rPr lang="en-US" sz="1150" dirty="0">
+                <a:solidFill>
+                  <a:srgbClr val="6055D8"/>
+                </a:solidFill>
+                <a:latin typeface="Courier New" pitchFamily="34" charset="0"/>
+                <a:ea typeface="Courier New" pitchFamily="34" charset="-122"/>
+                <a:cs typeface="Courier New" pitchFamily="34" charset="-120"/>
+              </a:rPr>
+              <a:t>.claude/skills/{name}/SKILL.md</a:t>
+            </a:r>
+            <a:endParaRPr lang="en-US" sz="1150" dirty="0"/>
+          </a:p>
+        </p:txBody>
+      </p:sp>
+      <p:sp>
+        <p:nvSpPr>
+          <p:cNvPr id="14" name="Text 11"/>
+          <p:cNvSpPr txBox="1"/>
+          <p:nvPr/>
+        </p:nvSpPr>
+        <p:spPr>
+          <a:xfrm>
+            <a:off x="777240" y="4846320"/>
+            <a:ext cx="5257800" cy="237744"/>
+          </a:xfrm>
+          <a:prstGeom prst="rect">
+            <a:avLst/>
+          </a:prstGeom>
+          <a:noFill/>
+          <a:ln/>
+        </p:spPr>
+        <p:txBody>
+          <a:bodyPr wrap="square" lIns="0" tIns="0" rIns="0" bIns="0" rtlCol="0" anchor="ctr"/>
+          <a:lstStyle/>
+          <a:p>
+            <a:pPr indent="0" marL="0">
+              <a:buNone/>
+            </a:pPr>
+            <a:r>
+              <a:rPr lang="en-US" sz="1400" b="1" dirty="0">
+                <a:solidFill>
+                  <a:srgbClr val="15171F"/>
+                </a:solidFill>
+                <a:latin typeface="Public Sans" pitchFamily="34" charset="0"/>
+                <a:ea typeface="Public Sans" pitchFamily="34" charset="-122"/>
+                <a:cs typeface="Public Sans" pitchFamily="34" charset="-120"/>
+              </a:rPr>
+              <a:t>A workflow</a:t>
+            </a:r>
+            <a:endParaRPr lang="en-US" sz="1400" dirty="0"/>
+          </a:p>
+        </p:txBody>
+      </p:sp>
+      <p:sp>
+        <p:nvSpPr>
+          <p:cNvPr id="15" name="Text 12"/>
+          <p:cNvSpPr txBox="1"/>
+          <p:nvPr/>
+        </p:nvSpPr>
+        <p:spPr>
+          <a:xfrm>
+            <a:off x="777240" y="5079492"/>
+            <a:ext cx="5257800" cy="237744"/>
+          </a:xfrm>
+          <a:prstGeom prst="rect">
+            <a:avLst/>
+          </a:prstGeom>
+          <a:noFill/>
+          <a:ln/>
+        </p:spPr>
+        <p:txBody>
+          <a:bodyPr wrap="square" lIns="0" tIns="0" rIns="0" bIns="0" rtlCol="0" anchor="ctr"/>
+          <a:lstStyle/>
+          <a:p>
+            <a:pPr indent="0" marL="0">
+              <a:buNone/>
+            </a:pPr>
+            <a:r>
+              <a:rPr lang="en-US" sz="1150" dirty="0">
+                <a:solidFill>
+                  <a:srgbClr val="6055D8"/>
+                </a:solidFill>
+                <a:latin typeface="Courier New" pitchFamily="34" charset="0"/>
+                <a:ea typeface="Courier New" pitchFamily="34" charset="-122"/>
+                <a:cs typeface="Courier New" pitchFamily="34" charset="-120"/>
+              </a:rPr>
+              <a:t>01 - Company/Workflows/{Name}.md</a:t>
+            </a:r>
+            <a:endParaRPr lang="en-US" sz="1150" dirty="0"/>
+          </a:p>
+        </p:txBody>
+      </p:sp>
+      <p:sp>
+        <p:nvSpPr>
+          <p:cNvPr id="16" name="Text 13"/>
+          <p:cNvSpPr txBox="1"/>
+          <p:nvPr/>
+        </p:nvSpPr>
+        <p:spPr>
+          <a:xfrm>
+            <a:off x="777240" y="5468112"/>
+            <a:ext cx="5257800" cy="237744"/>
+          </a:xfrm>
+          <a:prstGeom prst="rect">
+            <a:avLst/>
+          </a:prstGeom>
+          <a:noFill/>
+          <a:ln/>
+        </p:spPr>
+        <p:txBody>
+          <a:bodyPr wrap="square" lIns="0" tIns="0" rIns="0" bIns="0" rtlCol="0" anchor="ctr"/>
+          <a:lstStyle/>
+          <a:p>
+            <a:pPr indent="0" marL="0">
+              <a:buNone/>
+            </a:pPr>
+            <a:r>
+              <a:rPr lang="en-US" sz="1400" b="1" dirty="0">
+                <a:solidFill>
+                  <a:srgbClr val="15171F"/>
+                </a:solidFill>
+                <a:latin typeface="Public Sans" pitchFamily="34" charset="0"/>
+                <a:ea typeface="Public Sans" pitchFamily="34" charset="-122"/>
+                <a:cs typeface="Public Sans" pitchFamily="34" charset="-120"/>
+              </a:rPr>
+              <a:t>A project</a:t>
+            </a:r>
+            <a:endParaRPr lang="en-US" sz="1400" dirty="0"/>
+          </a:p>
+        </p:txBody>
+      </p:sp>
+      <p:sp>
+        <p:nvSpPr>
+          <p:cNvPr id="17" name="Text 14"/>
+          <p:cNvSpPr txBox="1"/>
+          <p:nvPr/>
+        </p:nvSpPr>
+        <p:spPr>
+          <a:xfrm>
+            <a:off x="777240" y="5701284"/>
+            <a:ext cx="5257800" cy="237744"/>
+          </a:xfrm>
+          <a:prstGeom prst="rect">
+            <a:avLst/>
+          </a:prstGeom>
+          <a:noFill/>
+          <a:ln/>
+        </p:spPr>
+        <p:txBody>
+          <a:bodyPr wrap="square" lIns="0" tIns="0" rIns="0" bIns="0" rtlCol="0" anchor="ctr"/>
+          <a:lstStyle/>
+          <a:p>
+            <a:pPr indent="0" marL="0">
+              <a:buNone/>
+            </a:pPr>
+            <a:r>
+              <a:rPr lang="en-US" sz="1150" dirty="0">
+                <a:solidFill>
+                  <a:srgbClr val="6055D8"/>
+                </a:solidFill>
+                <a:latin typeface="Courier New" pitchFamily="34" charset="0"/>
+                <a:ea typeface="Courier New" pitchFamily="34" charset="-122"/>
+                <a:cs typeface="Courier New" pitchFamily="34" charset="-120"/>
+              </a:rPr>
+              <a:t>02 - Work/{Name}.md</a:t>
+            </a:r>
+            <a:endParaRPr lang="en-US" sz="1150" dirty="0"/>
+          </a:p>
+        </p:txBody>
+      </p:sp>
+      <p:sp>
+        <p:nvSpPr>
+          <p:cNvPr id="18" name="Text 15"/>
+          <p:cNvSpPr txBox="1"/>
+          <p:nvPr/>
+        </p:nvSpPr>
+        <p:spPr>
+          <a:xfrm>
+            <a:off x="6583680" y="2359152"/>
+            <a:ext cx="5257800" cy="237744"/>
+          </a:xfrm>
+          <a:prstGeom prst="rect">
+            <a:avLst/>
+          </a:prstGeom>
+          <a:noFill/>
+          <a:ln/>
+        </p:spPr>
+        <p:txBody>
+          <a:bodyPr wrap="square" lIns="0" tIns="0" rIns="0" bIns="0" rtlCol="0" anchor="ctr"/>
+          <a:lstStyle/>
+          <a:p>
+            <a:pPr indent="0" marL="0">
+              <a:buNone/>
+            </a:pPr>
+            <a:r>
+              <a:rPr lang="en-US" sz="1400" b="1" dirty="0">
+                <a:solidFill>
+                  <a:srgbClr val="15171F"/>
+                </a:solidFill>
+                <a:latin typeface="Public Sans" pitchFamily="34" charset="0"/>
+                <a:ea typeface="Public Sans" pitchFamily="34" charset="-122"/>
+                <a:cs typeface="Public Sans" pitchFamily="34" charset="-120"/>
+              </a:rPr>
+              <a:t>A decision</a:t>
+            </a:r>
+            <a:endParaRPr lang="en-US" sz="1400" dirty="0"/>
+          </a:p>
+        </p:txBody>
+      </p:sp>
+      <p:sp>
+        <p:nvSpPr>
+          <p:cNvPr id="19" name="Text 16"/>
+          <p:cNvSpPr txBox="1"/>
+          <p:nvPr/>
+        </p:nvSpPr>
+        <p:spPr>
+          <a:xfrm>
+            <a:off x="6583680" y="2592324"/>
+            <a:ext cx="5257800" cy="237744"/>
+          </a:xfrm>
+          <a:prstGeom prst="rect">
+            <a:avLst/>
+          </a:prstGeom>
+          <a:noFill/>
+          <a:ln/>
+        </p:spPr>
+        <p:txBody>
+          <a:bodyPr wrap="square" lIns="0" tIns="0" rIns="0" bIns="0" rtlCol="0" anchor="ctr"/>
+          <a:lstStyle/>
+          <a:p>
+            <a:pPr indent="0" marL="0">
+              <a:buNone/>
+            </a:pPr>
+            <a:r>
+              <a:rPr lang="en-US" sz="1150" dirty="0">
+                <a:solidFill>
+                  <a:srgbClr val="6055D8"/>
+                </a:solidFill>
+                <a:latin typeface="Courier New" pitchFamily="34" charset="0"/>
+                <a:ea typeface="Courier New" pitchFamily="34" charset="-122"/>
+                <a:cs typeface="Courier New" pitchFamily="34" charset="-120"/>
+              </a:rPr>
+              <a:t>01 - Company/Decisions/{Name}.md</a:t>
+            </a:r>
+            <a:endParaRPr lang="en-US" sz="1150" dirty="0"/>
+          </a:p>
+        </p:txBody>
+      </p:sp>
+      <p:sp>
+        <p:nvSpPr>
+          <p:cNvPr id="20" name="Text 17"/>
+          <p:cNvSpPr txBox="1"/>
+          <p:nvPr/>
+        </p:nvSpPr>
+        <p:spPr>
+          <a:xfrm>
+            <a:off x="6583680" y="2980944"/>
+            <a:ext cx="5257800" cy="237744"/>
+          </a:xfrm>
+          <a:prstGeom prst="rect">
+            <a:avLst/>
+          </a:prstGeom>
+          <a:noFill/>
+          <a:ln/>
+        </p:spPr>
+        <p:txBody>
+          <a:bodyPr wrap="square" lIns="0" tIns="0" rIns="0" bIns="0" rtlCol="0" anchor="ctr"/>
+          <a:lstStyle/>
+          <a:p>
+            <a:pPr indent="0" marL="0">
+              <a:buNone/>
+            </a:pPr>
+            <a:r>
+              <a:rPr lang="en-US" sz="1400" b="1" dirty="0">
+                <a:solidFill>
+                  <a:srgbClr val="15171F"/>
+                </a:solidFill>
+                <a:latin typeface="Public Sans" pitchFamily="34" charset="0"/>
+                <a:ea typeface="Public Sans" pitchFamily="34" charset="-122"/>
+                <a:cs typeface="Public Sans" pitchFamily="34" charset="-120"/>
+              </a:rPr>
+              <a:t>The rules they all inherit</a:t>
+            </a:r>
+            <a:endParaRPr lang="en-US" sz="1400" dirty="0"/>
+          </a:p>
+        </p:txBody>
+      </p:sp>
+      <p:sp>
+        <p:nvSpPr>
+          <p:cNvPr id="21" name="Text 18"/>
+          <p:cNvSpPr txBox="1"/>
+          <p:nvPr/>
+        </p:nvSpPr>
+        <p:spPr>
+          <a:xfrm>
+            <a:off x="6583680" y="3214116"/>
+            <a:ext cx="5257800" cy="237744"/>
+          </a:xfrm>
+          <a:prstGeom prst="rect">
+            <a:avLst/>
+          </a:prstGeom>
+          <a:noFill/>
+          <a:ln/>
+        </p:spPr>
+        <p:txBody>
+          <a:bodyPr wrap="square" lIns="0" tIns="0" rIns="0" bIns="0" rtlCol="0" anchor="ctr"/>
+          <a:lstStyle/>
+          <a:p>
+            <a:pPr indent="0" marL="0">
+              <a:buNone/>
+            </a:pPr>
+            <a:r>
+              <a:rPr lang="en-US" sz="1150" dirty="0">
+                <a:solidFill>
+                  <a:srgbClr val="6055D8"/>
+                </a:solidFill>
+                <a:latin typeface="Courier New" pitchFamily="34" charset="0"/>
+                <a:ea typeface="Courier New" pitchFamily="34" charset="-122"/>
+                <a:cs typeface="Courier New" pitchFamily="34" charset="-120"/>
+              </a:rPr>
+              <a:t>CLAUDE.md</a:t>
+            </a:r>
+            <a:pPr indent="0" marL="0">
+              <a:buNone/>
+            </a:pPr>
+            <a:r>
+              <a:rPr lang="en-US" sz="1150" dirty="0">
+                <a:solidFill>
+                  <a:srgbClr val="9AA1AD"/>
+                </a:solidFill>
+                <a:latin typeface="Courier New" pitchFamily="34" charset="0"/>
+                <a:ea typeface="Courier New" pitchFamily="34" charset="-122"/>
+                <a:cs typeface="Courier New" pitchFamily="34" charset="-120"/>
+              </a:rPr>
+              <a:t>   at the top of the folder</a:t>
+            </a:r>
+            <a:endParaRPr lang="en-US" sz="1150" dirty="0"/>
+          </a:p>
+        </p:txBody>
+      </p:sp>
+      <p:sp>
+        <p:nvSpPr>
+          <p:cNvPr id="22" name="Text 19"/>
+          <p:cNvSpPr txBox="1"/>
+          <p:nvPr/>
+        </p:nvSpPr>
+        <p:spPr>
+          <a:xfrm>
+            <a:off x="6583680" y="3602736"/>
+            <a:ext cx="5257800" cy="237744"/>
+          </a:xfrm>
+          <a:prstGeom prst="rect">
+            <a:avLst/>
+          </a:prstGeom>
+          <a:noFill/>
+          <a:ln/>
+        </p:spPr>
+        <p:txBody>
+          <a:bodyPr wrap="square" lIns="0" tIns="0" rIns="0" bIns="0" rtlCol="0" anchor="ctr"/>
+          <a:lstStyle/>
+          <a:p>
+            <a:pPr indent="0" marL="0">
+              <a:buNone/>
+            </a:pPr>
+            <a:r>
+              <a:rPr lang="en-US" sz="1400" b="1" dirty="0">
+                <a:solidFill>
+                  <a:srgbClr val="5B6270"/>
+                </a:solidFill>
+                <a:latin typeface="Public Sans" pitchFamily="34" charset="0"/>
+                <a:ea typeface="Public Sans" pitchFamily="34" charset="-122"/>
+                <a:cs typeface="Public Sans" pitchFamily="34" charset="-120"/>
+              </a:rPr>
+              <a:t>The agents that actually run</a:t>
+            </a:r>
+            <a:endParaRPr lang="en-US" sz="1400" dirty="0"/>
+          </a:p>
+        </p:txBody>
+      </p:sp>
+      <p:sp>
+        <p:nvSpPr>
+          <p:cNvPr id="23" name="Text 20"/>
+          <p:cNvSpPr txBox="1"/>
+          <p:nvPr/>
+        </p:nvSpPr>
+        <p:spPr>
+          <a:xfrm>
+            <a:off x="6583680" y="3835908"/>
+            <a:ext cx="5257800" cy="237744"/>
+          </a:xfrm>
+          <a:prstGeom prst="rect">
+            <a:avLst/>
+          </a:prstGeom>
+          <a:noFill/>
+          <a:ln/>
+        </p:spPr>
+        <p:txBody>
+          <a:bodyPr wrap="square" lIns="0" tIns="0" rIns="0" bIns="0" rtlCol="0" anchor="ctr"/>
+          <a:lstStyle/>
+          <a:p>
+            <a:pPr indent="0" marL="0">
+              <a:buNone/>
+            </a:pPr>
+            <a:r>
+              <a:rPr lang="en-US" sz="1150" dirty="0">
+                <a:solidFill>
+                  <a:srgbClr val="5B6270"/>
+                </a:solidFill>
+                <a:latin typeface="Courier New" pitchFamily="34" charset="0"/>
+                <a:ea typeface="Courier New" pitchFamily="34" charset="-122"/>
+                <a:cs typeface="Courier New" pitchFamily="34" charset="-120"/>
+              </a:rPr>
+              <a:t>.claude/agents/{name}.md</a:t>
+            </a:r>
+            <a:pPr indent="0" marL="0">
+              <a:buNone/>
+            </a:pPr>
+            <a:r>
+              <a:rPr lang="en-US" sz="1150" dirty="0">
+                <a:solidFill>
+                  <a:srgbClr val="9AA1AD"/>
+                </a:solidFill>
+                <a:latin typeface="Courier New" pitchFamily="34" charset="0"/>
+                <a:ea typeface="Courier New" pitchFamily="34" charset="-122"/>
+                <a:cs typeface="Courier New" pitchFamily="34" charset="-120"/>
+              </a:rPr>
+              <a:t>   compiled from the roles</a:t>
+            </a:r>
+            <a:endParaRPr lang="en-US" sz="1150" dirty="0"/>
+          </a:p>
+        </p:txBody>
+      </p:sp>
+      <p:sp>
+        <p:nvSpPr>
+          <p:cNvPr id="24" name="Text 21"/>
+          <p:cNvSpPr txBox="1"/>
+          <p:nvPr/>
+        </p:nvSpPr>
+        <p:spPr>
+          <a:xfrm>
+            <a:off x="6583680" y="4224528"/>
+            <a:ext cx="5257800" cy="237744"/>
+          </a:xfrm>
+          <a:prstGeom prst="rect">
+            <a:avLst/>
+          </a:prstGeom>
+          <a:noFill/>
+          <a:ln/>
+        </p:spPr>
+        <p:txBody>
+          <a:bodyPr wrap="square" lIns="0" tIns="0" rIns="0" bIns="0" rtlCol="0" anchor="ctr"/>
+          <a:lstStyle/>
+          <a:p>
+            <a:pPr indent="0" marL="0">
+              <a:buNone/>
+            </a:pPr>
+            <a:r>
+              <a:rPr lang="en-US" sz="1400" b="1" dirty="0">
+                <a:solidFill>
+                  <a:srgbClr val="5B6270"/>
+                </a:solidFill>
+                <a:latin typeface="Public Sans" pitchFamily="34" charset="0"/>
+                <a:ea typeface="Public Sans" pitchFamily="34" charset="-122"/>
+                <a:cs typeface="Public Sans" pitchFamily="34" charset="-120"/>
+              </a:rPr>
+              <a:t>The workflow register</a:t>
+            </a:r>
+            <a:endParaRPr lang="en-US" sz="1400" dirty="0"/>
+          </a:p>
+        </p:txBody>
+      </p:sp>
+      <p:sp>
+        <p:nvSpPr>
+          <p:cNvPr id="25" name="Text 22"/>
+          <p:cNvSpPr txBox="1"/>
+          <p:nvPr/>
+        </p:nvSpPr>
+        <p:spPr>
+          <a:xfrm>
+            <a:off x="6583680" y="4457700"/>
+            <a:ext cx="5257800" cy="237744"/>
+          </a:xfrm>
+          <a:prstGeom prst="rect">
+            <a:avLst/>
+          </a:prstGeom>
+          <a:noFill/>
+          <a:ln/>
+        </p:spPr>
+        <p:txBody>
+          <a:bodyPr wrap="square" lIns="0" tIns="0" rIns="0" bIns="0" rtlCol="0" anchor="ctr"/>
+          <a:lstStyle/>
+          <a:p>
+            <a:pPr indent="0" marL="0">
+              <a:buNone/>
+            </a:pPr>
+            <a:r>
+              <a:rPr lang="en-US" sz="1150" dirty="0">
+                <a:solidFill>
+                  <a:srgbClr val="5B6270"/>
+                </a:solidFill>
+                <a:latin typeface="Courier New" pitchFamily="34" charset="0"/>
+                <a:ea typeface="Courier New" pitchFamily="34" charset="-122"/>
+                <a:cs typeface="Courier New" pitchFamily="34" charset="-120"/>
+              </a:rPr>
+              <a:t>01 - Company/Workflows/Workflows.md</a:t>
+            </a:r>
+            <a:endParaRPr lang="en-US" sz="1150" dirty="0"/>
+          </a:p>
+        </p:txBody>
+      </p:sp>
+      <p:sp>
+        <p:nvSpPr>
+          <p:cNvPr id="26" name="Text 23"/>
+          <p:cNvSpPr txBox="1"/>
+          <p:nvPr/>
+        </p:nvSpPr>
+        <p:spPr>
+          <a:xfrm>
+            <a:off x="6583680" y="4846320"/>
+            <a:ext cx="5257800" cy="237744"/>
+          </a:xfrm>
+          <a:prstGeom prst="rect">
+            <a:avLst/>
+          </a:prstGeom>
+          <a:noFill/>
+          <a:ln/>
+        </p:spPr>
+        <p:txBody>
+          <a:bodyPr wrap="square" lIns="0" tIns="0" rIns="0" bIns="0" rtlCol="0" anchor="ctr"/>
+          <a:lstStyle/>
+          <a:p>
+            <a:pPr indent="0" marL="0">
+              <a:buNone/>
+            </a:pPr>
+            <a:r>
+              <a:rPr lang="en-US" sz="1400" b="1" dirty="0">
+                <a:solidFill>
+                  <a:srgbClr val="5B6270"/>
+                </a:solidFill>
+                <a:latin typeface="Public Sans" pitchFamily="34" charset="0"/>
+                <a:ea typeface="Public Sans" pitchFamily="34" charset="-122"/>
+                <a:cs typeface="Public Sans" pitchFamily="34" charset="-120"/>
+              </a:rPr>
+              <a:t>Your five-page site</a:t>
+            </a:r>
+            <a:endParaRPr lang="en-US" sz="1400" dirty="0"/>
+          </a:p>
+        </p:txBody>
+      </p:sp>
+      <p:sp>
+        <p:nvSpPr>
+          <p:cNvPr id="27" name="Text 24"/>
+          <p:cNvSpPr txBox="1"/>
+          <p:nvPr/>
+        </p:nvSpPr>
+        <p:spPr>
+          <a:xfrm>
+            <a:off x="6583680" y="5079492"/>
+            <a:ext cx="5257800" cy="237744"/>
+          </a:xfrm>
+          <a:prstGeom prst="rect">
+            <a:avLst/>
+          </a:prstGeom>
+          <a:noFill/>
+          <a:ln/>
+        </p:spPr>
+        <p:txBody>
+          <a:bodyPr wrap="square" lIns="0" tIns="0" rIns="0" bIns="0" rtlCol="0" anchor="ctr"/>
+          <a:lstStyle/>
+          <a:p>
+            <a:pPr indent="0" marL="0">
+              <a:buNone/>
+            </a:pPr>
+            <a:r>
+              <a:rPr lang="en-US" sz="1150" dirty="0">
+                <a:solidFill>
+                  <a:srgbClr val="5B6270"/>
+                </a:solidFill>
+                <a:latin typeface="Courier New" pitchFamily="34" charset="0"/>
+                <a:ea typeface="Courier New" pitchFamily="34" charset="-122"/>
+                <a:cs typeface="Courier New" pitchFamily="34" charset="-120"/>
+              </a:rPr>
+              <a:t>05 - Operations/picture/</a:t>
+            </a:r>
+            <a:pPr indent="0" marL="0">
+              <a:buNone/>
+            </a:pPr>
+            <a:r>
+              <a:rPr lang="en-US" sz="1150" dirty="0">
+                <a:solidFill>
+                  <a:srgbClr val="9AA1AD"/>
+                </a:solidFill>
+                <a:latin typeface="Courier New" pitchFamily="34" charset="0"/>
+                <a:ea typeface="Courier New" pitchFamily="34" charset="-122"/>
+                <a:cs typeface="Courier New" pitchFamily="34" charset="-120"/>
+              </a:rPr>
+              <a:t>   open ai_operations.html</a:t>
+            </a:r>
+            <a:endParaRPr lang="en-US" sz="1150" dirty="0"/>
+          </a:p>
+        </p:txBody>
+      </p:sp>
+      <p:sp>
+        <p:nvSpPr>
+          <p:cNvPr id="28" name="Shape 25"/>
+          <p:cNvSpPr/>
+          <p:nvPr/>
+        </p:nvSpPr>
+        <p:spPr>
+          <a:xfrm>
+            <a:off x="6583680" y="5504688"/>
+            <a:ext cx="5257800" cy="640080"/>
+          </a:xfrm>
+          <a:prstGeom prst="roundRect">
+            <a:avLst>
+              <a:gd name="adj" fmla="val 8571"/>
+            </a:avLst>
+          </a:prstGeom>
+          <a:solidFill>
+            <a:srgbClr val="F4F5F8"/>
+          </a:solidFill>
+          <a:ln w="12700">
+            <a:solidFill>
+              <a:srgbClr val="E4E6EC"/>
+            </a:solidFill>
+            <a:prstDash val="solid"/>
+          </a:ln>
+        </p:spPr>
+      </p:sp>
+      <p:sp>
+        <p:nvSpPr>
+          <p:cNvPr id="29" name="Text 26"/>
+          <p:cNvSpPr txBox="1"/>
+          <p:nvPr/>
+        </p:nvSpPr>
+        <p:spPr>
+          <a:xfrm>
+            <a:off x="6858000" y="5504688"/>
+            <a:ext cx="4709160" cy="640080"/>
+          </a:xfrm>
+          <a:prstGeom prst="rect">
+            <a:avLst/>
+          </a:prstGeom>
+          <a:noFill/>
+          <a:ln/>
+        </p:spPr>
+        <p:txBody>
+          <a:bodyPr wrap="square" lIns="0" tIns="0" rIns="0" bIns="0" rtlCol="0" anchor="ctr"/>
+          <a:lstStyle/>
+          <a:p>
+            <a:pPr indent="0" marL="0">
+              <a:lnSpc>
+                <a:spcPts val="1800"/>
+              </a:lnSpc>
+              <a:buNone/>
+            </a:pPr>
+            <a:r>
+              <a:rPr lang="en-US" sz="1300" b="1" dirty="0">
+                <a:solidFill>
+                  <a:srgbClr val="15171F"/>
+                </a:solidFill>
+                <a:latin typeface="Public Sans" pitchFamily="34" charset="0"/>
+                <a:ea typeface="Public Sans" pitchFamily="34" charset="-122"/>
+                <a:cs typeface="Public Sans" pitchFamily="34" charset="-120"/>
+              </a:rPr>
+              <a:t>Grey means generated. </a:t>
+            </a:r>
+            <a:pPr indent="0" marL="0">
+              <a:lnSpc>
+                <a:spcPts val="1800"/>
+              </a:lnSpc>
+              <a:buNone/>
+            </a:pPr>
+            <a:r>
+              <a:rPr lang="en-US" sz="1300" dirty="0">
+                <a:solidFill>
+                  <a:srgbClr val="5B6270"/>
+                </a:solidFill>
+                <a:latin typeface="Public Sans" pitchFamily="34" charset="0"/>
+                <a:ea typeface="Public Sans" pitchFamily="34" charset="-122"/>
+                <a:cs typeface="Public Sans" pitchFamily="34" charset="-120"/>
+              </a:rPr>
+              <a:t>Never edit one of those — edit the note that owns the fact, and build again.</a:t>
+            </a:r>
+            <a:endParaRPr lang="en-US" sz="1300" dirty="0"/>
+          </a:p>
+        </p:txBody>
+      </p:sp>
+      <p:sp>
+        <p:nvSpPr>
+          <p:cNvPr id="30" name="Text 27"/>
+          <p:cNvSpPr txBox="1"/>
+          <p:nvPr/>
+        </p:nvSpPr>
+        <p:spPr>
+          <a:xfrm>
+            <a:off x="777240" y="6291072"/>
+            <a:ext cx="10637215" cy="274320"/>
+          </a:xfrm>
+          <a:prstGeom prst="rect">
+            <a:avLst/>
+          </a:prstGeom>
+          <a:noFill/>
+          <a:ln/>
+        </p:spPr>
+        <p:txBody>
+          <a:bodyPr wrap="square" lIns="0" tIns="0" rIns="0" bIns="0" rtlCol="0" anchor="ctr"/>
+          <a:lstStyle/>
+          <a:p>
+            <a:pPr indent="0" marL="0">
+              <a:buNone/>
+            </a:pPr>
+            <a:r>
+              <a:rPr lang="en-US" sz="950" spc="100" kern="0" dirty="0">
+                <a:solidFill>
+                  <a:srgbClr val="6B6D72"/>
+                </a:solidFill>
+                <a:latin typeface="Courier New" pitchFamily="34" charset="0"/>
+                <a:ea typeface="Courier New" pitchFamily="34" charset="-122"/>
+                <a:cs typeface="Courier New" pitchFamily="34" charset="-120"/>
+              </a:rPr>
+              <a:t>18</a:t>
+            </a:r>
+            <a:endParaRPr lang="en-US" sz="950" dirty="0"/>
+          </a:p>
+        </p:txBody>
+      </p:sp>
+    </p:spTree>
+  </p:cSld>
+  <p:clrMapOvr>
+    <a:masterClrMapping/>
+  </p:clrMapOvr>
+</p:sld>
+</file>
+
+<file path=ppt/slides/slide19.xml><?xml version="1.0" encoding="utf-8"?>
+<p:sld xmlns:a="http://schemas.openxmlformats.org/drawingml/2006/main" xmlns:r="http://schemas.openxmlformats.org/officeDocument/2006/relationships" xmlns:p="http://schemas.openxmlformats.org/presentationml/2006/main">
+  <p:cSld name="Slide 19">
     <p:bg>
       <p:bgPr>
         <a:solidFill>
@@ -7410,751 +9707,12 @@
                 <a:ea typeface="Courier New" pitchFamily="34" charset="-122"/>
                 <a:cs typeface="Courier New" pitchFamily="34" charset="-120"/>
               </a:rPr>
-              <a:t>17</a:t>
+              <a:t>19</a:t>
             </a:r>
             <a:endParaRPr lang="en-US" sz="950" dirty="0"/>
           </a:p>
         </p:txBody>
       </p:sp>
-    </p:spTree>
-  </p:cSld>
-  <p:clrMapOvr>
-    <a:masterClrMapping/>
-  </p:clrMapOvr>
-</p:sld>
-</file>
-
-<file path=ppt/slides/slide18.xml><?xml version="1.0" encoding="utf-8"?>
-<p:sld xmlns:a="http://schemas.openxmlformats.org/drawingml/2006/main" xmlns:r="http://schemas.openxmlformats.org/officeDocument/2006/relationships" xmlns:p="http://schemas.openxmlformats.org/presentationml/2006/main">
-  <p:cSld name="Slide 18">
-    <p:bg>
-      <p:bgPr>
-        <a:solidFill>
-          <a:srgbClr val="15171F"/>
-        </a:solidFill>
-      </p:bgPr>
-    </p:bg>
-    <p:spTree>
-      <p:nvGrpSpPr>
-        <p:cNvPr id="1" name=""/>
-        <p:cNvGrpSpPr/>
-        <p:nvPr/>
-      </p:nvGrpSpPr>
-      <p:grpSpPr>
-        <a:xfrm>
-          <a:off x="0" y="0"/>
-          <a:ext cx="0" cy="0"/>
-          <a:chOff x="0" y="0"/>
-          <a:chExt cx="0" cy="0"/>
-        </a:xfrm>
-      </p:grpSpPr>
-      <p:sp>
-        <p:nvSpPr>
-          <p:cNvPr id="2" name="Text 0"/>
-          <p:cNvSpPr txBox="1"/>
-          <p:nvPr/>
-        </p:nvSpPr>
-        <p:spPr>
-          <a:xfrm>
-            <a:off x="777240" y="420624"/>
-            <a:ext cx="8229600" cy="274320"/>
-          </a:xfrm>
-          <a:prstGeom prst="rect">
-            <a:avLst/>
-          </a:prstGeom>
-          <a:noFill/>
-          <a:ln/>
-        </p:spPr>
-        <p:txBody>
-          <a:bodyPr wrap="square" lIns="0" tIns="0" rIns="0" bIns="0" rtlCol="0" anchor="ctr"/>
-          <a:lstStyle/>
-          <a:p>
-            <a:pPr indent="0" marL="0">
-              <a:buNone/>
-            </a:pPr>
-            <a:r>
-              <a:rPr lang="en-US" sz="1100" spc="200" kern="0" dirty="0">
-                <a:solidFill>
-                  <a:srgbClr val="A59CFF"/>
-                </a:solidFill>
-                <a:latin typeface="Courier New" pitchFamily="34" charset="0"/>
-                <a:ea typeface="Courier New" pitchFamily="34" charset="-122"/>
-                <a:cs typeface="Courier New" pitchFamily="34" charset="-120"/>
-              </a:rPr>
-              <a:t>FROM HERE</a:t>
-            </a:r>
-            <a:endParaRPr lang="en-US" sz="1100" dirty="0"/>
-          </a:p>
-        </p:txBody>
-      </p:sp>
-      <p:sp>
-        <p:nvSpPr>
-          <p:cNvPr id="3" name="Text 1"/>
-          <p:cNvSpPr txBox="1"/>
-          <p:nvPr/>
-        </p:nvSpPr>
-        <p:spPr>
-          <a:xfrm>
-            <a:off x="777240" y="868680"/>
-            <a:ext cx="9951415" cy="914400"/>
-          </a:xfrm>
-          <a:prstGeom prst="rect">
-            <a:avLst/>
-          </a:prstGeom>
-          <a:noFill/>
-          <a:ln/>
-        </p:spPr>
-        <p:txBody>
-          <a:bodyPr wrap="square" lIns="0" tIns="0" rIns="0" bIns="0" rtlCol="0" anchor="ctr"/>
-          <a:lstStyle/>
-          <a:p>
-            <a:pPr indent="0" marL="0">
-              <a:lnSpc>
-                <a:spcPts val="3944"/>
-              </a:lnSpc>
-              <a:buNone/>
-            </a:pPr>
-            <a:r>
-              <a:rPr lang="en-US" sz="3400" b="1" dirty="0">
-                <a:solidFill>
-                  <a:srgbClr val="FFFFFF"/>
-                </a:solidFill>
-                <a:latin typeface="Public Sans" pitchFamily="34" charset="0"/>
-                <a:ea typeface="Public Sans" pitchFamily="34" charset="-122"/>
-                <a:cs typeface="Public Sans" pitchFamily="34" charset="-120"/>
-              </a:rPr>
-              <a:t>The next one is just more of the same</a:t>
-            </a:r>
-            <a:endParaRPr lang="en-US" sz="3400" dirty="0"/>
-          </a:p>
-        </p:txBody>
-      </p:sp>
-      <p:sp>
-        <p:nvSpPr>
-          <p:cNvPr id="4" name="Text 2"/>
-          <p:cNvSpPr txBox="1"/>
-          <p:nvPr/>
-        </p:nvSpPr>
-        <p:spPr>
-          <a:xfrm>
-            <a:off x="777240" y="1783080"/>
-            <a:ext cx="10637215" cy="566928"/>
-          </a:xfrm>
-          <a:prstGeom prst="rect">
-            <a:avLst/>
-          </a:prstGeom>
-          <a:noFill/>
-          <a:ln/>
-        </p:spPr>
-        <p:txBody>
-          <a:bodyPr wrap="square" lIns="0" tIns="0" rIns="0" bIns="0" rtlCol="0" anchor="ctr"/>
-          <a:lstStyle/>
-          <a:p>
-            <a:pPr indent="0" marL="0">
-              <a:lnSpc>
-                <a:spcPts val="2300"/>
-              </a:lnSpc>
-              <a:buNone/>
-            </a:pPr>
-            <a:r>
-              <a:rPr lang="en-US" sz="1600" dirty="0">
-                <a:solidFill>
-                  <a:srgbClr val="A8ADBA"/>
-                </a:solidFill>
-                <a:latin typeface="Public Sans" pitchFamily="34" charset="0"/>
-                <a:ea typeface="Public Sans" pitchFamily="34" charset="-122"/>
-                <a:cs typeface="Public Sans" pitchFamily="34" charset="-120"/>
-              </a:rPr>
-              <a:t>You have made one of everything. Nothing after today is a new kind of thing.</a:t>
-            </a:r>
-            <a:endParaRPr lang="en-US" sz="1600" dirty="0"/>
-          </a:p>
-        </p:txBody>
-      </p:sp>
-      <p:sp>
-        <p:nvSpPr>
-          <p:cNvPr id="5" name="Text 3"/>
-          <p:cNvSpPr txBox="1"/>
-          <p:nvPr/>
-        </p:nvSpPr>
-        <p:spPr>
-          <a:xfrm>
-            <a:off x="777240" y="2496312"/>
-            <a:ext cx="365760" cy="594360"/>
-          </a:xfrm>
-          <a:prstGeom prst="rect">
-            <a:avLst/>
-          </a:prstGeom>
-          <a:noFill/>
-          <a:ln/>
-        </p:spPr>
-        <p:txBody>
-          <a:bodyPr wrap="square" lIns="0" tIns="0" rIns="0" bIns="0" rtlCol="0" anchor="ctr"/>
-          <a:lstStyle/>
-          <a:p>
-            <a:pPr indent="0" marL="0">
-              <a:buNone/>
-            </a:pPr>
-            <a:r>
-              <a:rPr lang="en-US" sz="1600" b="1" dirty="0">
-                <a:solidFill>
-                  <a:srgbClr val="A59CFF"/>
-                </a:solidFill>
-                <a:latin typeface="Public Sans" pitchFamily="34" charset="0"/>
-                <a:ea typeface="Public Sans" pitchFamily="34" charset="-122"/>
-                <a:cs typeface="Public Sans" pitchFamily="34" charset="-120"/>
-              </a:rPr>
-              <a:t>—</a:t>
-            </a:r>
-            <a:endParaRPr lang="en-US" sz="1600" dirty="0"/>
-          </a:p>
-        </p:txBody>
-      </p:sp>
-      <p:sp>
-        <p:nvSpPr>
-          <p:cNvPr id="6" name="Text 4"/>
-          <p:cNvSpPr txBox="1"/>
-          <p:nvPr/>
-        </p:nvSpPr>
-        <p:spPr>
-          <a:xfrm>
-            <a:off x="1234440" y="2496312"/>
-            <a:ext cx="4206240" cy="594360"/>
-          </a:xfrm>
-          <a:prstGeom prst="rect">
-            <a:avLst/>
-          </a:prstGeom>
-          <a:noFill/>
-          <a:ln/>
-        </p:spPr>
-        <p:txBody>
-          <a:bodyPr wrap="square" lIns="0" tIns="0" rIns="0" bIns="0" rtlCol="0" anchor="ctr"/>
-          <a:lstStyle/>
-          <a:p>
-            <a:pPr indent="0" marL="0">
-              <a:buNone/>
-            </a:pPr>
-            <a:r>
-              <a:rPr lang="en-US" sz="1600" b="1" dirty="0">
-                <a:solidFill>
-                  <a:srgbClr val="FFFFFF"/>
-                </a:solidFill>
-                <a:latin typeface="Public Sans" pitchFamily="34" charset="0"/>
-                <a:ea typeface="Public Sans" pitchFamily="34" charset="-122"/>
-                <a:cs typeface="Public Sans" pitchFamily="34" charset="-120"/>
-              </a:rPr>
-              <a:t>Another department</a:t>
-            </a:r>
-            <a:endParaRPr lang="en-US" sz="1600" dirty="0"/>
-          </a:p>
-        </p:txBody>
-      </p:sp>
-      <p:sp>
-        <p:nvSpPr>
-          <p:cNvPr id="7" name="Text 5"/>
-          <p:cNvSpPr txBox="1"/>
-          <p:nvPr/>
-        </p:nvSpPr>
-        <p:spPr>
-          <a:xfrm>
-            <a:off x="5623560" y="2496312"/>
-            <a:ext cx="5760720" cy="594360"/>
-          </a:xfrm>
-          <a:prstGeom prst="rect">
-            <a:avLst/>
-          </a:prstGeom>
-          <a:noFill/>
-          <a:ln/>
-        </p:spPr>
-        <p:txBody>
-          <a:bodyPr wrap="square" lIns="0" tIns="0" rIns="0" bIns="0" rtlCol="0" anchor="ctr"/>
-          <a:lstStyle/>
-          <a:p>
-            <a:pPr indent="0" marL="0">
-              <a:lnSpc>
-                <a:spcPts val="2100"/>
-              </a:lnSpc>
-              <a:buNone/>
-            </a:pPr>
-            <a:r>
-              <a:rPr lang="en-US" sz="1500" dirty="0">
-                <a:solidFill>
-                  <a:srgbClr val="A8ADBA"/>
-                </a:solidFill>
-                <a:latin typeface="Public Sans" pitchFamily="34" charset="0"/>
-                <a:ea typeface="Public Sans" pitchFamily="34" charset="-122"/>
-                <a:cs typeface="Public Sans" pitchFamily="34" charset="-120"/>
-              </a:rPr>
-              <a:t>The moment you notice a part of your job nobody answers for.</a:t>
-            </a:r>
-            <a:endParaRPr lang="en-US" sz="1500" dirty="0"/>
-          </a:p>
-        </p:txBody>
-      </p:sp>
-      <p:sp>
-        <p:nvSpPr>
-          <p:cNvPr id="8" name="Text 6"/>
-          <p:cNvSpPr txBox="1"/>
-          <p:nvPr/>
-        </p:nvSpPr>
-        <p:spPr>
-          <a:xfrm>
-            <a:off x="777240" y="3273552"/>
-            <a:ext cx="365760" cy="594360"/>
-          </a:xfrm>
-          <a:prstGeom prst="rect">
-            <a:avLst/>
-          </a:prstGeom>
-          <a:noFill/>
-          <a:ln/>
-        </p:spPr>
-        <p:txBody>
-          <a:bodyPr wrap="square" lIns="0" tIns="0" rIns="0" bIns="0" rtlCol="0" anchor="ctr"/>
-          <a:lstStyle/>
-          <a:p>
-            <a:pPr indent="0" marL="0">
-              <a:buNone/>
-            </a:pPr>
-            <a:r>
-              <a:rPr lang="en-US" sz="1600" b="1" dirty="0">
-                <a:solidFill>
-                  <a:srgbClr val="A59CFF"/>
-                </a:solidFill>
-                <a:latin typeface="Public Sans" pitchFamily="34" charset="0"/>
-                <a:ea typeface="Public Sans" pitchFamily="34" charset="-122"/>
-                <a:cs typeface="Public Sans" pitchFamily="34" charset="-120"/>
-              </a:rPr>
-              <a:t>—</a:t>
-            </a:r>
-            <a:endParaRPr lang="en-US" sz="1600" dirty="0"/>
-          </a:p>
-        </p:txBody>
-      </p:sp>
-      <p:sp>
-        <p:nvSpPr>
-          <p:cNvPr id="9" name="Text 7"/>
-          <p:cNvSpPr txBox="1"/>
-          <p:nvPr/>
-        </p:nvSpPr>
-        <p:spPr>
-          <a:xfrm>
-            <a:off x="1234440" y="3273552"/>
-            <a:ext cx="4206240" cy="594360"/>
-          </a:xfrm>
-          <a:prstGeom prst="rect">
-            <a:avLst/>
-          </a:prstGeom>
-          <a:noFill/>
-          <a:ln/>
-        </p:spPr>
-        <p:txBody>
-          <a:bodyPr wrap="square" lIns="0" tIns="0" rIns="0" bIns="0" rtlCol="0" anchor="ctr"/>
-          <a:lstStyle/>
-          <a:p>
-            <a:pPr indent="0" marL="0">
-              <a:buNone/>
-            </a:pPr>
-            <a:r>
-              <a:rPr lang="en-US" sz="1600" b="1" dirty="0">
-                <a:solidFill>
-                  <a:srgbClr val="FFFFFF"/>
-                </a:solidFill>
-                <a:latin typeface="Public Sans" pitchFamily="34" charset="0"/>
-                <a:ea typeface="Public Sans" pitchFamily="34" charset="-122"/>
-                <a:cs typeface="Public Sans" pitchFamily="34" charset="-120"/>
-              </a:rPr>
-              <a:t>Another specialist</a:t>
-            </a:r>
-            <a:endParaRPr lang="en-US" sz="1600" dirty="0"/>
-          </a:p>
-        </p:txBody>
-      </p:sp>
-      <p:sp>
-        <p:nvSpPr>
-          <p:cNvPr id="10" name="Text 8"/>
-          <p:cNvSpPr txBox="1"/>
-          <p:nvPr/>
-        </p:nvSpPr>
-        <p:spPr>
-          <a:xfrm>
-            <a:off x="5623560" y="3273552"/>
-            <a:ext cx="5760720" cy="594360"/>
-          </a:xfrm>
-          <a:prstGeom prst="rect">
-            <a:avLst/>
-          </a:prstGeom>
-          <a:noFill/>
-          <a:ln/>
-        </p:spPr>
-        <p:txBody>
-          <a:bodyPr wrap="square" lIns="0" tIns="0" rIns="0" bIns="0" rtlCol="0" anchor="ctr"/>
-          <a:lstStyle/>
-          <a:p>
-            <a:pPr indent="0" marL="0">
-              <a:lnSpc>
-                <a:spcPts val="2100"/>
-              </a:lnSpc>
-              <a:buNone/>
-            </a:pPr>
-            <a:r>
-              <a:rPr lang="en-US" sz="1500" dirty="0">
-                <a:solidFill>
-                  <a:srgbClr val="A8ADBA"/>
-                </a:solidFill>
-                <a:latin typeface="Public Sans" pitchFamily="34" charset="0"/>
-                <a:ea typeface="Public Sans" pitchFamily="34" charset="-122"/>
-                <a:cs typeface="Public Sans" pitchFamily="34" charset="-120"/>
-              </a:rPr>
-              <a:t>The second time one job goes wrong the same way.</a:t>
-            </a:r>
-            <a:endParaRPr lang="en-US" sz="1500" dirty="0"/>
-          </a:p>
-        </p:txBody>
-      </p:sp>
-      <p:sp>
-        <p:nvSpPr>
-          <p:cNvPr id="11" name="Text 9"/>
-          <p:cNvSpPr txBox="1"/>
-          <p:nvPr/>
-        </p:nvSpPr>
-        <p:spPr>
-          <a:xfrm>
-            <a:off x="777240" y="4050792"/>
-            <a:ext cx="365760" cy="594360"/>
-          </a:xfrm>
-          <a:prstGeom prst="rect">
-            <a:avLst/>
-          </a:prstGeom>
-          <a:noFill/>
-          <a:ln/>
-        </p:spPr>
-        <p:txBody>
-          <a:bodyPr wrap="square" lIns="0" tIns="0" rIns="0" bIns="0" rtlCol="0" anchor="ctr"/>
-          <a:lstStyle/>
-          <a:p>
-            <a:pPr indent="0" marL="0">
-              <a:buNone/>
-            </a:pPr>
-            <a:r>
-              <a:rPr lang="en-US" sz="1600" b="1" dirty="0">
-                <a:solidFill>
-                  <a:srgbClr val="A59CFF"/>
-                </a:solidFill>
-                <a:latin typeface="Public Sans" pitchFamily="34" charset="0"/>
-                <a:ea typeface="Public Sans" pitchFamily="34" charset="-122"/>
-                <a:cs typeface="Public Sans" pitchFamily="34" charset="-120"/>
-              </a:rPr>
-              <a:t>—</a:t>
-            </a:r>
-            <a:endParaRPr lang="en-US" sz="1600" dirty="0"/>
-          </a:p>
-        </p:txBody>
-      </p:sp>
-      <p:sp>
-        <p:nvSpPr>
-          <p:cNvPr id="12" name="Text 10"/>
-          <p:cNvSpPr txBox="1"/>
-          <p:nvPr/>
-        </p:nvSpPr>
-        <p:spPr>
-          <a:xfrm>
-            <a:off x="1234440" y="4050792"/>
-            <a:ext cx="4206240" cy="594360"/>
-          </a:xfrm>
-          <a:prstGeom prst="rect">
-            <a:avLst/>
-          </a:prstGeom>
-          <a:noFill/>
-          <a:ln/>
-        </p:spPr>
-        <p:txBody>
-          <a:bodyPr wrap="square" lIns="0" tIns="0" rIns="0" bIns="0" rtlCol="0" anchor="ctr"/>
-          <a:lstStyle/>
-          <a:p>
-            <a:pPr indent="0" marL="0">
-              <a:buNone/>
-            </a:pPr>
-            <a:r>
-              <a:rPr lang="en-US" sz="1600" b="1" dirty="0">
-                <a:solidFill>
-                  <a:srgbClr val="FFFFFF"/>
-                </a:solidFill>
-                <a:latin typeface="Public Sans" pitchFamily="34" charset="0"/>
-                <a:ea typeface="Public Sans" pitchFamily="34" charset="-122"/>
-                <a:cs typeface="Public Sans" pitchFamily="34" charset="-120"/>
-              </a:rPr>
-              <a:t>Another skill</a:t>
-            </a:r>
-            <a:endParaRPr lang="en-US" sz="1600" dirty="0"/>
-          </a:p>
-        </p:txBody>
-      </p:sp>
-      <p:sp>
-        <p:nvSpPr>
-          <p:cNvPr id="13" name="Text 11"/>
-          <p:cNvSpPr txBox="1"/>
-          <p:nvPr/>
-        </p:nvSpPr>
-        <p:spPr>
-          <a:xfrm>
-            <a:off x="5623560" y="4050792"/>
-            <a:ext cx="5760720" cy="594360"/>
-          </a:xfrm>
-          <a:prstGeom prst="rect">
-            <a:avLst/>
-          </a:prstGeom>
-          <a:noFill/>
-          <a:ln/>
-        </p:spPr>
-        <p:txBody>
-          <a:bodyPr wrap="square" lIns="0" tIns="0" rIns="0" bIns="0" rtlCol="0" anchor="ctr"/>
-          <a:lstStyle/>
-          <a:p>
-            <a:pPr indent="0" marL="0">
-              <a:lnSpc>
-                <a:spcPts val="2100"/>
-              </a:lnSpc>
-              <a:buNone/>
-            </a:pPr>
-            <a:r>
-              <a:rPr lang="en-US" sz="1500" dirty="0">
-                <a:solidFill>
-                  <a:srgbClr val="A8ADBA"/>
-                </a:solidFill>
-                <a:latin typeface="Public Sans" pitchFamily="34" charset="0"/>
-                <a:ea typeface="Public Sans" pitchFamily="34" charset="-122"/>
-                <a:cs typeface="Public Sans" pitchFamily="34" charset="-120"/>
-              </a:rPr>
-              <a:t>The second time you explain the same thing.</a:t>
-            </a:r>
-            <a:endParaRPr lang="en-US" sz="1500" dirty="0"/>
-          </a:p>
-        </p:txBody>
-      </p:sp>
-      <p:sp>
-        <p:nvSpPr>
-          <p:cNvPr id="14" name="Text 12"/>
-          <p:cNvSpPr txBox="1"/>
-          <p:nvPr/>
-        </p:nvSpPr>
-        <p:spPr>
-          <a:xfrm>
-            <a:off x="777240" y="4828032"/>
-            <a:ext cx="365760" cy="594360"/>
-          </a:xfrm>
-          <a:prstGeom prst="rect">
-            <a:avLst/>
-          </a:prstGeom>
-          <a:noFill/>
-          <a:ln/>
-        </p:spPr>
-        <p:txBody>
-          <a:bodyPr wrap="square" lIns="0" tIns="0" rIns="0" bIns="0" rtlCol="0" anchor="ctr"/>
-          <a:lstStyle/>
-          <a:p>
-            <a:pPr indent="0" marL="0">
-              <a:buNone/>
-            </a:pPr>
-            <a:r>
-              <a:rPr lang="en-US" sz="1600" b="1" dirty="0">
-                <a:solidFill>
-                  <a:srgbClr val="A59CFF"/>
-                </a:solidFill>
-                <a:latin typeface="Public Sans" pitchFamily="34" charset="0"/>
-                <a:ea typeface="Public Sans" pitchFamily="34" charset="-122"/>
-                <a:cs typeface="Public Sans" pitchFamily="34" charset="-120"/>
-              </a:rPr>
-              <a:t>—</a:t>
-            </a:r>
-            <a:endParaRPr lang="en-US" sz="1600" dirty="0"/>
-          </a:p>
-        </p:txBody>
-      </p:sp>
-      <p:sp>
-        <p:nvSpPr>
-          <p:cNvPr id="15" name="Text 13"/>
-          <p:cNvSpPr txBox="1"/>
-          <p:nvPr/>
-        </p:nvSpPr>
-        <p:spPr>
-          <a:xfrm>
-            <a:off x="1234440" y="4828032"/>
-            <a:ext cx="4206240" cy="594360"/>
-          </a:xfrm>
-          <a:prstGeom prst="rect">
-            <a:avLst/>
-          </a:prstGeom>
-          <a:noFill/>
-          <a:ln/>
-        </p:spPr>
-        <p:txBody>
-          <a:bodyPr wrap="square" lIns="0" tIns="0" rIns="0" bIns="0" rtlCol="0" anchor="ctr"/>
-          <a:lstStyle/>
-          <a:p>
-            <a:pPr indent="0" marL="0">
-              <a:buNone/>
-            </a:pPr>
-            <a:r>
-              <a:rPr lang="en-US" sz="1600" b="1" dirty="0">
-                <a:solidFill>
-                  <a:srgbClr val="FFFFFF"/>
-                </a:solidFill>
-                <a:latin typeface="Public Sans" pitchFamily="34" charset="0"/>
-                <a:ea typeface="Public Sans" pitchFamily="34" charset="-122"/>
-                <a:cs typeface="Public Sans" pitchFamily="34" charset="-120"/>
-              </a:rPr>
-              <a:t>A schedule</a:t>
-            </a:r>
-            <a:endParaRPr lang="en-US" sz="1600" dirty="0"/>
-          </a:p>
-        </p:txBody>
-      </p:sp>
-      <p:sp>
-        <p:nvSpPr>
-          <p:cNvPr id="16" name="Text 14"/>
-          <p:cNvSpPr txBox="1"/>
-          <p:nvPr/>
-        </p:nvSpPr>
-        <p:spPr>
-          <a:xfrm>
-            <a:off x="5623560" y="4828032"/>
-            <a:ext cx="5760720" cy="594360"/>
-          </a:xfrm>
-          <a:prstGeom prst="rect">
-            <a:avLst/>
-          </a:prstGeom>
-          <a:noFill/>
-          <a:ln/>
-        </p:spPr>
-        <p:txBody>
-          <a:bodyPr wrap="square" lIns="0" tIns="0" rIns="0" bIns="0" rtlCol="0" anchor="ctr"/>
-          <a:lstStyle/>
-          <a:p>
-            <a:pPr indent="0" marL="0">
-              <a:lnSpc>
-                <a:spcPts val="2100"/>
-              </a:lnSpc>
-              <a:buNone/>
-            </a:pPr>
-            <a:r>
-              <a:rPr lang="en-US" sz="1500" dirty="0">
-                <a:solidFill>
-                  <a:srgbClr val="A8ADBA"/>
-                </a:solidFill>
-                <a:latin typeface="Public Sans" pitchFamily="34" charset="0"/>
-                <a:ea typeface="Public Sans" pitchFamily="34" charset="-122"/>
-                <a:cs typeface="Public Sans" pitchFamily="34" charset="-120"/>
-              </a:rPr>
-              <a:t>When you want the week closed on Friday without being asked.</a:t>
-            </a:r>
-            <a:endParaRPr lang="en-US" sz="1500" dirty="0"/>
-          </a:p>
-        </p:txBody>
-      </p:sp>
-      <p:sp>
-        <p:nvSpPr>
-          <p:cNvPr id="17" name="Shape 15"/>
-          <p:cNvSpPr/>
-          <p:nvPr/>
-        </p:nvSpPr>
-        <p:spPr>
-          <a:xfrm>
-            <a:off x="777240" y="5669280"/>
-            <a:ext cx="7680960" cy="658368"/>
-          </a:xfrm>
-          <a:prstGeom prst="roundRect">
-            <a:avLst>
-              <a:gd name="adj" fmla="val 8333"/>
-            </a:avLst>
-          </a:prstGeom>
-          <a:solidFill>
-            <a:srgbClr val="1B1D29"/>
-          </a:solidFill>
-          <a:ln w="17780">
-            <a:solidFill>
-              <a:srgbClr val="7367F0"/>
-            </a:solidFill>
-            <a:prstDash val="solid"/>
-          </a:ln>
-        </p:spPr>
-      </p:sp>
-      <p:sp>
-        <p:nvSpPr>
-          <p:cNvPr id="18" name="Text 16"/>
-          <p:cNvSpPr txBox="1"/>
-          <p:nvPr/>
-        </p:nvSpPr>
-        <p:spPr>
-          <a:xfrm>
-            <a:off x="1097280" y="5669280"/>
-            <a:ext cx="7132320" cy="658368"/>
-          </a:xfrm>
-          <a:prstGeom prst="rect">
-            <a:avLst/>
-          </a:prstGeom>
-          <a:noFill/>
-          <a:ln/>
-        </p:spPr>
-        <p:txBody>
-          <a:bodyPr wrap="square" lIns="0" tIns="0" rIns="0" bIns="0" rtlCol="0" anchor="ctr"/>
-          <a:lstStyle/>
-          <a:p>
-            <a:pPr indent="0" marL="0">
-              <a:buNone/>
-            </a:pPr>
-            <a:r>
-              <a:rPr lang="en-US" sz="1450" b="1" dirty="0">
-                <a:solidFill>
-                  <a:srgbClr val="FFFFFF"/>
-                </a:solidFill>
-                <a:latin typeface="Public Sans" pitchFamily="34" charset="0"/>
-                <a:ea typeface="Public Sans" pitchFamily="34" charset="-122"/>
-                <a:cs typeface="Public Sans" pitchFamily="34" charset="-120"/>
-              </a:rPr>
-              <a:t>Monday: open the project, not a new chat. </a:t>
-            </a:r>
-            <a:pPr indent="0" marL="0">
-              <a:buNone/>
-            </a:pPr>
-            <a:r>
-              <a:rPr lang="en-US" sz="1450" dirty="0">
-                <a:solidFill>
-                  <a:srgbClr val="A8ADBA"/>
-                </a:solidFill>
-                <a:latin typeface="Public Sans" pitchFamily="34" charset="0"/>
-                <a:ea typeface="Public Sans" pitchFamily="34" charset="-122"/>
-                <a:cs typeface="Public Sans" pitchFamily="34" charset="-120"/>
-              </a:rPr>
-              <a:t>That is the whole habit.</a:t>
-            </a:r>
-            <a:endParaRPr lang="en-US" sz="1450" dirty="0"/>
-          </a:p>
-        </p:txBody>
-      </p:sp>
-      <p:pic>
-        <p:nvPicPr>
-          <p:cNvPr id="19" name="Image 0" descr="/tmp/claude-0/-home-claude/e62a35b1-5075-553d-b086-acebfebc41ba/scratchpad/brand/meshpro-lockup-navy.png">    </p:cNvPr>
-          <p:cNvPicPr>
-            <a:picLocks noChangeAspect="1"/>
-          </p:cNvPicPr>
-          <p:nvPr/>
-        </p:nvPicPr>
-        <p:blipFill>
-          <a:blip r:embed="rId1"/>
-          <a:stretch>
-            <a:fillRect/>
-          </a:stretch>
-        </p:blipFill>
-        <p:spPr>
-          <a:xfrm>
-            <a:off x="9128455" y="5760720"/>
-            <a:ext cx="2286000" cy="576072"/>
-          </a:xfrm>
-          <a:prstGeom prst="rect">
-            <a:avLst/>
-          </a:prstGeom>
-        </p:spPr>
-      </p:pic>
     </p:spTree>
   </p:cSld>
   <p:clrMapOvr>
@@ -8853,6 +10411,745 @@
           </a:p>
         </p:txBody>
       </p:sp>
+    </p:spTree>
+  </p:cSld>
+  <p:clrMapOvr>
+    <a:masterClrMapping/>
+  </p:clrMapOvr>
+</p:sld>
+</file>
+
+<file path=ppt/slides/slide20.xml><?xml version="1.0" encoding="utf-8"?>
+<p:sld xmlns:a="http://schemas.openxmlformats.org/drawingml/2006/main" xmlns:r="http://schemas.openxmlformats.org/officeDocument/2006/relationships" xmlns:p="http://schemas.openxmlformats.org/presentationml/2006/main">
+  <p:cSld name="Slide 20">
+    <p:bg>
+      <p:bgPr>
+        <a:solidFill>
+          <a:srgbClr val="15171F"/>
+        </a:solidFill>
+      </p:bgPr>
+    </p:bg>
+    <p:spTree>
+      <p:nvGrpSpPr>
+        <p:cNvPr id="1" name=""/>
+        <p:cNvGrpSpPr/>
+        <p:nvPr/>
+      </p:nvGrpSpPr>
+      <p:grpSpPr>
+        <a:xfrm>
+          <a:off x="0" y="0"/>
+          <a:ext cx="0" cy="0"/>
+          <a:chOff x="0" y="0"/>
+          <a:chExt cx="0" cy="0"/>
+        </a:xfrm>
+      </p:grpSpPr>
+      <p:sp>
+        <p:nvSpPr>
+          <p:cNvPr id="2" name="Text 0"/>
+          <p:cNvSpPr txBox="1"/>
+          <p:nvPr/>
+        </p:nvSpPr>
+        <p:spPr>
+          <a:xfrm>
+            <a:off x="777240" y="420624"/>
+            <a:ext cx="8229600" cy="274320"/>
+          </a:xfrm>
+          <a:prstGeom prst="rect">
+            <a:avLst/>
+          </a:prstGeom>
+          <a:noFill/>
+          <a:ln/>
+        </p:spPr>
+        <p:txBody>
+          <a:bodyPr wrap="square" lIns="0" tIns="0" rIns="0" bIns="0" rtlCol="0" anchor="ctr"/>
+          <a:lstStyle/>
+          <a:p>
+            <a:pPr indent="0" marL="0">
+              <a:buNone/>
+            </a:pPr>
+            <a:r>
+              <a:rPr lang="en-US" sz="1100" spc="200" kern="0" dirty="0">
+                <a:solidFill>
+                  <a:srgbClr val="A59CFF"/>
+                </a:solidFill>
+                <a:latin typeface="Courier New" pitchFamily="34" charset="0"/>
+                <a:ea typeface="Courier New" pitchFamily="34" charset="-122"/>
+                <a:cs typeface="Courier New" pitchFamily="34" charset="-120"/>
+              </a:rPr>
+              <a:t>FROM HERE</a:t>
+            </a:r>
+            <a:endParaRPr lang="en-US" sz="1100" dirty="0"/>
+          </a:p>
+        </p:txBody>
+      </p:sp>
+      <p:sp>
+        <p:nvSpPr>
+          <p:cNvPr id="3" name="Text 1"/>
+          <p:cNvSpPr txBox="1"/>
+          <p:nvPr/>
+        </p:nvSpPr>
+        <p:spPr>
+          <a:xfrm>
+            <a:off x="777240" y="868680"/>
+            <a:ext cx="9951415" cy="914400"/>
+          </a:xfrm>
+          <a:prstGeom prst="rect">
+            <a:avLst/>
+          </a:prstGeom>
+          <a:noFill/>
+          <a:ln/>
+        </p:spPr>
+        <p:txBody>
+          <a:bodyPr wrap="square" lIns="0" tIns="0" rIns="0" bIns="0" rtlCol="0" anchor="ctr"/>
+          <a:lstStyle/>
+          <a:p>
+            <a:pPr indent="0" marL="0">
+              <a:lnSpc>
+                <a:spcPts val="3944"/>
+              </a:lnSpc>
+              <a:buNone/>
+            </a:pPr>
+            <a:r>
+              <a:rPr lang="en-US" sz="3400" b="1" dirty="0">
+                <a:solidFill>
+                  <a:srgbClr val="FFFFFF"/>
+                </a:solidFill>
+                <a:latin typeface="Public Sans" pitchFamily="34" charset="0"/>
+                <a:ea typeface="Public Sans" pitchFamily="34" charset="-122"/>
+                <a:cs typeface="Public Sans" pitchFamily="34" charset="-120"/>
+              </a:rPr>
+              <a:t>The next one is just more of the same</a:t>
+            </a:r>
+            <a:endParaRPr lang="en-US" sz="3400" dirty="0"/>
+          </a:p>
+        </p:txBody>
+      </p:sp>
+      <p:sp>
+        <p:nvSpPr>
+          <p:cNvPr id="4" name="Text 2"/>
+          <p:cNvSpPr txBox="1"/>
+          <p:nvPr/>
+        </p:nvSpPr>
+        <p:spPr>
+          <a:xfrm>
+            <a:off x="777240" y="1783080"/>
+            <a:ext cx="10637215" cy="566928"/>
+          </a:xfrm>
+          <a:prstGeom prst="rect">
+            <a:avLst/>
+          </a:prstGeom>
+          <a:noFill/>
+          <a:ln/>
+        </p:spPr>
+        <p:txBody>
+          <a:bodyPr wrap="square" lIns="0" tIns="0" rIns="0" bIns="0" rtlCol="0" anchor="ctr"/>
+          <a:lstStyle/>
+          <a:p>
+            <a:pPr indent="0" marL="0">
+              <a:lnSpc>
+                <a:spcPts val="2300"/>
+              </a:lnSpc>
+              <a:buNone/>
+            </a:pPr>
+            <a:r>
+              <a:rPr lang="en-US" sz="1600" dirty="0">
+                <a:solidFill>
+                  <a:srgbClr val="A8ADBA"/>
+                </a:solidFill>
+                <a:latin typeface="Public Sans" pitchFamily="34" charset="0"/>
+                <a:ea typeface="Public Sans" pitchFamily="34" charset="-122"/>
+                <a:cs typeface="Public Sans" pitchFamily="34" charset="-120"/>
+              </a:rPr>
+              <a:t>You have made one of everything. Nothing after today is a new kind of thing.</a:t>
+            </a:r>
+            <a:endParaRPr lang="en-US" sz="1600" dirty="0"/>
+          </a:p>
+        </p:txBody>
+      </p:sp>
+      <p:sp>
+        <p:nvSpPr>
+          <p:cNvPr id="5" name="Text 3"/>
+          <p:cNvSpPr txBox="1"/>
+          <p:nvPr/>
+        </p:nvSpPr>
+        <p:spPr>
+          <a:xfrm>
+            <a:off x="777240" y="2496312"/>
+            <a:ext cx="365760" cy="594360"/>
+          </a:xfrm>
+          <a:prstGeom prst="rect">
+            <a:avLst/>
+          </a:prstGeom>
+          <a:noFill/>
+          <a:ln/>
+        </p:spPr>
+        <p:txBody>
+          <a:bodyPr wrap="square" lIns="0" tIns="0" rIns="0" bIns="0" rtlCol="0" anchor="ctr"/>
+          <a:lstStyle/>
+          <a:p>
+            <a:pPr indent="0" marL="0">
+              <a:buNone/>
+            </a:pPr>
+            <a:r>
+              <a:rPr lang="en-US" sz="1600" b="1" dirty="0">
+                <a:solidFill>
+                  <a:srgbClr val="A59CFF"/>
+                </a:solidFill>
+                <a:latin typeface="Public Sans" pitchFamily="34" charset="0"/>
+                <a:ea typeface="Public Sans" pitchFamily="34" charset="-122"/>
+                <a:cs typeface="Public Sans" pitchFamily="34" charset="-120"/>
+              </a:rPr>
+              <a:t>—</a:t>
+            </a:r>
+            <a:endParaRPr lang="en-US" sz="1600" dirty="0"/>
+          </a:p>
+        </p:txBody>
+      </p:sp>
+      <p:sp>
+        <p:nvSpPr>
+          <p:cNvPr id="6" name="Text 4"/>
+          <p:cNvSpPr txBox="1"/>
+          <p:nvPr/>
+        </p:nvSpPr>
+        <p:spPr>
+          <a:xfrm>
+            <a:off x="1234440" y="2496312"/>
+            <a:ext cx="4206240" cy="594360"/>
+          </a:xfrm>
+          <a:prstGeom prst="rect">
+            <a:avLst/>
+          </a:prstGeom>
+          <a:noFill/>
+          <a:ln/>
+        </p:spPr>
+        <p:txBody>
+          <a:bodyPr wrap="square" lIns="0" tIns="0" rIns="0" bIns="0" rtlCol="0" anchor="ctr"/>
+          <a:lstStyle/>
+          <a:p>
+            <a:pPr indent="0" marL="0">
+              <a:buNone/>
+            </a:pPr>
+            <a:r>
+              <a:rPr lang="en-US" sz="1600" b="1" dirty="0">
+                <a:solidFill>
+                  <a:srgbClr val="FFFFFF"/>
+                </a:solidFill>
+                <a:latin typeface="Public Sans" pitchFamily="34" charset="0"/>
+                <a:ea typeface="Public Sans" pitchFamily="34" charset="-122"/>
+                <a:cs typeface="Public Sans" pitchFamily="34" charset="-120"/>
+              </a:rPr>
+              <a:t>Another department</a:t>
+            </a:r>
+            <a:endParaRPr lang="en-US" sz="1600" dirty="0"/>
+          </a:p>
+        </p:txBody>
+      </p:sp>
+      <p:sp>
+        <p:nvSpPr>
+          <p:cNvPr id="7" name="Text 5"/>
+          <p:cNvSpPr txBox="1"/>
+          <p:nvPr/>
+        </p:nvSpPr>
+        <p:spPr>
+          <a:xfrm>
+            <a:off x="5623560" y="2496312"/>
+            <a:ext cx="5760720" cy="594360"/>
+          </a:xfrm>
+          <a:prstGeom prst="rect">
+            <a:avLst/>
+          </a:prstGeom>
+          <a:noFill/>
+          <a:ln/>
+        </p:spPr>
+        <p:txBody>
+          <a:bodyPr wrap="square" lIns="0" tIns="0" rIns="0" bIns="0" rtlCol="0" anchor="ctr"/>
+          <a:lstStyle/>
+          <a:p>
+            <a:pPr indent="0" marL="0">
+              <a:lnSpc>
+                <a:spcPts val="2100"/>
+              </a:lnSpc>
+              <a:buNone/>
+            </a:pPr>
+            <a:r>
+              <a:rPr lang="en-US" sz="1500" dirty="0">
+                <a:solidFill>
+                  <a:srgbClr val="A8ADBA"/>
+                </a:solidFill>
+                <a:latin typeface="Public Sans" pitchFamily="34" charset="0"/>
+                <a:ea typeface="Public Sans" pitchFamily="34" charset="-122"/>
+                <a:cs typeface="Public Sans" pitchFamily="34" charset="-120"/>
+              </a:rPr>
+              <a:t>The moment you notice a part of your job nobody answers for.</a:t>
+            </a:r>
+            <a:endParaRPr lang="en-US" sz="1500" dirty="0"/>
+          </a:p>
+        </p:txBody>
+      </p:sp>
+      <p:sp>
+        <p:nvSpPr>
+          <p:cNvPr id="8" name="Text 6"/>
+          <p:cNvSpPr txBox="1"/>
+          <p:nvPr/>
+        </p:nvSpPr>
+        <p:spPr>
+          <a:xfrm>
+            <a:off x="777240" y="3273552"/>
+            <a:ext cx="365760" cy="594360"/>
+          </a:xfrm>
+          <a:prstGeom prst="rect">
+            <a:avLst/>
+          </a:prstGeom>
+          <a:noFill/>
+          <a:ln/>
+        </p:spPr>
+        <p:txBody>
+          <a:bodyPr wrap="square" lIns="0" tIns="0" rIns="0" bIns="0" rtlCol="0" anchor="ctr"/>
+          <a:lstStyle/>
+          <a:p>
+            <a:pPr indent="0" marL="0">
+              <a:buNone/>
+            </a:pPr>
+            <a:r>
+              <a:rPr lang="en-US" sz="1600" b="1" dirty="0">
+                <a:solidFill>
+                  <a:srgbClr val="A59CFF"/>
+                </a:solidFill>
+                <a:latin typeface="Public Sans" pitchFamily="34" charset="0"/>
+                <a:ea typeface="Public Sans" pitchFamily="34" charset="-122"/>
+                <a:cs typeface="Public Sans" pitchFamily="34" charset="-120"/>
+              </a:rPr>
+              <a:t>—</a:t>
+            </a:r>
+            <a:endParaRPr lang="en-US" sz="1600" dirty="0"/>
+          </a:p>
+        </p:txBody>
+      </p:sp>
+      <p:sp>
+        <p:nvSpPr>
+          <p:cNvPr id="9" name="Text 7"/>
+          <p:cNvSpPr txBox="1"/>
+          <p:nvPr/>
+        </p:nvSpPr>
+        <p:spPr>
+          <a:xfrm>
+            <a:off x="1234440" y="3273552"/>
+            <a:ext cx="4206240" cy="594360"/>
+          </a:xfrm>
+          <a:prstGeom prst="rect">
+            <a:avLst/>
+          </a:prstGeom>
+          <a:noFill/>
+          <a:ln/>
+        </p:spPr>
+        <p:txBody>
+          <a:bodyPr wrap="square" lIns="0" tIns="0" rIns="0" bIns="0" rtlCol="0" anchor="ctr"/>
+          <a:lstStyle/>
+          <a:p>
+            <a:pPr indent="0" marL="0">
+              <a:buNone/>
+            </a:pPr>
+            <a:r>
+              <a:rPr lang="en-US" sz="1600" b="1" dirty="0">
+                <a:solidFill>
+                  <a:srgbClr val="FFFFFF"/>
+                </a:solidFill>
+                <a:latin typeface="Public Sans" pitchFamily="34" charset="0"/>
+                <a:ea typeface="Public Sans" pitchFamily="34" charset="-122"/>
+                <a:cs typeface="Public Sans" pitchFamily="34" charset="-120"/>
+              </a:rPr>
+              <a:t>Another specialist</a:t>
+            </a:r>
+            <a:endParaRPr lang="en-US" sz="1600" dirty="0"/>
+          </a:p>
+        </p:txBody>
+      </p:sp>
+      <p:sp>
+        <p:nvSpPr>
+          <p:cNvPr id="10" name="Text 8"/>
+          <p:cNvSpPr txBox="1"/>
+          <p:nvPr/>
+        </p:nvSpPr>
+        <p:spPr>
+          <a:xfrm>
+            <a:off x="5623560" y="3273552"/>
+            <a:ext cx="5760720" cy="594360"/>
+          </a:xfrm>
+          <a:prstGeom prst="rect">
+            <a:avLst/>
+          </a:prstGeom>
+          <a:noFill/>
+          <a:ln/>
+        </p:spPr>
+        <p:txBody>
+          <a:bodyPr wrap="square" lIns="0" tIns="0" rIns="0" bIns="0" rtlCol="0" anchor="ctr"/>
+          <a:lstStyle/>
+          <a:p>
+            <a:pPr indent="0" marL="0">
+              <a:lnSpc>
+                <a:spcPts val="2100"/>
+              </a:lnSpc>
+              <a:buNone/>
+            </a:pPr>
+            <a:r>
+              <a:rPr lang="en-US" sz="1500" dirty="0">
+                <a:solidFill>
+                  <a:srgbClr val="A8ADBA"/>
+                </a:solidFill>
+                <a:latin typeface="Public Sans" pitchFamily="34" charset="0"/>
+                <a:ea typeface="Public Sans" pitchFamily="34" charset="-122"/>
+                <a:cs typeface="Public Sans" pitchFamily="34" charset="-120"/>
+              </a:rPr>
+              <a:t>The second time one job goes wrong the same way.</a:t>
+            </a:r>
+            <a:endParaRPr lang="en-US" sz="1500" dirty="0"/>
+          </a:p>
+        </p:txBody>
+      </p:sp>
+      <p:sp>
+        <p:nvSpPr>
+          <p:cNvPr id="11" name="Text 9"/>
+          <p:cNvSpPr txBox="1"/>
+          <p:nvPr/>
+        </p:nvSpPr>
+        <p:spPr>
+          <a:xfrm>
+            <a:off x="777240" y="4050792"/>
+            <a:ext cx="365760" cy="594360"/>
+          </a:xfrm>
+          <a:prstGeom prst="rect">
+            <a:avLst/>
+          </a:prstGeom>
+          <a:noFill/>
+          <a:ln/>
+        </p:spPr>
+        <p:txBody>
+          <a:bodyPr wrap="square" lIns="0" tIns="0" rIns="0" bIns="0" rtlCol="0" anchor="ctr"/>
+          <a:lstStyle/>
+          <a:p>
+            <a:pPr indent="0" marL="0">
+              <a:buNone/>
+            </a:pPr>
+            <a:r>
+              <a:rPr lang="en-US" sz="1600" b="1" dirty="0">
+                <a:solidFill>
+                  <a:srgbClr val="A59CFF"/>
+                </a:solidFill>
+                <a:latin typeface="Public Sans" pitchFamily="34" charset="0"/>
+                <a:ea typeface="Public Sans" pitchFamily="34" charset="-122"/>
+                <a:cs typeface="Public Sans" pitchFamily="34" charset="-120"/>
+              </a:rPr>
+              <a:t>—</a:t>
+            </a:r>
+            <a:endParaRPr lang="en-US" sz="1600" dirty="0"/>
+          </a:p>
+        </p:txBody>
+      </p:sp>
+      <p:sp>
+        <p:nvSpPr>
+          <p:cNvPr id="12" name="Text 10"/>
+          <p:cNvSpPr txBox="1"/>
+          <p:nvPr/>
+        </p:nvSpPr>
+        <p:spPr>
+          <a:xfrm>
+            <a:off x="1234440" y="4050792"/>
+            <a:ext cx="4206240" cy="594360"/>
+          </a:xfrm>
+          <a:prstGeom prst="rect">
+            <a:avLst/>
+          </a:prstGeom>
+          <a:noFill/>
+          <a:ln/>
+        </p:spPr>
+        <p:txBody>
+          <a:bodyPr wrap="square" lIns="0" tIns="0" rIns="0" bIns="0" rtlCol="0" anchor="ctr"/>
+          <a:lstStyle/>
+          <a:p>
+            <a:pPr indent="0" marL="0">
+              <a:buNone/>
+            </a:pPr>
+            <a:r>
+              <a:rPr lang="en-US" sz="1600" b="1" dirty="0">
+                <a:solidFill>
+                  <a:srgbClr val="FFFFFF"/>
+                </a:solidFill>
+                <a:latin typeface="Public Sans" pitchFamily="34" charset="0"/>
+                <a:ea typeface="Public Sans" pitchFamily="34" charset="-122"/>
+                <a:cs typeface="Public Sans" pitchFamily="34" charset="-120"/>
+              </a:rPr>
+              <a:t>Another skill</a:t>
+            </a:r>
+            <a:endParaRPr lang="en-US" sz="1600" dirty="0"/>
+          </a:p>
+        </p:txBody>
+      </p:sp>
+      <p:sp>
+        <p:nvSpPr>
+          <p:cNvPr id="13" name="Text 11"/>
+          <p:cNvSpPr txBox="1"/>
+          <p:nvPr/>
+        </p:nvSpPr>
+        <p:spPr>
+          <a:xfrm>
+            <a:off x="5623560" y="4050792"/>
+            <a:ext cx="5760720" cy="594360"/>
+          </a:xfrm>
+          <a:prstGeom prst="rect">
+            <a:avLst/>
+          </a:prstGeom>
+          <a:noFill/>
+          <a:ln/>
+        </p:spPr>
+        <p:txBody>
+          <a:bodyPr wrap="square" lIns="0" tIns="0" rIns="0" bIns="0" rtlCol="0" anchor="ctr"/>
+          <a:lstStyle/>
+          <a:p>
+            <a:pPr indent="0" marL="0">
+              <a:lnSpc>
+                <a:spcPts val="2100"/>
+              </a:lnSpc>
+              <a:buNone/>
+            </a:pPr>
+            <a:r>
+              <a:rPr lang="en-US" sz="1500" dirty="0">
+                <a:solidFill>
+                  <a:srgbClr val="A8ADBA"/>
+                </a:solidFill>
+                <a:latin typeface="Public Sans" pitchFamily="34" charset="0"/>
+                <a:ea typeface="Public Sans" pitchFamily="34" charset="-122"/>
+                <a:cs typeface="Public Sans" pitchFamily="34" charset="-120"/>
+              </a:rPr>
+              <a:t>The second time you explain the same thing.</a:t>
+            </a:r>
+            <a:endParaRPr lang="en-US" sz="1500" dirty="0"/>
+          </a:p>
+        </p:txBody>
+      </p:sp>
+      <p:sp>
+        <p:nvSpPr>
+          <p:cNvPr id="14" name="Text 12"/>
+          <p:cNvSpPr txBox="1"/>
+          <p:nvPr/>
+        </p:nvSpPr>
+        <p:spPr>
+          <a:xfrm>
+            <a:off x="777240" y="4828032"/>
+            <a:ext cx="365760" cy="594360"/>
+          </a:xfrm>
+          <a:prstGeom prst="rect">
+            <a:avLst/>
+          </a:prstGeom>
+          <a:noFill/>
+          <a:ln/>
+        </p:spPr>
+        <p:txBody>
+          <a:bodyPr wrap="square" lIns="0" tIns="0" rIns="0" bIns="0" rtlCol="0" anchor="ctr"/>
+          <a:lstStyle/>
+          <a:p>
+            <a:pPr indent="0" marL="0">
+              <a:buNone/>
+            </a:pPr>
+            <a:r>
+              <a:rPr lang="en-US" sz="1600" b="1" dirty="0">
+                <a:solidFill>
+                  <a:srgbClr val="A59CFF"/>
+                </a:solidFill>
+                <a:latin typeface="Public Sans" pitchFamily="34" charset="0"/>
+                <a:ea typeface="Public Sans" pitchFamily="34" charset="-122"/>
+                <a:cs typeface="Public Sans" pitchFamily="34" charset="-120"/>
+              </a:rPr>
+              <a:t>—</a:t>
+            </a:r>
+            <a:endParaRPr lang="en-US" sz="1600" dirty="0"/>
+          </a:p>
+        </p:txBody>
+      </p:sp>
+      <p:sp>
+        <p:nvSpPr>
+          <p:cNvPr id="15" name="Text 13"/>
+          <p:cNvSpPr txBox="1"/>
+          <p:nvPr/>
+        </p:nvSpPr>
+        <p:spPr>
+          <a:xfrm>
+            <a:off x="1234440" y="4828032"/>
+            <a:ext cx="4206240" cy="594360"/>
+          </a:xfrm>
+          <a:prstGeom prst="rect">
+            <a:avLst/>
+          </a:prstGeom>
+          <a:noFill/>
+          <a:ln/>
+        </p:spPr>
+        <p:txBody>
+          <a:bodyPr wrap="square" lIns="0" tIns="0" rIns="0" bIns="0" rtlCol="0" anchor="ctr"/>
+          <a:lstStyle/>
+          <a:p>
+            <a:pPr indent="0" marL="0">
+              <a:buNone/>
+            </a:pPr>
+            <a:r>
+              <a:rPr lang="en-US" sz="1600" b="1" dirty="0">
+                <a:solidFill>
+                  <a:srgbClr val="FFFFFF"/>
+                </a:solidFill>
+                <a:latin typeface="Public Sans" pitchFamily="34" charset="0"/>
+                <a:ea typeface="Public Sans" pitchFamily="34" charset="-122"/>
+                <a:cs typeface="Public Sans" pitchFamily="34" charset="-120"/>
+              </a:rPr>
+              <a:t>A schedule</a:t>
+            </a:r>
+            <a:endParaRPr lang="en-US" sz="1600" dirty="0"/>
+          </a:p>
+        </p:txBody>
+      </p:sp>
+      <p:sp>
+        <p:nvSpPr>
+          <p:cNvPr id="16" name="Text 14"/>
+          <p:cNvSpPr txBox="1"/>
+          <p:nvPr/>
+        </p:nvSpPr>
+        <p:spPr>
+          <a:xfrm>
+            <a:off x="5623560" y="4828032"/>
+            <a:ext cx="5760720" cy="594360"/>
+          </a:xfrm>
+          <a:prstGeom prst="rect">
+            <a:avLst/>
+          </a:prstGeom>
+          <a:noFill/>
+          <a:ln/>
+        </p:spPr>
+        <p:txBody>
+          <a:bodyPr wrap="square" lIns="0" tIns="0" rIns="0" bIns="0" rtlCol="0" anchor="ctr"/>
+          <a:lstStyle/>
+          <a:p>
+            <a:pPr indent="0" marL="0">
+              <a:lnSpc>
+                <a:spcPts val="2100"/>
+              </a:lnSpc>
+              <a:buNone/>
+            </a:pPr>
+            <a:r>
+              <a:rPr lang="en-US" sz="1500" dirty="0">
+                <a:solidFill>
+                  <a:srgbClr val="A8ADBA"/>
+                </a:solidFill>
+                <a:latin typeface="Public Sans" pitchFamily="34" charset="0"/>
+                <a:ea typeface="Public Sans" pitchFamily="34" charset="-122"/>
+                <a:cs typeface="Public Sans" pitchFamily="34" charset="-120"/>
+              </a:rPr>
+              <a:t>When you want the week closed on Friday without being asked.</a:t>
+            </a:r>
+            <a:endParaRPr lang="en-US" sz="1500" dirty="0"/>
+          </a:p>
+        </p:txBody>
+      </p:sp>
+      <p:sp>
+        <p:nvSpPr>
+          <p:cNvPr id="17" name="Shape 15"/>
+          <p:cNvSpPr/>
+          <p:nvPr/>
+        </p:nvSpPr>
+        <p:spPr>
+          <a:xfrm>
+            <a:off x="777240" y="5669280"/>
+            <a:ext cx="7680960" cy="658368"/>
+          </a:xfrm>
+          <a:prstGeom prst="roundRect">
+            <a:avLst>
+              <a:gd name="adj" fmla="val 8333"/>
+            </a:avLst>
+          </a:prstGeom>
+          <a:solidFill>
+            <a:srgbClr val="1B1D29"/>
+          </a:solidFill>
+          <a:ln w="17780">
+            <a:solidFill>
+              <a:srgbClr val="7367F0"/>
+            </a:solidFill>
+            <a:prstDash val="solid"/>
+          </a:ln>
+        </p:spPr>
+      </p:sp>
+      <p:sp>
+        <p:nvSpPr>
+          <p:cNvPr id="18" name="Text 16"/>
+          <p:cNvSpPr txBox="1"/>
+          <p:nvPr/>
+        </p:nvSpPr>
+        <p:spPr>
+          <a:xfrm>
+            <a:off x="1097280" y="5669280"/>
+            <a:ext cx="7132320" cy="658368"/>
+          </a:xfrm>
+          <a:prstGeom prst="rect">
+            <a:avLst/>
+          </a:prstGeom>
+          <a:noFill/>
+          <a:ln/>
+        </p:spPr>
+        <p:txBody>
+          <a:bodyPr wrap="square" lIns="0" tIns="0" rIns="0" bIns="0" rtlCol="0" anchor="ctr"/>
+          <a:lstStyle/>
+          <a:p>
+            <a:pPr indent="0" marL="0">
+              <a:buNone/>
+            </a:pPr>
+            <a:r>
+              <a:rPr lang="en-US" sz="1450" b="1" dirty="0">
+                <a:solidFill>
+                  <a:srgbClr val="FFFFFF"/>
+                </a:solidFill>
+                <a:latin typeface="Public Sans" pitchFamily="34" charset="0"/>
+                <a:ea typeface="Public Sans" pitchFamily="34" charset="-122"/>
+                <a:cs typeface="Public Sans" pitchFamily="34" charset="-120"/>
+              </a:rPr>
+              <a:t>Monday: open the project, not a new chat. </a:t>
+            </a:r>
+            <a:pPr indent="0" marL="0">
+              <a:buNone/>
+            </a:pPr>
+            <a:r>
+              <a:rPr lang="en-US" sz="1450" dirty="0">
+                <a:solidFill>
+                  <a:srgbClr val="A8ADBA"/>
+                </a:solidFill>
+                <a:latin typeface="Public Sans" pitchFamily="34" charset="0"/>
+                <a:ea typeface="Public Sans" pitchFamily="34" charset="-122"/>
+                <a:cs typeface="Public Sans" pitchFamily="34" charset="-120"/>
+              </a:rPr>
+              <a:t>That is the whole habit.</a:t>
+            </a:r>
+            <a:endParaRPr lang="en-US" sz="1450" dirty="0"/>
+          </a:p>
+        </p:txBody>
+      </p:sp>
+      <p:pic>
+        <p:nvPicPr>
+          <p:cNvPr id="19" name="Image 0" descr="/tmp/claude-0/-home-claude/e62a35b1-5075-553d-b086-acebfebc41ba/scratchpad/brand/meshpro-lockup-navy.png">    </p:cNvPr>
+          <p:cNvPicPr>
+            <a:picLocks noChangeAspect="1"/>
+          </p:cNvPicPr>
+          <p:nvPr/>
+        </p:nvPicPr>
+        <p:blipFill>
+          <a:blip r:embed="rId1"/>
+          <a:stretch>
+            <a:fillRect/>
+          </a:stretch>
+        </p:blipFill>
+        <p:spPr>
+          <a:xfrm>
+            <a:off x="9128455" y="5760720"/>
+            <a:ext cx="2286000" cy="576072"/>
+          </a:xfrm>
+          <a:prstGeom prst="rect">
+            <a:avLst/>
+          </a:prstGeom>
+        </p:spPr>
+      </p:pic>
     </p:spTree>
   </p:cSld>
   <p:clrMapOvr>

</xml_diff>